<commit_message>
Deck: paper titles and recent work in the survey, research finding, RoBERTa objective
Co-Authored-By: Claude Opus 5.5 <noreply@anthropic.com>
</commit_message>
<xml_diff>
--- a/reports/ppt/InsightDesk_final.pptx
+++ b/reports/ppt/InsightDesk_final.pptx
@@ -10292,12 +10292,12 @@
                 <a:spcPts val="0"/>
               </a:spcBef>
               <a:spcAft>
-                <a:spcPts val="500"/>
+                <a:spcPts val="400"/>
               </a:spcAft>
               <a:buNone/>
             </a:pPr>
             <a:r>
-              <a:rPr lang="en-US" sz="1100">
+              <a:rPr lang="en-US" sz="1050">
                 <a:solidFill>
                   <a:schemeClr val="dk1"/>
                 </a:solidFill>
@@ -10315,12 +10315,12 @@
                 <a:spcPts val="0"/>
               </a:spcBef>
               <a:spcAft>
-                <a:spcPts val="500"/>
+                <a:spcPts val="400"/>
               </a:spcAft>
               <a:buNone/>
             </a:pPr>
             <a:r>
-              <a:rPr lang="en-US" sz="1100">
+              <a:rPr lang="en-US" sz="1050">
                 <a:solidFill>
                   <a:schemeClr val="dk1"/>
                 </a:solidFill>
@@ -10338,12 +10338,12 @@
                 <a:spcPts val="0"/>
               </a:spcBef>
               <a:spcAft>
-                <a:spcPts val="500"/>
+                <a:spcPts val="400"/>
               </a:spcAft>
               <a:buNone/>
             </a:pPr>
             <a:r>
-              <a:rPr lang="en-US" sz="1100">
+              <a:rPr lang="en-US" sz="1050">
                 <a:solidFill>
                   <a:schemeClr val="dk1"/>
                 </a:solidFill>
@@ -10361,12 +10361,12 @@
                 <a:spcPts val="0"/>
               </a:spcBef>
               <a:spcAft>
-                <a:spcPts val="500"/>
+                <a:spcPts val="400"/>
               </a:spcAft>
               <a:buNone/>
             </a:pPr>
             <a:r>
-              <a:rPr lang="en-US" sz="1100">
+              <a:rPr lang="en-US" sz="1050">
                 <a:solidFill>
                   <a:schemeClr val="dk1"/>
                 </a:solidFill>
@@ -10375,7 +10375,7 @@
                 <a:cs typeface="Times New Roman"/>
                 <a:sym typeface="Times New Roman"/>
               </a:rPr>
-              <a:t xml:space="preserve">[4] J. Devlin, M.-W. Chang, K. Lee, K. Toutanova, “BERT: Pre-training of deep bidirectional transformers,” NAACL, 2019.</a:t>
+              <a:t xml:space="preserve">[4] M. Grootendorst, “BERTopic: Neural topic modeling with a class-based TF-IDF procedure,” arXiv:2203.05794, 2022.</a:t>
             </a:r>
           </a:p>
           <a:p>
@@ -10384,12 +10384,12 @@
                 <a:spcPts val="0"/>
               </a:spcBef>
               <a:spcAft>
-                <a:spcPts val="500"/>
+                <a:spcPts val="400"/>
               </a:spcAft>
               <a:buNone/>
             </a:pPr>
             <a:r>
-              <a:rPr lang="en-US" sz="1100">
+              <a:rPr lang="en-US" sz="1050">
                 <a:solidFill>
                   <a:schemeClr val="dk1"/>
                 </a:solidFill>
@@ -10398,7 +10398,7 @@
                 <a:cs typeface="Times New Roman"/>
                 <a:sym typeface="Times New Roman"/>
               </a:rPr>
-              <a:t xml:space="preserve">[5] G. S. Manku, A. Jain, A. Das Sarma, “Detecting near-duplicates for web crawling,” WWW, 2007.</a:t>
+              <a:t xml:space="preserve">[5] T. Zhang, I. C. Irsan, F. Thung, D. Lo, “Cupid: Leveraging ChatGPT for more accurate duplicate bug report detection,” arXiv:2308.10022, 2023.</a:t>
             </a:r>
           </a:p>
           <a:p>
@@ -10407,12 +10407,12 @@
                 <a:spcPts val="0"/>
               </a:spcBef>
               <a:spcAft>
-                <a:spcPts val="500"/>
+                <a:spcPts val="400"/>
               </a:spcAft>
               <a:buNone/>
             </a:pPr>
             <a:r>
-              <a:rPr lang="en-US" sz="1100">
+              <a:rPr lang="en-US" sz="1050">
                 <a:solidFill>
                   <a:schemeClr val="dk1"/>
                 </a:solidFill>
@@ -10421,7 +10421,7 @@
                 <a:cs typeface="Times New Roman"/>
                 <a:sym typeface="Times New Roman"/>
               </a:rPr>
-              <a:t xml:space="preserve">[6] A. Z. Broder, “On the resemblance and containment of documents,” Compression and Complexity of Sequences, 1997.</a:t>
+              <a:t xml:space="preserve">[6] R. Peeters, A. Steiner, C. Bizer, “Entity matching using large language models,” EDBT, 2025.</a:t>
             </a:r>
           </a:p>
           <a:p>
@@ -10430,12 +10430,12 @@
                 <a:spcPts val="0"/>
               </a:spcBef>
               <a:spcAft>
-                <a:spcPts val="500"/>
+                <a:spcPts val="400"/>
               </a:spcAft>
               <a:buNone/>
             </a:pPr>
             <a:r>
-              <a:rPr lang="en-US" sz="1100">
+              <a:rPr lang="en-US" sz="1050">
                 <a:solidFill>
                   <a:schemeClr val="dk1"/>
                 </a:solidFill>
@@ -10444,7 +10444,30 @@
                 <a:cs typeface="Times New Roman"/>
                 <a:sym typeface="Times New Roman"/>
               </a:rPr>
-              <a:t xml:space="preserve">[7] M. Grootendorst, “BERTopic: Neural topic modeling with a class-based TF-IDF procedure,” arXiv:2203.05794, 2022.</a:t>
+              <a:t xml:space="preserve">[7] “GPTrace: Effective crash deduplication using LLM embeddings,” ICSE, 2026 (arXiv:2512.01609).</a:t>
+            </a:r>
+          </a:p>
+          <a:p>
+            <a:pPr indent="0" lvl="0" marL="0" rtl="0" algn="l">
+              <a:spcBef>
+                <a:spcPts val="0"/>
+              </a:spcBef>
+              <a:spcAft>
+                <a:spcPts val="400"/>
+              </a:spcAft>
+              <a:buNone/>
+            </a:pPr>
+            <a:r>
+              <a:rPr lang="en-US" sz="1050">
+                <a:solidFill>
+                  <a:schemeClr val="dk1"/>
+                </a:solidFill>
+                <a:latin typeface="Times New Roman"/>
+                <a:ea typeface="Times New Roman"/>
+                <a:cs typeface="Times New Roman"/>
+                <a:sym typeface="Times New Roman"/>
+              </a:rPr>
+              <a:t xml:space="preserve">[8] M. Hong et al., “Dial-In LLM: Human-aligned LLM-in-the-loop intent clustering for customer service dialogues,” EMNLP, 2025.</a:t>
             </a:r>
           </a:p>
         </p:txBody>
@@ -10803,12 +10826,12 @@
                 <a:spcPts val="0"/>
               </a:spcBef>
               <a:spcAft>
-                <a:spcPts val="500"/>
+                <a:spcPts val="400"/>
               </a:spcAft>
               <a:buNone/>
             </a:pPr>
             <a:r>
-              <a:rPr lang="en-US" sz="1100">
+              <a:rPr lang="en-US" sz="1050">
                 <a:solidFill>
                   <a:schemeClr val="dk1"/>
                 </a:solidFill>
@@ -10817,7 +10840,7 @@
                 <a:cs typeface="Times New Roman"/>
                 <a:sym typeface="Times New Roman"/>
               </a:rPr>
-              <a:t xml:space="preserve">[8] C. Gao et al., “Online app review analysis for identifying emerging issues,” ICSE, 2018.</a:t>
+              <a:t xml:space="preserve">[9] P. Pattnayak et al., “LLM-guided lifecycle-aware clustering of multi-turn customer support conversations,” AACL, 2025.</a:t>
             </a:r>
           </a:p>
           <a:p>
@@ -10826,12 +10849,12 @@
                 <a:spcPts val="0"/>
               </a:spcBef>
               <a:spcAft>
-                <a:spcPts val="500"/>
+                <a:spcPts val="400"/>
               </a:spcAft>
               <a:buNone/>
             </a:pPr>
             <a:r>
-              <a:rPr lang="en-US" sz="1100">
+              <a:rPr lang="en-US" sz="1050">
                 <a:solidFill>
                   <a:schemeClr val="dk1"/>
                 </a:solidFill>
@@ -10840,7 +10863,7 @@
                 <a:cs typeface="Times New Roman"/>
                 <a:sym typeface="Times New Roman"/>
               </a:rPr>
-              <a:t xml:space="preserve">[9] C. Gao et al., “Emerging app issue identification via online joint sentiment-topic tracing,” IEEE TSE, 2022.</a:t>
+              <a:t xml:space="preserve">[10] F. Liu et al., “TickIt: Leveraging large language models for automated ticket escalation,” FSE, 2025.</a:t>
             </a:r>
           </a:p>
           <a:p>
@@ -10849,12 +10872,12 @@
                 <a:spcPts val="0"/>
               </a:spcBef>
               <a:spcAft>
-                <a:spcPts val="500"/>
+                <a:spcPts val="400"/>
               </a:spcAft>
               <a:buNone/>
             </a:pPr>
             <a:r>
-              <a:rPr lang="en-US" sz="1100">
+              <a:rPr lang="en-US" sz="1050">
                 <a:solidFill>
                   <a:schemeClr val="dk1"/>
                 </a:solidFill>
@@ -10863,7 +10886,7 @@
                 <a:cs typeface="Times New Roman"/>
                 <a:sym typeface="Times New Roman"/>
               </a:rPr>
-              <a:t xml:space="preserve">[10] SentiSum, “What is anomaly detection?,” product documentation, help.sentisum.com, 2025.</a:t>
+              <a:t xml:space="preserve">[11] “Incident-aware duplicate ticket aggregation for cloud systems (iPACK),” ICSE, 2023 (arXiv:2302.09520).</a:t>
             </a:r>
           </a:p>
           <a:p>
@@ -10872,12 +10895,12 @@
                 <a:spcPts val="0"/>
               </a:spcBef>
               <a:spcAft>
-                <a:spcPts val="500"/>
+                <a:spcPts val="400"/>
               </a:spcAft>
               <a:buNone/>
             </a:pPr>
             <a:r>
-              <a:rPr lang="en-US" sz="1100">
+              <a:rPr lang="en-US" sz="1050">
                 <a:solidFill>
                   <a:schemeClr val="dk1"/>
                 </a:solidFill>
@@ -10886,7 +10909,7 @@
                 <a:cs typeface="Times New Roman"/>
                 <a:sym typeface="Times New Roman"/>
               </a:rPr>
-              <a:t xml:space="preserve">[11] “iPACK: Incident-aware duplicate ticket aggregation for cloud systems,” ICSE, 2023.</a:t>
+              <a:t xml:space="preserve">[12] SentiSum, “What is anomaly detection?,” product documentation, help.sentisum.com, 2025.</a:t>
             </a:r>
           </a:p>
           <a:p>
@@ -10895,12 +10918,12 @@
                 <a:spcPts val="0"/>
               </a:spcBef>
               <a:spcAft>
-                <a:spcPts val="500"/>
+                <a:spcPts val="400"/>
               </a:spcAft>
               <a:buNone/>
             </a:pPr>
             <a:r>
-              <a:rPr lang="en-US" sz="1100">
+              <a:rPr lang="en-US" sz="1050">
                 <a:solidFill>
                   <a:schemeClr val="dk1"/>
                 </a:solidFill>
@@ -10909,7 +10932,7 @@
                 <a:cs typeface="Times New Roman"/>
                 <a:sym typeface="Times New Roman"/>
               </a:rPr>
-              <a:t xml:space="preserve">[12] “TickIt: Leveraging large language models for automated ticket escalation,” arXiv:2504.08475, 2025.</a:t>
+              <a:t xml:space="preserve">[13] G. S. Manku, A. Jain, A. Das Sarma, “Detecting near-duplicates for web crawling,” WWW, 2007.</a:t>
             </a:r>
           </a:p>
           <a:p>
@@ -10918,12 +10941,12 @@
                 <a:spcPts val="0"/>
               </a:spcBef>
               <a:spcAft>
-                <a:spcPts val="500"/>
+                <a:spcPts val="400"/>
               </a:spcAft>
               <a:buNone/>
             </a:pPr>
             <a:r>
-              <a:rPr lang="en-US" sz="1100">
+              <a:rPr lang="en-US" sz="1050">
                 <a:solidFill>
                   <a:schemeClr val="dk1"/>
                 </a:solidFill>
@@ -10932,7 +10955,7 @@
                 <a:cs typeface="Times New Roman"/>
                 <a:sym typeface="Times New Roman"/>
               </a:rPr>
-              <a:t xml:space="preserve">[13] “Root cause prediction from log data using large language models,” Diva-Portal research report, 2024.</a:t>
+              <a:t xml:space="preserve">[14] A. Z. Broder, “On the resemblance and containment of documents,” Compression and Complexity of Sequences, 1997.</a:t>
             </a:r>
           </a:p>
           <a:p>
@@ -10941,12 +10964,12 @@
                 <a:spcPts val="0"/>
               </a:spcBef>
               <a:spcAft>
-                <a:spcPts val="500"/>
+                <a:spcPts val="400"/>
               </a:spcAft>
               <a:buNone/>
             </a:pPr>
             <a:r>
-              <a:rPr lang="en-US" sz="1100">
+              <a:rPr lang="en-US" sz="1050">
                 <a:solidFill>
                   <a:schemeClr val="dk1"/>
                 </a:solidFill>
@@ -10955,7 +10978,7 @@
                 <a:cs typeface="Times New Roman"/>
                 <a:sym typeface="Times New Roman"/>
               </a:rPr>
-              <a:t xml:space="preserve">[14] S. Lee, S. Lee, “Duplicate bug report detection by using sentence embedding and Faiss,” CEUR-WS vol. 3655, 2023.</a:t>
+              <a:t xml:space="preserve">[15] E. S. Page, “Continuous inspection schemes,” Biometrika, vol. 41, 1954 (CUSUM).</a:t>
             </a:r>
           </a:p>
         </p:txBody>
@@ -11690,8 +11713,8 @@
           <p:nvPr/>
         </p:nvGraphicFramePr>
         <p:xfrm>
-          <a:off x="497000" y="1530000"/>
-          <a:ext cx="8150000" cy="3100000"/>
+          <a:off x="497000" y="1500000"/>
+          <a:ext cx="8150000" cy="2840000"/>
         </p:xfrm>
         <a:graphic>
           <a:graphicData uri="http://schemas.openxmlformats.org/drawingml/2006/table">
@@ -11701,13 +11724,13 @@
                 <a:tableStyleId>{ADC876BD-21E3-499D-94FC-3D607E5DCE7B}</a:tableStyleId>
               </a:tblPr>
               <a:tblGrid>
+                <a:gridCol w="2050000"/>
+                <a:gridCol w="1400000"/>
                 <a:gridCol w="1600000"/>
                 <a:gridCol w="1500000"/>
-                <a:gridCol w="1700000"/>
-                <a:gridCol w="1650000"/>
-                <a:gridCol w="1700000"/>
+                <a:gridCol w="1600000"/>
               </a:tblGrid>
-              <a:tr h="300000">
+              <a:tr h="280000">
                 <a:tc>
                   <a:txBody>
                     <a:bodyPr/>
@@ -11723,13 +11746,13 @@
                         <a:buNone/>
                       </a:pPr>
                       <a:r>
-                        <a:rPr b="1" lang="en-US" sz="1050">
+                        <a:rPr b="1" lang="en-US" sz="1000">
                           <a:latin typeface="Times New Roman"/>
                           <a:ea typeface="Times New Roman"/>
                           <a:cs typeface="Times New Roman"/>
                           <a:sym typeface="Times New Roman"/>
                         </a:rPr>
-                        <a:t>System (venue, year)</a:t>
+                        <a:t>Paper (venue, year)</a:t>
                       </a:r>
                     </a:p>
                   </a:txBody>
@@ -11787,7 +11810,7 @@
                         <a:buNone/>
                       </a:pPr>
                       <a:r>
-                        <a:rPr b="1" lang="en-US" sz="1050">
+                        <a:rPr b="1" lang="en-US" sz="1000">
                           <a:latin typeface="Times New Roman"/>
                           <a:ea typeface="Times New Roman"/>
                           <a:cs typeface="Times New Roman"/>
@@ -11851,7 +11874,7 @@
                         <a:buNone/>
                       </a:pPr>
                       <a:r>
-                        <a:rPr b="1" lang="en-US" sz="1050">
+                        <a:rPr b="1" lang="en-US" sz="1000">
                           <a:latin typeface="Times New Roman"/>
                           <a:ea typeface="Times New Roman"/>
                           <a:cs typeface="Times New Roman"/>
@@ -11915,7 +11938,7 @@
                         <a:buNone/>
                       </a:pPr>
                       <a:r>
-                        <a:rPr b="1" lang="en-US" sz="1050">
+                        <a:rPr b="1" lang="en-US" sz="1000">
                           <a:latin typeface="Times New Roman"/>
                           <a:ea typeface="Times New Roman"/>
                           <a:cs typeface="Times New Roman"/>
@@ -11979,7 +12002,7 @@
                         <a:buNone/>
                       </a:pPr>
                       <a:r>
-                        <a:rPr b="1" lang="en-US" sz="1050">
+                        <a:rPr b="1" lang="en-US" sz="1000">
                           <a:latin typeface="Times New Roman"/>
                           <a:ea typeface="Times New Roman"/>
                           <a:cs typeface="Times New Roman"/>
@@ -12029,7 +12052,7 @@
                   </a:tcPr>
                 </a:tc>
               </a:tr>
-              <a:tr h="700000">
+              <a:tr h="640000">
                 <a:tc>
                   <a:txBody>
                     <a:bodyPr/>
@@ -12045,13 +12068,13 @@
                         <a:buNone/>
                       </a:pPr>
                       <a:r>
-                        <a:rPr b="1" lang="en-US" sz="950">
+                        <a:rPr lang="en-US" sz="900">
                           <a:latin typeface="Times New Roman"/>
                           <a:ea typeface="Times New Roman"/>
                           <a:cs typeface="Times New Roman"/>
                           <a:sym typeface="Times New Roman"/>
                         </a:rPr>
-                        <a:t>SimHash [5] (WWW 2007)</a:t>
+                        <a:t>“Cupid: Leveraging ChatGPT for More Accurate Duplicate Bug Report Detection” [5], 2023</a:t>
                       </a:r>
                     </a:p>
                   </a:txBody>
@@ -12109,13 +12132,13 @@
                         <a:buNone/>
                       </a:pPr>
                       <a:r>
-                        <a:rPr lang="en-US" sz="950">
+                        <a:rPr lang="en-US" sz="900">
                           <a:latin typeface="Times New Roman"/>
                           <a:ea typeface="Times New Roman"/>
                           <a:cs typeface="Times New Roman"/>
                           <a:sym typeface="Times New Roman"/>
                         </a:rPr>
-                        <a:t>64-bit fingerprints, Hamming distance</a:t>
+                        <a:t>ChatGPT extracts essentials, then REP retrieval</a:t>
                       </a:r>
                     </a:p>
                   </a:txBody>
@@ -12173,13 +12196,13 @@
                         <a:buNone/>
                       </a:pPr>
                       <a:r>
-                        <a:rPr lang="en-US" sz="950">
+                        <a:rPr lang="en-US" sz="900">
                           <a:latin typeface="Times New Roman"/>
                           <a:ea typeface="Times New Roman"/>
                           <a:cs typeface="Times New Roman"/>
                           <a:sym typeface="Times New Roman"/>
                         </a:rPr>
-                        <a:t>Hamming distance k = 3 bits</a:t>
+                        <a:t>LLM on 40–60% of reports; Recall-Rate@10 0.60–0.65</a:t>
                       </a:r>
                     </a:p>
                   </a:txBody>
@@ -12237,13 +12260,13 @@
                         <a:buNone/>
                       </a:pPr>
                       <a:r>
-                        <a:rPr lang="en-US" sz="950">
+                        <a:rPr lang="en-US" sz="900">
                           <a:latin typeface="Times New Roman"/>
                           <a:ea typeface="Times New Roman"/>
                           <a:cs typeface="Times New Roman"/>
                           <a:sym typeface="Times New Roman"/>
                         </a:rPr>
-                        <a:t>Detects near-copies only (F1 0.12)</a:t>
+                        <a:t>Ranking only; no cases, spikes or escalation</a:t>
                       </a:r>
                     </a:p>
                   </a:txBody>
@@ -12301,13 +12324,13 @@
                         <a:buNone/>
                       </a:pPr>
                       <a:r>
-                        <a:rPr lang="en-US" sz="950">
+                        <a:rPr lang="en-US" sz="900">
                           <a:latin typeface="Times New Roman"/>
                           <a:ea typeface="Times New Roman"/>
                           <a:cs typeface="Times New Roman"/>
                           <a:sym typeface="Times New Roman"/>
                         </a:rPr>
-                        <a:t>Matches meaning, not wording</a:t>
+                        <a:t>Online cases with spike alerts and RCA</a:t>
                       </a:r>
                     </a:p>
                   </a:txBody>
@@ -12351,7 +12374,7 @@
                   </a:tcPr>
                 </a:tc>
               </a:tr>
-              <a:tr h="700000">
+              <a:tr h="640000">
                 <a:tc>
                   <a:txBody>
                     <a:bodyPr/>
@@ -12367,13 +12390,13 @@
                         <a:buNone/>
                       </a:pPr>
                       <a:r>
-                        <a:rPr b="1" lang="en-US" sz="950">
+                        <a:rPr lang="en-US" sz="900">
                           <a:latin typeface="Times New Roman"/>
                           <a:ea typeface="Times New Roman"/>
                           <a:cs typeface="Times New Roman"/>
                           <a:sym typeface="Times New Roman"/>
                         </a:rPr>
-                        <a:t>MinHash-LSH [6] (1997)</a:t>
+                        <a:t>“Entity Matching using Large Language Models” [6], EDBT 2025</a:t>
                       </a:r>
                     </a:p>
                   </a:txBody>
@@ -12431,13 +12454,13 @@
                         <a:buNone/>
                       </a:pPr>
                       <a:r>
-                        <a:rPr lang="en-US" sz="950">
+                        <a:rPr lang="en-US" sz="900">
                           <a:latin typeface="Times New Roman"/>
                           <a:ea typeface="Times New Roman"/>
                           <a:cs typeface="Times New Roman"/>
                           <a:sym typeface="Times New Roman"/>
                         </a:rPr>
-                        <a:t>Jaccard over shingles + banding</a:t>
+                        <a:t>Zero-shot GPT-4 pair judge</a:t>
                       </a:r>
                     </a:p>
                   </a:txBody>
@@ -12495,13 +12518,13 @@
                         <a:buNone/>
                       </a:pPr>
                       <a:r>
-                        <a:rPr lang="en-US" sz="950">
+                        <a:rPr lang="en-US" sz="900">
                           <a:latin typeface="Times New Roman"/>
                           <a:ea typeface="Times New Roman"/>
                           <a:cs typeface="Times New Roman"/>
                           <a:sym typeface="Times New Roman"/>
                         </a:rPr>
-                        <a:t>Similarity cut 0.75 / 0.80 / 0.85</a:t>
+                        <a:t>Prompt only; F1 89.6–98.4 on record pairs</a:t>
                       </a:r>
                     </a:p>
                   </a:txBody>
@@ -12559,13 +12582,13 @@
                         <a:buNone/>
                       </a:pPr>
                       <a:r>
-                        <a:rPr lang="en-US" sz="950">
+                        <a:rPr lang="en-US" sz="900">
                           <a:latin typeface="Times New Roman"/>
                           <a:ea typeface="Times New Roman"/>
                           <a:cs typeface="Times New Roman"/>
                           <a:sym typeface="Times New Roman"/>
                         </a:rPr>
-                        <a:t>Detects near-copies only (F1 0.20)</a:t>
+                        <a:t>Judges every pair: cost grows with pairs</a:t>
                       </a:r>
                     </a:p>
                   </a:txBody>
@@ -12623,13 +12646,13 @@
                         <a:buNone/>
                       </a:pPr>
                       <a:r>
-                        <a:rPr lang="en-US" sz="950">
+                        <a:rPr lang="en-US" sz="900">
                           <a:latin typeface="Times New Roman"/>
                           <a:ea typeface="Times New Roman"/>
                           <a:cs typeface="Times New Roman"/>
                           <a:sym typeface="Times New Roman"/>
                         </a:rPr>
-                        <a:t>Matches meaning, not wording</a:t>
+                        <a:t>Judge only in the calibrated band, at most 5 candidates</a:t>
                       </a:r>
                     </a:p>
                   </a:txBody>
@@ -12673,7 +12696,7 @@
                   </a:tcPr>
                 </a:tc>
               </a:tr>
-              <a:tr h="700000">
+              <a:tr h="640000">
                 <a:tc>
                   <a:txBody>
                     <a:bodyPr/>
@@ -12689,13 +12712,13 @@
                         <a:buNone/>
                       </a:pPr>
                       <a:r>
-                        <a:rPr b="1" lang="en-US" sz="950">
+                        <a:rPr lang="en-US" sz="900">
                           <a:latin typeface="Times New Roman"/>
                           <a:ea typeface="Times New Roman"/>
                           <a:cs typeface="Times New Roman"/>
                           <a:sym typeface="Times New Roman"/>
                         </a:rPr>
-                        <a:t>BERTopic [7] (2022)</a:t>
+                        <a:t>“GPTrace: Effective Crash Deduplication Using LLM Embeddings” [7], ICSE 2026</a:t>
                       </a:r>
                     </a:p>
                   </a:txBody>
@@ -12753,13 +12776,13 @@
                         <a:buNone/>
                       </a:pPr>
                       <a:r>
-                        <a:rPr lang="en-US" sz="950">
+                        <a:rPr lang="en-US" sz="900">
                           <a:latin typeface="Times New Roman"/>
                           <a:ea typeface="Times New Roman"/>
                           <a:cs typeface="Times New Roman"/>
                           <a:sym typeface="Times New Roman"/>
                         </a:rPr>
-                        <a:t>Embeddings + UMAP + HDBSCAN topics</a:t>
+                        <a:t>LLM embeddings + HDBSCAN clustering</a:t>
                       </a:r>
                     </a:p>
                   </a:txBody>
@@ -12817,13 +12840,13 @@
                         <a:buNone/>
                       </a:pPr>
                       <a:r>
-                        <a:rPr lang="en-US" sz="950">
+                        <a:rPr lang="en-US" sz="900">
                           <a:latin typeface="Times New Roman"/>
                           <a:ea typeface="Times New Roman"/>
                           <a:cs typeface="Times New Roman"/>
                           <a:sym typeface="Times New Roman"/>
                         </a:rPr>
-                        <a:t>Library defaults (minimum topic size)</a:t>
+                        <a:t>Density clustering over 300K crash reports</a:t>
                       </a:r>
                     </a:p>
                   </a:txBody>
@@ -12881,13 +12904,13 @@
                         <a:buNone/>
                       </a:pPr>
                       <a:r>
-                        <a:rPr lang="en-US" sz="950">
+                        <a:rPr lang="en-US" sz="900">
                           <a:latin typeface="Times New Roman"/>
                           <a:ea typeface="Times New Roman"/>
                           <a:cs typeface="Times New Roman"/>
                           <a:sym typeface="Times New Roman"/>
                         </a:rPr>
-                        <a:t>Topics are themes, not problems (P 0.16)</a:t>
+                        <a:t>Batch; stack traces only</a:t>
                       </a:r>
                     </a:p>
                   </a:txBody>
@@ -12945,13 +12968,13 @@
                         <a:buNone/>
                       </a:pPr>
                       <a:r>
-                        <a:rPr lang="en-US" sz="950">
+                        <a:rPr lang="en-US" sz="900">
                           <a:latin typeface="Times New Roman"/>
                           <a:ea typeface="Times New Roman"/>
                           <a:cs typeface="Times New Roman"/>
                           <a:sym typeface="Times New Roman"/>
                         </a:rPr>
-                        <a:t>Problem-level cases; topics used only for routing</a:t>
+                        <a:t>Online grouping of free-text complaints</a:t>
                       </a:r>
                     </a:p>
                   </a:txBody>
@@ -12995,7 +13018,7 @@
                   </a:tcPr>
                 </a:tc>
               </a:tr>
-              <a:tr h="700000">
+              <a:tr h="640000">
                 <a:tc>
                   <a:txBody>
                     <a:bodyPr/>
@@ -13011,13 +13034,13 @@
                         <a:buNone/>
                       </a:pPr>
                       <a:r>
-                        <a:rPr b="1" lang="en-US" sz="950">
+                        <a:rPr lang="en-US" sz="900">
                           <a:latin typeface="Times New Roman"/>
                           <a:ea typeface="Times New Roman"/>
                           <a:cs typeface="Times New Roman"/>
                           <a:sym typeface="Times New Roman"/>
                         </a:rPr>
-                        <a:t>IDEA / MERIT [8, 9] (ICSE 2018, TSE 2022)</a:t>
+                        <a:t>“Dial-In LLM: Human-Aligned LLM-in-the-loop Intent Clustering for Customer Service Dialogues” [8], EMNLP 2025</a:t>
                       </a:r>
                     </a:p>
                   </a:txBody>
@@ -13075,13 +13098,13 @@
                         <a:buNone/>
                       </a:pPr>
                       <a:r>
-                        <a:rPr lang="en-US" sz="950">
+                        <a:rPr lang="en-US" sz="900">
                           <a:latin typeface="Times New Roman"/>
                           <a:ea typeface="Times New Roman"/>
                           <a:cs typeface="Times New Roman"/>
                           <a:sym typeface="Times New Roman"/>
                         </a:rPr>
-                        <a:t>Online topic models per app version</a:t>
+                        <a:t>LLM-in-the-loop intent clustering</a:t>
                       </a:r>
                     </a:p>
                   </a:txBody>
@@ -13139,13 +13162,13 @@
                         <a:buNone/>
                       </a:pPr>
                       <a:r>
-                        <a:rPr lang="en-US" sz="950">
+                        <a:rPr lang="en-US" sz="900">
                           <a:latin typeface="Times New Roman"/>
                           <a:ea typeface="Times New Roman"/>
                           <a:cs typeface="Times New Roman"/>
                           <a:sym typeface="Times New Roman"/>
                         </a:rPr>
-                        <a:t>Change in topic share between versions</a:t>
+                        <a:t>100k calls, 1,507 clusters; &gt;95% agreement with humans</a:t>
                       </a:r>
                     </a:p>
                   </a:txBody>
@@ -13203,13 +13226,13 @@
                         <a:buNone/>
                       </a:pPr>
                       <a:r>
-                        <a:rPr lang="en-US" sz="950">
+                        <a:rPr lang="en-US" sz="900">
                           <a:latin typeface="Times New Roman"/>
                           <a:ea typeface="Times New Roman"/>
                           <a:cs typeface="Times New Roman"/>
                           <a:sym typeface="Times New Roman"/>
                         </a:rPr>
-                        <a:t>Per version; no problem cases</a:t>
+                        <a:t>Intents, not problems; batch</a:t>
                       </a:r>
                     </a:p>
                   </a:txBody>
@@ -13267,13 +13290,13 @@
                         <a:buNone/>
                       </a:pPr>
                       <a:r>
-                        <a:rPr lang="en-US" sz="950">
+                        <a:rPr lang="en-US" sz="900">
                           <a:latin typeface="Times New Roman"/>
                           <a:ea typeface="Times New Roman"/>
                           <a:cs typeface="Times New Roman"/>
                           <a:sym typeface="Times New Roman"/>
                         </a:rPr>
-                        <a:t>Per-case grouping as each complaint arrives</a:t>
+                        <a:t>Problem cases decided as complaints arrive</a:t>
                       </a:r>
                     </a:p>
                   </a:txBody>
@@ -13830,8 +13853,8 @@
           <p:nvPr/>
         </p:nvGraphicFramePr>
         <p:xfrm>
-          <a:off x="497000" y="1530000"/>
-          <a:ext cx="8150000" cy="3100000"/>
+          <a:off x="497000" y="1500000"/>
+          <a:ext cx="8150000" cy="2600000"/>
         </p:xfrm>
         <a:graphic>
           <a:graphicData uri="http://schemas.openxmlformats.org/drawingml/2006/table">
@@ -13841,13 +13864,13 @@
                 <a:tableStyleId>{ADC876BD-21E3-499D-94FC-3D607E5DCE7B}</a:tableStyleId>
               </a:tblPr>
               <a:tblGrid>
+                <a:gridCol w="2050000"/>
+                <a:gridCol w="1400000"/>
                 <a:gridCol w="1600000"/>
                 <a:gridCol w="1500000"/>
-                <a:gridCol w="1700000"/>
-                <a:gridCol w="1650000"/>
-                <a:gridCol w="1700000"/>
+                <a:gridCol w="1600000"/>
               </a:tblGrid>
-              <a:tr h="300000">
+              <a:tr h="280000">
                 <a:tc>
                   <a:txBody>
                     <a:bodyPr/>
@@ -13863,13 +13886,13 @@
                         <a:buNone/>
                       </a:pPr>
                       <a:r>
-                        <a:rPr b="1" lang="en-US" sz="1050">
+                        <a:rPr b="1" lang="en-US" sz="1000">
                           <a:latin typeface="Times New Roman"/>
                           <a:ea typeface="Times New Roman"/>
                           <a:cs typeface="Times New Roman"/>
                           <a:sym typeface="Times New Roman"/>
                         </a:rPr>
-                        <a:t>System (venue, year)</a:t>
+                        <a:t>Paper (venue, year)</a:t>
                       </a:r>
                     </a:p>
                   </a:txBody>
@@ -13927,7 +13950,7 @@
                         <a:buNone/>
                       </a:pPr>
                       <a:r>
-                        <a:rPr b="1" lang="en-US" sz="1050">
+                        <a:rPr b="1" lang="en-US" sz="1000">
                           <a:latin typeface="Times New Roman"/>
                           <a:ea typeface="Times New Roman"/>
                           <a:cs typeface="Times New Roman"/>
@@ -13991,7 +14014,7 @@
                         <a:buNone/>
                       </a:pPr>
                       <a:r>
-                        <a:rPr b="1" lang="en-US" sz="1050">
+                        <a:rPr b="1" lang="en-US" sz="1000">
                           <a:latin typeface="Times New Roman"/>
                           <a:ea typeface="Times New Roman"/>
                           <a:cs typeface="Times New Roman"/>
@@ -14055,7 +14078,7 @@
                         <a:buNone/>
                       </a:pPr>
                       <a:r>
-                        <a:rPr b="1" lang="en-US" sz="1050">
+                        <a:rPr b="1" lang="en-US" sz="1000">
                           <a:latin typeface="Times New Roman"/>
                           <a:ea typeface="Times New Roman"/>
                           <a:cs typeface="Times New Roman"/>
@@ -14119,7 +14142,7 @@
                         <a:buNone/>
                       </a:pPr>
                       <a:r>
-                        <a:rPr b="1" lang="en-US" sz="1050">
+                        <a:rPr b="1" lang="en-US" sz="1000">
                           <a:latin typeface="Times New Roman"/>
                           <a:ea typeface="Times New Roman"/>
                           <a:cs typeface="Times New Roman"/>
@@ -14169,7 +14192,7 @@
                   </a:tcPr>
                 </a:tc>
               </a:tr>
-              <a:tr h="700000">
+              <a:tr h="580000">
                 <a:tc>
                   <a:txBody>
                     <a:bodyPr/>
@@ -14185,13 +14208,13 @@
                         <a:buNone/>
                       </a:pPr>
                       <a:r>
-                        <a:rPr b="1" lang="en-US" sz="950">
+                        <a:rPr lang="en-US" sz="900">
                           <a:latin typeface="Times New Roman"/>
                           <a:ea typeface="Times New Roman"/>
                           <a:cs typeface="Times New Roman"/>
                           <a:sym typeface="Times New Roman"/>
                         </a:rPr>
-                        <a:t>SentiSum [10] (commercial)</a:t>
+                        <a:t>“LLM-Guided Lifecycle-Aware Clustering of Multi-Turn Customer Support Conversations” [9], AACL 2025</a:t>
                       </a:r>
                     </a:p>
                   </a:txBody>
@@ -14249,13 +14272,13 @@
                         <a:buNone/>
                       </a:pPr>
                       <a:r>
-                        <a:rPr lang="en-US" sz="950">
+                        <a:rPr lang="en-US" sz="900">
                           <a:latin typeface="Times New Roman"/>
                           <a:ea typeface="Times New Roman"/>
                           <a:cs typeface="Times New Roman"/>
                           <a:sym typeface="Times New Roman"/>
                         </a:rPr>
-                        <a:t>Anomaly detection per tag</a:t>
+                        <a:t>Incremental clustering; LLM splits degraded clusters</a:t>
                       </a:r>
                     </a:p>
                   </a:txBody>
@@ -14313,13 +14336,13 @@
                         <a:buNone/>
                       </a:pPr>
                       <a:r>
-                        <a:rPr lang="en-US" sz="950">
+                        <a:rPr lang="en-US" sz="900">
                           <a:latin typeface="Times New Roman"/>
                           <a:ea typeface="Times New Roman"/>
                           <a:cs typeface="Times New Roman"/>
                           <a:sym typeface="Times New Roman"/>
                         </a:rPr>
-                        <a:t>z-score &gt; 2 per tag</a:t>
+                        <a:t>Silhouette / Davies-Bouldin quality triggers</a:t>
                       </a:r>
                     </a:p>
                   </a:txBody>
@@ -14377,13 +14400,13 @@
                         <a:buNone/>
                       </a:pPr>
                       <a:r>
-                        <a:rPr lang="en-US" sz="950">
+                        <a:rPr lang="en-US" sz="900">
                           <a:latin typeface="Times New Roman"/>
                           <a:ea typeface="Times New Roman"/>
                           <a:cs typeface="Times New Roman"/>
                           <a:sym typeface="Times New Roman"/>
                         </a:rPr>
-                        <a:t>Fails at 0–2 complaints per window (0% detected)</a:t>
+                        <a:t>No spike detection, RCA or escalation</a:t>
                       </a:r>
                     </a:p>
                   </a:txBody>
@@ -14441,13 +14464,13 @@
                         <a:buNone/>
                       </a:pPr>
                       <a:r>
-                        <a:rPr lang="en-US" sz="950">
+                        <a:rPr lang="en-US" sz="900">
                           <a:latin typeface="Times New Roman"/>
                           <a:ea typeface="Times New Roman"/>
                           <a:cs typeface="Times New Roman"/>
                           <a:sym typeface="Times New Roman"/>
                         </a:rPr>
-                        <a:t>Poisson CUSUM, h = 2 (76–91% detected)</a:t>
+                        <a:t>Full pipeline: spikes, RCA, approval</a:t>
                       </a:r>
                     </a:p>
                   </a:txBody>
@@ -14491,7 +14514,7 @@
                   </a:tcPr>
                 </a:tc>
               </a:tr>
-              <a:tr h="700000">
+              <a:tr h="580000">
                 <a:tc>
                   <a:txBody>
                     <a:bodyPr/>
@@ -14507,13 +14530,13 @@
                         <a:buNone/>
                       </a:pPr>
                       <a:r>
-                        <a:rPr b="1" lang="en-US" sz="950">
+                        <a:rPr lang="en-US" sz="900">
                           <a:latin typeface="Times New Roman"/>
                           <a:ea typeface="Times New Roman"/>
                           <a:cs typeface="Times New Roman"/>
                           <a:sym typeface="Times New Roman"/>
                         </a:rPr>
-                        <a:t>iPACK [11] (ICSE 2023)</a:t>
+                        <a:t>“TickIt: Leveraging Large Language Models for Automated Ticket Escalation” [10], FSE 2025 (ByteDance)</a:t>
                       </a:r>
                     </a:p>
                   </a:txBody>
@@ -14571,13 +14594,13 @@
                         <a:buNone/>
                       </a:pPr>
                       <a:r>
-                        <a:rPr lang="en-US" sz="950">
+                        <a:rPr lang="en-US" sz="900">
                           <a:latin typeface="Times New Roman"/>
                           <a:ea typeface="Times New Roman"/>
                           <a:cs typeface="Times New Roman"/>
                           <a:sym typeface="Times New Roman"/>
                         </a:rPr>
-                        <a:t>Links tickets to cloud incidents</a:t>
+                        <a:t>LLM escalation with category fine-tuning</a:t>
                       </a:r>
                     </a:p>
                   </a:txBody>
@@ -14635,13 +14658,13 @@
                         <a:buNone/>
                       </a:pPr>
                       <a:r>
-                        <a:rPr lang="en-US" sz="950">
+                        <a:rPr lang="en-US" sz="900">
                           <a:latin typeface="Times New Roman"/>
                           <a:ea typeface="Times New Roman"/>
                           <a:cs typeface="Times New Roman"/>
                           <a:sym typeface="Times New Roman"/>
                         </a:rPr>
-                        <a:t>Requires cloud monitoring alerts</a:t>
+                        <a:t>Predefined ticket categories</a:t>
                       </a:r>
                     </a:p>
                   </a:txBody>
@@ -14699,13 +14722,13 @@
                         <a:buNone/>
                       </a:pPr>
                       <a:r>
-                        <a:rPr lang="en-US" sz="950">
+                        <a:rPr lang="en-US" sz="900">
                           <a:latin typeface="Times New Roman"/>
                           <a:ea typeface="Times New Roman"/>
                           <a:cs typeface="Times New Roman"/>
                           <a:sym typeface="Times New Roman"/>
                         </a:rPr>
-                        <a:t>Depends on telemetry</a:t>
+                        <a:t>Fixed category set; no spike detection</a:t>
                       </a:r>
                     </a:p>
                   </a:txBody>
@@ -14763,13 +14786,13 @@
                         <a:buNone/>
                       </a:pPr>
                       <a:r>
-                        <a:rPr lang="en-US" sz="950">
+                        <a:rPr lang="en-US" sz="900">
                           <a:latin typeface="Times New Roman"/>
                           <a:ea typeface="Times New Roman"/>
                           <a:cs typeface="Times New Roman"/>
                           <a:sym typeface="Times New Roman"/>
                         </a:rPr>
-                        <a:t>Works from complaint text alone</a:t>
+                        <a:t>Open-ended cases + CUSUM + vague alarm</a:t>
                       </a:r>
                     </a:p>
                   </a:txBody>
@@ -14813,7 +14836,7 @@
                   </a:tcPr>
                 </a:tc>
               </a:tr>
-              <a:tr h="700000">
+              <a:tr h="580000">
                 <a:tc>
                   <a:txBody>
                     <a:bodyPr/>
@@ -14829,13 +14852,13 @@
                         <a:buNone/>
                       </a:pPr>
                       <a:r>
-                        <a:rPr b="1" lang="en-US" sz="950">
+                        <a:rPr lang="en-US" sz="900">
                           <a:latin typeface="Times New Roman"/>
                           <a:ea typeface="Times New Roman"/>
                           <a:cs typeface="Times New Roman"/>
                           <a:sym typeface="Times New Roman"/>
                         </a:rPr>
-                        <a:t>TickIt [12] (2025)</a:t>
+                        <a:t>“Incident-aware Duplicate Ticket Aggregation for Cloud Systems” (iPACK) [11], ICSE 2023 (Microsoft)</a:t>
                       </a:r>
                     </a:p>
                   </a:txBody>
@@ -14893,13 +14916,13 @@
                         <a:buNone/>
                       </a:pPr>
                       <a:r>
-                        <a:rPr lang="en-US" sz="950">
+                        <a:rPr lang="en-US" sz="900">
                           <a:latin typeface="Times New Roman"/>
                           <a:ea typeface="Times New Roman"/>
                           <a:cs typeface="Times New Roman"/>
                           <a:sym typeface="Times New Roman"/>
                         </a:rPr>
-                        <a:t>LLM ticket grouping and escalation</a:t>
+                        <a:t>Links tickets to cloud incident alerts</a:t>
                       </a:r>
                     </a:p>
                   </a:txBody>
@@ -14957,13 +14980,13 @@
                         <a:buNone/>
                       </a:pPr>
                       <a:r>
-                        <a:rPr lang="en-US" sz="950">
+                        <a:rPr lang="en-US" sz="900">
                           <a:latin typeface="Times New Roman"/>
                           <a:ea typeface="Times New Roman"/>
                           <a:cs typeface="Times New Roman"/>
                           <a:sym typeface="Times New Roman"/>
                         </a:rPr>
-                        <a:t>Predefined ticket categories</a:t>
+                        <a:t>Requires monitoring alerts; F1 0.87–0.94</a:t>
                       </a:r>
                     </a:p>
                   </a:txBody>
@@ -15021,13 +15044,13 @@
                         <a:buNone/>
                       </a:pPr>
                       <a:r>
-                        <a:rPr lang="en-US" sz="950">
+                        <a:rPr lang="en-US" sz="900">
                           <a:latin typeface="Times New Roman"/>
                           <a:ea typeface="Times New Roman"/>
                           <a:cs typeface="Times New Roman"/>
                           <a:sym typeface="Times New Roman"/>
                         </a:rPr>
-                        <a:t>Fixed category set</a:t>
+                        <a:t>Depends on telemetry</a:t>
                       </a:r>
                     </a:p>
                   </a:txBody>
@@ -15085,13 +15108,13 @@
                         <a:buNone/>
                       </a:pPr>
                       <a:r>
-                        <a:rPr lang="en-US" sz="950">
+                        <a:rPr lang="en-US" sz="900">
                           <a:latin typeface="Times New Roman"/>
                           <a:ea typeface="Times New Roman"/>
                           <a:cs typeface="Times New Roman"/>
                           <a:sym typeface="Times New Roman"/>
                         </a:rPr>
-                        <a:t>Open-ended cases + vague-complaint alarm</a:t>
+                        <a:t>Works from complaint text alone</a:t>
                       </a:r>
                     </a:p>
                   </a:txBody>
@@ -15135,7 +15158,7 @@
                   </a:tcPr>
                 </a:tc>
               </a:tr>
-              <a:tr h="700000">
+              <a:tr h="580000">
                 <a:tc>
                   <a:txBody>
                     <a:bodyPr/>
@@ -15151,13 +15174,13 @@
                         <a:buNone/>
                       </a:pPr>
                       <a:r>
-                        <a:rPr b="1" lang="en-US" sz="950">
+                        <a:rPr lang="en-US" sz="900">
                           <a:latin typeface="Times New Roman"/>
                           <a:ea typeface="Times New Roman"/>
                           <a:cs typeface="Times New Roman"/>
                           <a:sym typeface="Times New Roman"/>
                         </a:rPr>
-                        <a:t>LLM RCA from logs [13] (2024)</a:t>
+                        <a:t>SentiSum anomaly detection [12], commercial, 2025</a:t>
                       </a:r>
                     </a:p>
                   </a:txBody>
@@ -15215,13 +15238,13 @@
                         <a:buNone/>
                       </a:pPr>
                       <a:r>
-                        <a:rPr lang="en-US" sz="950">
+                        <a:rPr lang="en-US" sz="900">
                           <a:latin typeface="Times New Roman"/>
                           <a:ea typeface="Times New Roman"/>
                           <a:cs typeface="Times New Roman"/>
                           <a:sym typeface="Times New Roman"/>
                         </a:rPr>
-                        <a:t>Mistral / Mixtral on log data</a:t>
+                        <a:t>Anomaly detection per tag</a:t>
                       </a:r>
                     </a:p>
                   </a:txBody>
@@ -15279,13 +15302,13 @@
                         <a:buNone/>
                       </a:pPr>
                       <a:r>
-                        <a:rPr lang="en-US" sz="950">
+                        <a:rPr lang="en-US" sz="900">
                           <a:latin typeface="Times New Roman"/>
                           <a:ea typeface="Times New Roman"/>
                           <a:cs typeface="Times New Roman"/>
                           <a:sym typeface="Times New Roman"/>
                         </a:rPr>
-                        <a:t>Trained on labelled log data</a:t>
+                        <a:t>z-score &gt; 2 per tag</a:t>
                       </a:r>
                     </a:p>
                   </a:txBody>
@@ -15343,13 +15366,13 @@
                         <a:buNone/>
                       </a:pPr>
                       <a:r>
-                        <a:rPr lang="en-US" sz="950">
+                        <a:rPr lang="en-US" sz="900">
                           <a:latin typeface="Times New Roman"/>
                           <a:ea typeface="Times New Roman"/>
                           <a:cs typeface="Times New Roman"/>
                           <a:sym typeface="Times New Roman"/>
                         </a:rPr>
-                        <a:t>Needs labelled data</a:t>
+                        <a:t>Fails at 0–2 complaints per window (0% detected)</a:t>
                       </a:r>
                     </a:p>
                   </a:txBody>
@@ -15407,13 +15430,13 @@
                         <a:buNone/>
                       </a:pPr>
                       <a:r>
-                        <a:rPr lang="en-US" sz="950">
+                        <a:rPr lang="en-US" sz="900">
                           <a:latin typeface="Times New Roman"/>
                           <a:ea typeface="Times New Roman"/>
                           <a:cs typeface="Times New Roman"/>
                           <a:sym typeface="Times New Roman"/>
                         </a:rPr>
-                        <a:t>Grounded RCA, no training, human approval</a:t>
+                        <a:t>Poisson CUSUM, h = 2 (76–91% detected)</a:t>
                       </a:r>
                     </a:p>
                   </a:txBody>
@@ -15608,6 +15631,55 @@
           </a:graphicData>
         </a:graphic>
       </p:graphicFrame>
+      <p:sp>
+        <p:nvSpPr>
+          <p:cNvPr id="950" name="Results text 950"/>
+          <p:cNvSpPr txBox="1"/>
+          <p:nvPr/>
+        </p:nvSpPr>
+        <p:spPr>
+          <a:xfrm>
+            <a:off x="497000" y="4170000"/>
+            <a:ext cx="8150000" cy="620000"/>
+          </a:xfrm>
+          <a:prstGeom prst="rect">
+            <a:avLst/>
+          </a:prstGeom>
+          <a:noFill/>
+          <a:ln>
+            <a:noFill/>
+          </a:ln>
+        </p:spPr>
+        <p:txBody>
+          <a:bodyPr anchorCtr="0" anchor="t" bIns="45720" lIns="45720" spcFirstLastPara="1" rIns="45720" wrap="square" tIns="45720">
+            <a:noAutofit/>
+          </a:bodyPr>
+          <a:lstStyle/>
+          <a:p>
+            <a:pPr indent="0" lvl="0" marL="0" rtl="0" algn="l">
+              <a:spcBef>
+                <a:spcPts val="0"/>
+              </a:spcBef>
+              <a:spcAft>
+                <a:spcPts val="0"/>
+              </a:spcAft>
+              <a:buNone/>
+            </a:pPr>
+            <a:r>
+              <a:rPr b="1" lang="en-US" sz="1000">
+                <a:solidFill>
+                  <a:schemeClr val="dk1"/>
+                </a:solidFill>
+                <a:latin typeface="Times New Roman"/>
+                <a:ea typeface="Times New Roman"/>
+                <a:cs typeface="Times New Roman"/>
+                <a:sym typeface="Times New Roman"/>
+              </a:rPr>
+              <a:t xml:space="preserve">Research finding: several systems group duplicate reports (CLAP, TickIt, iPACK, Dial-In LLM), but none we found in academic papers, industry blogs, products or patents combines online problem-level case merging of raw complaint text with per-case spike detection, root-cause explanation and human-approved escalation.</a:t>
+            </a:r>
+          </a:p>
+        </p:txBody>
+      </p:sp>
     </p:spTree>
   </p:cSld>
   <p:clrMapOvr>
@@ -18908,8 +18980,8 @@
           <p:nvPr/>
         </p:nvGraphicFramePr>
         <p:xfrm>
-          <a:off x="497000" y="1530000"/>
-          <a:ext cx="8150000" cy="3100000"/>
+          <a:off x="497000" y="1500000"/>
+          <a:ext cx="8150000" cy="2840000"/>
         </p:xfrm>
         <a:graphic>
           <a:graphicData uri="http://schemas.openxmlformats.org/drawingml/2006/table">
@@ -18919,13 +18991,13 @@
                 <a:tableStyleId>{ADC876BD-21E3-499D-94FC-3D607E5DCE7B}</a:tableStyleId>
               </a:tblPr>
               <a:tblGrid>
+                <a:gridCol w="2050000"/>
+                <a:gridCol w="1400000"/>
                 <a:gridCol w="1600000"/>
                 <a:gridCol w="1500000"/>
-                <a:gridCol w="1700000"/>
-                <a:gridCol w="1650000"/>
-                <a:gridCol w="1700000"/>
+                <a:gridCol w="1600000"/>
               </a:tblGrid>
-              <a:tr h="300000">
+              <a:tr h="280000">
                 <a:tc>
                   <a:txBody>
                     <a:bodyPr/>
@@ -18941,13 +19013,13 @@
                         <a:buNone/>
                       </a:pPr>
                       <a:r>
-                        <a:rPr b="1" lang="en-US" sz="1050">
+                        <a:rPr b="1" lang="en-US" sz="1000">
                           <a:latin typeface="Times New Roman"/>
                           <a:ea typeface="Times New Roman"/>
                           <a:cs typeface="Times New Roman"/>
                           <a:sym typeface="Times New Roman"/>
                         </a:rPr>
-                        <a:t>System (venue, year)</a:t>
+                        <a:t>Paper (venue, year)</a:t>
                       </a:r>
                     </a:p>
                   </a:txBody>
@@ -19005,7 +19077,7 @@
                         <a:buNone/>
                       </a:pPr>
                       <a:r>
-                        <a:rPr b="1" lang="en-US" sz="1050">
+                        <a:rPr b="1" lang="en-US" sz="1000">
                           <a:latin typeface="Times New Roman"/>
                           <a:ea typeface="Times New Roman"/>
                           <a:cs typeface="Times New Roman"/>
@@ -19069,7 +19141,7 @@
                         <a:buNone/>
                       </a:pPr>
                       <a:r>
-                        <a:rPr b="1" lang="en-US" sz="1050">
+                        <a:rPr b="1" lang="en-US" sz="1000">
                           <a:latin typeface="Times New Roman"/>
                           <a:ea typeface="Times New Roman"/>
                           <a:cs typeface="Times New Roman"/>
@@ -19133,7 +19205,7 @@
                         <a:buNone/>
                       </a:pPr>
                       <a:r>
-                        <a:rPr b="1" lang="en-US" sz="1050">
+                        <a:rPr b="1" lang="en-US" sz="1000">
                           <a:latin typeface="Times New Roman"/>
                           <a:ea typeface="Times New Roman"/>
                           <a:cs typeface="Times New Roman"/>
@@ -19197,7 +19269,7 @@
                         <a:buNone/>
                       </a:pPr>
                       <a:r>
-                        <a:rPr b="1" lang="en-US" sz="1050">
+                        <a:rPr b="1" lang="en-US" sz="1000">
                           <a:latin typeface="Times New Roman"/>
                           <a:ea typeface="Times New Roman"/>
                           <a:cs typeface="Times New Roman"/>
@@ -19247,7 +19319,7 @@
                   </a:tcPr>
                 </a:tc>
               </a:tr>
-              <a:tr h="700000">
+              <a:tr h="640000">
                 <a:tc>
                   <a:txBody>
                     <a:bodyPr/>
@@ -19263,13 +19335,13 @@
                         <a:buNone/>
                       </a:pPr>
                       <a:r>
-                        <a:rPr b="1" lang="en-US" sz="950">
+                        <a:rPr lang="en-US" sz="900">
                           <a:latin typeface="Times New Roman"/>
                           <a:ea typeface="Times New Roman"/>
                           <a:cs typeface="Times New Roman"/>
                           <a:sym typeface="Times New Roman"/>
                         </a:rPr>
-                        <a:t>CLAP [1] (ICSE 2016)</a:t>
+                        <a:t>“Release Planning of Mobile Apps Based on User Reviews” (CLAP) [1], ICSE 2016</a:t>
                       </a:r>
                     </a:p>
                   </a:txBody>
@@ -19327,7 +19399,7 @@
                         <a:buNone/>
                       </a:pPr>
                       <a:r>
-                        <a:rPr lang="en-US" sz="950">
+                        <a:rPr lang="en-US" sz="900">
                           <a:latin typeface="Times New Roman"/>
                           <a:ea typeface="Times New Roman"/>
                           <a:cs typeface="Times New Roman"/>
@@ -19391,13 +19463,13 @@
                         <a:buNone/>
                       </a:pPr>
                       <a:r>
-                        <a:rPr lang="en-US" sz="950">
+                        <a:rPr lang="en-US" sz="900">
                           <a:latin typeface="Times New Roman"/>
                           <a:ea typeface="Times New Roman"/>
                           <a:cs typeface="Times New Roman"/>
                           <a:sym typeface="Times New Roman"/>
                         </a:rPr>
-                        <a:t>eps 0.6 as published; 0.75 tuned on our data</a:t>
+                        <a:t>eps 0.6 published; 0.75 tuned on our data</a:t>
                       </a:r>
                     </a:p>
                   </a:txBody>
@@ -19455,7 +19527,7 @@
                         <a:buNone/>
                       </a:pPr>
                       <a:r>
-                        <a:rPr lang="en-US" sz="950">
+                        <a:rPr lang="en-US" sz="900">
                           <a:latin typeface="Times New Roman"/>
                           <a:ea typeface="Times New Roman"/>
                           <a:cs typeface="Times New Roman"/>
@@ -19519,7 +19591,7 @@
                         <a:buNone/>
                       </a:pPr>
                       <a:r>
-                        <a:rPr lang="en-US" sz="950">
+                        <a:rPr lang="en-US" sz="900">
                           <a:latin typeface="Times New Roman"/>
                           <a:ea typeface="Times New Roman"/>
                           <a:cs typeface="Times New Roman"/>
@@ -19569,7 +19641,7 @@
                   </a:tcPr>
                 </a:tc>
               </a:tr>
-              <a:tr h="700000">
+              <a:tr h="640000">
                 <a:tc>
                   <a:txBody>
                     <a:bodyPr/>
@@ -19585,13 +19657,13 @@
                         <a:buNone/>
                       </a:pPr>
                       <a:r>
-                        <a:rPr b="1" lang="en-US" sz="950">
+                        <a:rPr lang="en-US" sz="900">
                           <a:latin typeface="Times New Roman"/>
                           <a:ea typeface="Times New Roman"/>
                           <a:cs typeface="Times New Roman"/>
                           <a:sym typeface="Times New Roman"/>
                         </a:rPr>
-                        <a:t>REP / BM25 [2] (ASE 2011)</a:t>
+                        <a:t>“Towards More Accurate Retrieval of Duplicate Bug Reports” (REP) [2], ASE 2011</a:t>
                       </a:r>
                     </a:p>
                   </a:txBody>
@@ -19649,7 +19721,7 @@
                         <a:buNone/>
                       </a:pPr>
                       <a:r>
-                        <a:rPr lang="en-US" sz="950">
+                        <a:rPr lang="en-US" sz="900">
                           <a:latin typeface="Times New Roman"/>
                           <a:ea typeface="Times New Roman"/>
                           <a:cs typeface="Times New Roman"/>
@@ -19713,7 +19785,7 @@
                         <a:buNone/>
                       </a:pPr>
                       <a:r>
-                        <a:rPr lang="en-US" sz="950">
+                        <a:rPr lang="en-US" sz="900">
                           <a:latin typeface="Times New Roman"/>
                           <a:ea typeface="Times New Roman"/>
                           <a:cs typeface="Times New Roman"/>
@@ -19777,13 +19849,13 @@
                         <a:buNone/>
                       </a:pPr>
                       <a:r>
-                        <a:rPr lang="en-US" sz="950">
+                        <a:rPr lang="en-US" sz="900">
                           <a:latin typeface="Times New Roman"/>
                           <a:ea typeface="Times New Roman"/>
                           <a:cs typeface="Times New Roman"/>
                           <a:sym typeface="Times New Roman"/>
                         </a:rPr>
-                        <a:t>Misses paraphrases (“can't log in” vs “sign-in fails”)</a:t>
+                        <a:t>Misses paraphrases; top-5 hit 0.43–0.44 vs our 0.46–0.56</a:t>
                       </a:r>
                     </a:p>
                   </a:txBody>
@@ -19841,7 +19913,7 @@
                         <a:buNone/>
                       </a:pPr>
                       <a:r>
-                        <a:rPr lang="en-US" sz="950">
+                        <a:rPr lang="en-US" sz="900">
                           <a:latin typeface="Times New Roman"/>
                           <a:ea typeface="Times New Roman"/>
                           <a:cs typeface="Times New Roman"/>
@@ -19891,7 +19963,7 @@
                   </a:tcPr>
                 </a:tc>
               </a:tr>
-              <a:tr h="700000">
+              <a:tr h="640000">
                 <a:tc>
                   <a:txBody>
                     <a:bodyPr/>
@@ -19907,13 +19979,13 @@
                         <a:buNone/>
                       </a:pPr>
                       <a:r>
-                        <a:rPr b="1" lang="en-US" sz="950">
+                        <a:rPr lang="en-US" sz="900">
                           <a:latin typeface="Times New Roman"/>
                           <a:ea typeface="Times New Roman"/>
                           <a:cs typeface="Times New Roman"/>
                           <a:sym typeface="Times New Roman"/>
                         </a:rPr>
-                        <a:t>Sentence-BERT [3] (EMNLP 2019)</a:t>
+                        <a:t>“Sentence-BERT: Sentence Embeddings using Siamese BERT-Networks” [3], EMNLP 2019</a:t>
                       </a:r>
                     </a:p>
                   </a:txBody>
@@ -19971,7 +20043,7 @@
                         <a:buNone/>
                       </a:pPr>
                       <a:r>
-                        <a:rPr lang="en-US" sz="950">
+                        <a:rPr lang="en-US" sz="900">
                           <a:latin typeface="Times New Roman"/>
                           <a:ea typeface="Times New Roman"/>
                           <a:cs typeface="Times New Roman"/>
@@ -20035,7 +20107,7 @@
                         <a:buNone/>
                       </a:pPr>
                       <a:r>
-                        <a:rPr lang="en-US" sz="950">
+                        <a:rPr lang="en-US" sz="900">
                           <a:latin typeface="Times New Roman"/>
                           <a:ea typeface="Times New Roman"/>
                           <a:cs typeface="Times New Roman"/>
@@ -20099,13 +20171,13 @@
                         <a:buNone/>
                       </a:pPr>
                       <a:r>
-                        <a:rPr lang="en-US" sz="950">
+                        <a:rPr lang="en-US" sz="900">
                           <a:latin typeface="Times New Roman"/>
                           <a:ea typeface="Times New Roman"/>
                           <a:cs typeface="Times New Roman"/>
                           <a:sym typeface="Times New Roman"/>
                         </a:rPr>
-                        <a:t>One cut cannot be both safe and inclusive (F1 ≈ 0.10)</a:t>
+                        <a:t>One cut cannot be safe and inclusive (F1 ≈ 0.10)</a:t>
                       </a:r>
                     </a:p>
                   </a:txBody>
@@ -20163,7 +20235,7 @@
                         <a:buNone/>
                       </a:pPr>
                       <a:r>
-                        <a:rPr lang="en-US" sz="950">
+                        <a:rPr lang="en-US" sz="900">
                           <a:latin typeface="Times New Roman"/>
                           <a:ea typeface="Times New Roman"/>
                           <a:cs typeface="Times New Roman"/>
@@ -20213,7 +20285,7 @@
                   </a:tcPr>
                 </a:tc>
               </a:tr>
-              <a:tr h="700000">
+              <a:tr h="640000">
                 <a:tc>
                   <a:txBody>
                     <a:bodyPr/>
@@ -20229,13 +20301,13 @@
                         <a:buNone/>
                       </a:pPr>
                       <a:r>
-                        <a:rPr b="1" lang="en-US" sz="950">
+                        <a:rPr lang="en-US" sz="900">
                           <a:latin typeface="Times New Roman"/>
                           <a:ea typeface="Times New Roman"/>
                           <a:cs typeface="Times New Roman"/>
                           <a:sym typeface="Times New Roman"/>
                         </a:rPr>
-                        <a:t>BERT cross-encoder [4] (NAACL 2019)</a:t>
+                        <a:t>“BERTopic: Neural Topic Modeling with a Class-Based TF-IDF Procedure” [4], 2022</a:t>
                       </a:r>
                     </a:p>
                   </a:txBody>
@@ -20293,13 +20365,13 @@
                         <a:buNone/>
                       </a:pPr>
                       <a:r>
-                        <a:rPr lang="en-US" sz="950">
+                        <a:rPr lang="en-US" sz="900">
                           <a:latin typeface="Times New Roman"/>
                           <a:ea typeface="Times New Roman"/>
                           <a:cs typeface="Times New Roman"/>
                           <a:sym typeface="Times New Roman"/>
                         </a:rPr>
-                        <a:t>Fine-tuned pair classifier</a:t>
+                        <a:t>Embeddings + UMAP + HDBSCAN topics</a:t>
                       </a:r>
                     </a:p>
                   </a:txBody>
@@ -20357,13 +20429,13 @@
                         <a:buNone/>
                       </a:pPr>
                       <a:r>
-                        <a:rPr lang="en-US" sz="950">
+                        <a:rPr lang="en-US" sz="900">
                           <a:latin typeface="Times New Roman"/>
                           <a:ea typeface="Times New Roman"/>
                           <a:cs typeface="Times New Roman"/>
                           <a:sym typeface="Times New Roman"/>
                         </a:rPr>
-                        <a:t>Score cut 0.4834, tuned on 110 labelled pairs</a:t>
+                        <a:t>Library defaults (minimum topic size)</a:t>
                       </a:r>
                     </a:p>
                   </a:txBody>
@@ -20421,13 +20493,13 @@
                         <a:buNone/>
                       </a:pPr>
                       <a:r>
-                        <a:rPr lang="en-US" sz="950">
+                        <a:rPr lang="en-US" sz="900">
                           <a:latin typeface="Times New Roman"/>
                           <a:ea typeface="Times New Roman"/>
                           <a:cs typeface="Times New Roman"/>
                           <a:sym typeface="Times New Roman"/>
                         </a:rPr>
-                        <a:t>Pair scores do not hold in a live stream (P 0.38)</a:t>
+                        <a:t>Topics are themes, not problems (precision 0.16)</a:t>
                       </a:r>
                     </a:p>
                   </a:txBody>
@@ -20485,13 +20557,13 @@
                         <a:buNone/>
                       </a:pPr>
                       <a:r>
-                        <a:rPr lang="en-US" sz="950">
+                        <a:rPr lang="en-US" sz="900">
                           <a:latin typeface="Times New Roman"/>
                           <a:ea typeface="Times New Roman"/>
                           <a:cs typeface="Times New Roman"/>
                           <a:sym typeface="Times New Roman"/>
                         </a:rPr>
-                        <a:t>Band calibrated on the stream + LLM judge (P 0.80)</a:t>
+                        <a:t>Problem-level cases; topics only for routing</a:t>
                       </a:r>
                     </a:p>
                   </a:txBody>
@@ -21010,7 +21082,7 @@
                 <a:cs typeface="Times New Roman"/>
                 <a:sym typeface="Times New Roman"/>
               </a:rPr>
-              <a:t>Measure customer sentiment with two AI models.</a:t>
+              <a:t>Measure customer sentiment using the RoBERTa model.</a:t>
             </a:r>
             <a:endParaRPr>
               <a:solidFill>

</xml_diff>

<commit_message>
Deck: live t_low rows in the calibration table
</commit_message>
<xml_diff>
--- a/reports/ppt/InsightDesk_final.pptx
+++ b/reports/ppt/InsightDesk_final.pptx
@@ -19461,7 +19461,7 @@
                           <a:cs typeface="Times New Roman"/>
                           <a:sym typeface="Times New Roman"/>
                         </a:rPr>
-                        <a:t>Note</a:t>
+                        <a:t>LLM share</a:t>
                       </a:r>
                     </a:p>
                   </a:txBody>
@@ -19505,7 +19505,7 @@
                   </a:tcPr>
                 </a:tc>
               </a:tr>
-              <a:tr h="420000">
+              <a:tr h="360000">
                 <a:tc>
                   <a:txBody>
                     <a:bodyPr/>
@@ -19591,7 +19591,7 @@
                           <a:cs typeface="Times New Roman"/>
                           <a:sym typeface="Times New Roman"/>
                         </a:rPr>
-                        <a:t>20th percentile of duplicates</a:t>
+                        <a:t>20th pct. of duplicates</a:t>
                       </a:r>
                     </a:p>
                   </a:txBody>
@@ -19911,7 +19911,7 @@
                           <a:cs typeface="Times New Roman"/>
                           <a:sym typeface="Times New Roman"/>
                         </a:rPr>
-                        <a:t>exact</a:t>
+                        <a:t>86%</a:t>
                       </a:r>
                     </a:p>
                   </a:txBody>
@@ -19955,7 +19955,7 @@
                   </a:tcPr>
                 </a:tc>
               </a:tr>
-              <a:tr h="420000">
+              <a:tr h="360000">
                 <a:tc>
                   <a:txBody>
                     <a:bodyPr/>
@@ -19977,7 +19977,71 @@
                           <a:cs typeface="Times New Roman"/>
                           <a:sym typeface="Times New Roman"/>
                         </a:rPr>
-                        <a:t>t_high lowered by 0.03</a:t>
+                        <a:t>t_low raised by 0.04</a:t>
+                      </a:r>
+                    </a:p>
+                  </a:txBody>
+                  <a:tcPr marT="45720" marB="45720" marR="45720" marL="45720">
+                    <a:lnL cap="flat" cmpd="sng" w="19050">
+                      <a:solidFill>
+                        <a:srgbClr val="262626"/>
+                      </a:solidFill>
+                      <a:prstDash val="solid"/>
+                      <a:round/>
+                      <a:headEnd len="sm" w="sm" type="none"/>
+                      <a:tailEnd len="sm" w="sm" type="none"/>
+                    </a:lnL>
+                    <a:lnR cap="flat" cmpd="sng" w="19050">
+                      <a:solidFill>
+                        <a:srgbClr val="262626"/>
+                      </a:solidFill>
+                      <a:prstDash val="solid"/>
+                      <a:round/>
+                      <a:headEnd len="sm" w="sm" type="none"/>
+                      <a:tailEnd len="sm" w="sm" type="none"/>
+                    </a:lnR>
+                    <a:lnT cap="flat" cmpd="sng" w="19050">
+                      <a:solidFill>
+                        <a:srgbClr val="262626"/>
+                      </a:solidFill>
+                      <a:prstDash val="solid"/>
+                      <a:round/>
+                      <a:headEnd len="sm" w="sm" type="none"/>
+                      <a:tailEnd len="sm" w="sm" type="none"/>
+                    </a:lnT>
+                    <a:lnB cap="flat" cmpd="sng" w="19050">
+                      <a:solidFill>
+                        <a:srgbClr val="262626"/>
+                      </a:solidFill>
+                      <a:prstDash val="solid"/>
+                      <a:round/>
+                      <a:headEnd len="sm" w="sm" type="none"/>
+                      <a:tailEnd len="sm" w="sm" type="none"/>
+                    </a:lnB>
+                  </a:tcPr>
+                </a:tc>
+                <a:tc>
+                  <a:txBody>
+                    <a:bodyPr/>
+                    <a:lstStyle/>
+                    <a:p>
+                      <a:pPr indent="0" lvl="0" marL="0" rtl="0" algn="l">
+                        <a:spcBef>
+                          <a:spcPts val="0"/>
+                        </a:spcBef>
+                        <a:spcAft>
+                          <a:spcPts val="0"/>
+                        </a:spcAft>
+                        <a:buNone/>
+                      </a:pPr>
+                      <a:r>
+                        <a:rPr lang="en-US" sz="900">
+                          <a:latin typeface="Times New Roman"/>
+                          <a:ea typeface="Times New Roman"/>
+                          <a:cs typeface="Times New Roman"/>
+                          <a:sym typeface="Times New Roman"/>
+                        </a:rPr>
+                        <a:t>+ 0.04</a:t>
                       </a:r>
                     </a:p>
                   </a:txBody>
@@ -20105,7 +20169,7 @@
                           <a:cs typeface="Times New Roman"/>
                           <a:sym typeface="Times New Roman"/>
                         </a:rPr>
-                        <a:t>− 0.03</a:t>
+                        <a:t>0.803</a:t>
                       </a:r>
                     </a:p>
                   </a:txBody>
@@ -20169,7 +20233,7 @@
                           <a:cs typeface="Times New Roman"/>
                           <a:sym typeface="Times New Roman"/>
                         </a:rPr>
-                        <a:t>0.831</a:t>
+                        <a:t>0.256</a:t>
                       </a:r>
                     </a:p>
                   </a:txBody>
@@ -20233,7 +20297,7 @@
                           <a:cs typeface="Times New Roman"/>
                           <a:sym typeface="Times New Roman"/>
                         </a:rPr>
-                        <a:t>0.233</a:t>
+                        <a:t>0.388</a:t>
                       </a:r>
                     </a:p>
                   </a:txBody>
@@ -20297,7 +20361,73 @@
                           <a:cs typeface="Times New Roman"/>
                           <a:sym typeface="Times New Roman"/>
                         </a:rPr>
-                        <a:t>0.364</a:t>
+                        <a:t>81%</a:t>
+                      </a:r>
+                    </a:p>
+                  </a:txBody>
+                  <a:tcPr marT="45720" marB="45720" marR="45720" marL="45720">
+                    <a:lnL cap="flat" cmpd="sng" w="19050">
+                      <a:solidFill>
+                        <a:srgbClr val="262626"/>
+                      </a:solidFill>
+                      <a:prstDash val="solid"/>
+                      <a:round/>
+                      <a:headEnd len="sm" w="sm" type="none"/>
+                      <a:tailEnd len="sm" w="sm" type="none"/>
+                    </a:lnL>
+                    <a:lnR cap="flat" cmpd="sng" w="19050">
+                      <a:solidFill>
+                        <a:srgbClr val="262626"/>
+                      </a:solidFill>
+                      <a:prstDash val="solid"/>
+                      <a:round/>
+                      <a:headEnd len="sm" w="sm" type="none"/>
+                      <a:tailEnd len="sm" w="sm" type="none"/>
+                    </a:lnR>
+                    <a:lnT cap="flat" cmpd="sng" w="19050">
+                      <a:solidFill>
+                        <a:srgbClr val="262626"/>
+                      </a:solidFill>
+                      <a:prstDash val="solid"/>
+                      <a:round/>
+                      <a:headEnd len="sm" w="sm" type="none"/>
+                      <a:tailEnd len="sm" w="sm" type="none"/>
+                    </a:lnT>
+                    <a:lnB cap="flat" cmpd="sng" w="19050">
+                      <a:solidFill>
+                        <a:srgbClr val="262626"/>
+                      </a:solidFill>
+                      <a:prstDash val="solid"/>
+                      <a:round/>
+                      <a:headEnd len="sm" w="sm" type="none"/>
+                      <a:tailEnd len="sm" w="sm" type="none"/>
+                    </a:lnB>
+                  </a:tcPr>
+                </a:tc>
+              </a:tr>
+              <a:tr h="360000">
+                <a:tc>
+                  <a:txBody>
+                    <a:bodyPr/>
+                    <a:lstStyle/>
+                    <a:p>
+                      <a:pPr indent="0" lvl="0" marL="0" rtl="0" algn="l">
+                        <a:spcBef>
+                          <a:spcPts val="0"/>
+                        </a:spcBef>
+                        <a:spcAft>
+                          <a:spcPts val="0"/>
+                        </a:spcAft>
+                        <a:buNone/>
+                      </a:pPr>
+                      <a:r>
+                        <a:rPr lang="en-US" sz="900">
+                          <a:latin typeface="Times New Roman"/>
+                          <a:ea typeface="Times New Roman"/>
+                          <a:cs typeface="Times New Roman"/>
+                          <a:sym typeface="Times New Roman"/>
+                        </a:rPr>
+                        <a:t>t_low raised by 0.09</a:t>
                       </a:r>
                     </a:p>
                   </a:txBody>
@@ -20361,7 +20491,7 @@
                           <a:cs typeface="Times New Roman"/>
                           <a:sym typeface="Times New Roman"/>
                         </a:rPr>
-                        <a:t>robust</a:t>
+                        <a:t>+ 0.09</a:t>
                       </a:r>
                     </a:p>
                   </a:txBody>
@@ -20404,8 +20534,778 @@
                     </a:lnB>
                   </a:tcPr>
                 </a:tc>
+                <a:tc>
+                  <a:txBody>
+                    <a:bodyPr/>
+                    <a:lstStyle/>
+                    <a:p>
+                      <a:pPr indent="0" lvl="0" marL="0" rtl="0" algn="l">
+                        <a:spcBef>
+                          <a:spcPts val="0"/>
+                        </a:spcBef>
+                        <a:spcAft>
+                          <a:spcPts val="0"/>
+                        </a:spcAft>
+                        <a:buNone/>
+                      </a:pPr>
+                      <a:r>
+                        <a:rPr lang="en-US" sz="900">
+                          <a:latin typeface="Times New Roman"/>
+                          <a:ea typeface="Times New Roman"/>
+                          <a:cs typeface="Times New Roman"/>
+                          <a:sym typeface="Times New Roman"/>
+                        </a:rPr>
+                        <a:t>same</a:t>
+                      </a:r>
+                    </a:p>
+                  </a:txBody>
+                  <a:tcPr marT="45720" marB="45720" marR="45720" marL="45720">
+                    <a:lnL cap="flat" cmpd="sng" w="19050">
+                      <a:solidFill>
+                        <a:srgbClr val="262626"/>
+                      </a:solidFill>
+                      <a:prstDash val="solid"/>
+                      <a:round/>
+                      <a:headEnd len="sm" w="sm" type="none"/>
+                      <a:tailEnd len="sm" w="sm" type="none"/>
+                    </a:lnL>
+                    <a:lnR cap="flat" cmpd="sng" w="19050">
+                      <a:solidFill>
+                        <a:srgbClr val="262626"/>
+                      </a:solidFill>
+                      <a:prstDash val="solid"/>
+                      <a:round/>
+                      <a:headEnd len="sm" w="sm" type="none"/>
+                      <a:tailEnd len="sm" w="sm" type="none"/>
+                    </a:lnR>
+                    <a:lnT cap="flat" cmpd="sng" w="19050">
+                      <a:solidFill>
+                        <a:srgbClr val="262626"/>
+                      </a:solidFill>
+                      <a:prstDash val="solid"/>
+                      <a:round/>
+                      <a:headEnd len="sm" w="sm" type="none"/>
+                      <a:tailEnd len="sm" w="sm" type="none"/>
+                    </a:lnT>
+                    <a:lnB cap="flat" cmpd="sng" w="19050">
+                      <a:solidFill>
+                        <a:srgbClr val="262626"/>
+                      </a:solidFill>
+                      <a:prstDash val="solid"/>
+                      <a:round/>
+                      <a:headEnd len="sm" w="sm" type="none"/>
+                      <a:tailEnd len="sm" w="sm" type="none"/>
+                    </a:lnB>
+                  </a:tcPr>
+                </a:tc>
+                <a:tc>
+                  <a:txBody>
+                    <a:bodyPr/>
+                    <a:lstStyle/>
+                    <a:p>
+                      <a:pPr indent="0" lvl="0" marL="0" rtl="0" algn="l">
+                        <a:spcBef>
+                          <a:spcPts val="0"/>
+                        </a:spcBef>
+                        <a:spcAft>
+                          <a:spcPts val="0"/>
+                        </a:spcAft>
+                        <a:buNone/>
+                      </a:pPr>
+                      <a:r>
+                        <a:rPr lang="en-US" sz="900">
+                          <a:latin typeface="Times New Roman"/>
+                          <a:ea typeface="Times New Roman"/>
+                          <a:cs typeface="Times New Roman"/>
+                          <a:sym typeface="Times New Roman"/>
+                        </a:rPr>
+                        <a:t>0.867</a:t>
+                      </a:r>
+                    </a:p>
+                  </a:txBody>
+                  <a:tcPr marT="45720" marB="45720" marR="45720" marL="45720">
+                    <a:lnL cap="flat" cmpd="sng" w="19050">
+                      <a:solidFill>
+                        <a:srgbClr val="262626"/>
+                      </a:solidFill>
+                      <a:prstDash val="solid"/>
+                      <a:round/>
+                      <a:headEnd len="sm" w="sm" type="none"/>
+                      <a:tailEnd len="sm" w="sm" type="none"/>
+                    </a:lnL>
+                    <a:lnR cap="flat" cmpd="sng" w="19050">
+                      <a:solidFill>
+                        <a:srgbClr val="262626"/>
+                      </a:solidFill>
+                      <a:prstDash val="solid"/>
+                      <a:round/>
+                      <a:headEnd len="sm" w="sm" type="none"/>
+                      <a:tailEnd len="sm" w="sm" type="none"/>
+                    </a:lnR>
+                    <a:lnT cap="flat" cmpd="sng" w="19050">
+                      <a:solidFill>
+                        <a:srgbClr val="262626"/>
+                      </a:solidFill>
+                      <a:prstDash val="solid"/>
+                      <a:round/>
+                      <a:headEnd len="sm" w="sm" type="none"/>
+                      <a:tailEnd len="sm" w="sm" type="none"/>
+                    </a:lnT>
+                    <a:lnB cap="flat" cmpd="sng" w="19050">
+                      <a:solidFill>
+                        <a:srgbClr val="262626"/>
+                      </a:solidFill>
+                      <a:prstDash val="solid"/>
+                      <a:round/>
+                      <a:headEnd len="sm" w="sm" type="none"/>
+                      <a:tailEnd len="sm" w="sm" type="none"/>
+                    </a:lnB>
+                  </a:tcPr>
+                </a:tc>
+                <a:tc>
+                  <a:txBody>
+                    <a:bodyPr/>
+                    <a:lstStyle/>
+                    <a:p>
+                      <a:pPr indent="0" lvl="0" marL="0" rtl="0" algn="l">
+                        <a:spcBef>
+                          <a:spcPts val="0"/>
+                        </a:spcBef>
+                        <a:spcAft>
+                          <a:spcPts val="0"/>
+                        </a:spcAft>
+                        <a:buNone/>
+                      </a:pPr>
+                      <a:r>
+                        <a:rPr lang="en-US" sz="900">
+                          <a:latin typeface="Times New Roman"/>
+                          <a:ea typeface="Times New Roman"/>
+                          <a:cs typeface="Times New Roman"/>
+                          <a:sym typeface="Times New Roman"/>
+                        </a:rPr>
+                        <a:t>0.264</a:t>
+                      </a:r>
+                    </a:p>
+                  </a:txBody>
+                  <a:tcPr marT="45720" marB="45720" marR="45720" marL="45720">
+                    <a:lnL cap="flat" cmpd="sng" w="19050">
+                      <a:solidFill>
+                        <a:srgbClr val="262626"/>
+                      </a:solidFill>
+                      <a:prstDash val="solid"/>
+                      <a:round/>
+                      <a:headEnd len="sm" w="sm" type="none"/>
+                      <a:tailEnd len="sm" w="sm" type="none"/>
+                    </a:lnL>
+                    <a:lnR cap="flat" cmpd="sng" w="19050">
+                      <a:solidFill>
+                        <a:srgbClr val="262626"/>
+                      </a:solidFill>
+                      <a:prstDash val="solid"/>
+                      <a:round/>
+                      <a:headEnd len="sm" w="sm" type="none"/>
+                      <a:tailEnd len="sm" w="sm" type="none"/>
+                    </a:lnR>
+                    <a:lnT cap="flat" cmpd="sng" w="19050">
+                      <a:solidFill>
+                        <a:srgbClr val="262626"/>
+                      </a:solidFill>
+                      <a:prstDash val="solid"/>
+                      <a:round/>
+                      <a:headEnd len="sm" w="sm" type="none"/>
+                      <a:tailEnd len="sm" w="sm" type="none"/>
+                    </a:lnT>
+                    <a:lnB cap="flat" cmpd="sng" w="19050">
+                      <a:solidFill>
+                        <a:srgbClr val="262626"/>
+                      </a:solidFill>
+                      <a:prstDash val="solid"/>
+                      <a:round/>
+                      <a:headEnd len="sm" w="sm" type="none"/>
+                      <a:tailEnd len="sm" w="sm" type="none"/>
+                    </a:lnB>
+                  </a:tcPr>
+                </a:tc>
+                <a:tc>
+                  <a:txBody>
+                    <a:bodyPr/>
+                    <a:lstStyle/>
+                    <a:p>
+                      <a:pPr indent="0" lvl="0" marL="0" rtl="0" algn="l">
+                        <a:spcBef>
+                          <a:spcPts val="0"/>
+                        </a:spcBef>
+                        <a:spcAft>
+                          <a:spcPts val="0"/>
+                        </a:spcAft>
+                        <a:buNone/>
+                      </a:pPr>
+                      <a:r>
+                        <a:rPr lang="en-US" sz="900">
+                          <a:latin typeface="Times New Roman"/>
+                          <a:ea typeface="Times New Roman"/>
+                          <a:cs typeface="Times New Roman"/>
+                          <a:sym typeface="Times New Roman"/>
+                        </a:rPr>
+                        <a:t>0.404</a:t>
+                      </a:r>
+                    </a:p>
+                  </a:txBody>
+                  <a:tcPr marT="45720" marB="45720" marR="45720" marL="45720">
+                    <a:lnL cap="flat" cmpd="sng" w="19050">
+                      <a:solidFill>
+                        <a:srgbClr val="262626"/>
+                      </a:solidFill>
+                      <a:prstDash val="solid"/>
+                      <a:round/>
+                      <a:headEnd len="sm" w="sm" type="none"/>
+                      <a:tailEnd len="sm" w="sm" type="none"/>
+                    </a:lnL>
+                    <a:lnR cap="flat" cmpd="sng" w="19050">
+                      <a:solidFill>
+                        <a:srgbClr val="262626"/>
+                      </a:solidFill>
+                      <a:prstDash val="solid"/>
+                      <a:round/>
+                      <a:headEnd len="sm" w="sm" type="none"/>
+                      <a:tailEnd len="sm" w="sm" type="none"/>
+                    </a:lnR>
+                    <a:lnT cap="flat" cmpd="sng" w="19050">
+                      <a:solidFill>
+                        <a:srgbClr val="262626"/>
+                      </a:solidFill>
+                      <a:prstDash val="solid"/>
+                      <a:round/>
+                      <a:headEnd len="sm" w="sm" type="none"/>
+                      <a:tailEnd len="sm" w="sm" type="none"/>
+                    </a:lnT>
+                    <a:lnB cap="flat" cmpd="sng" w="19050">
+                      <a:solidFill>
+                        <a:srgbClr val="262626"/>
+                      </a:solidFill>
+                      <a:prstDash val="solid"/>
+                      <a:round/>
+                      <a:headEnd len="sm" w="sm" type="none"/>
+                      <a:tailEnd len="sm" w="sm" type="none"/>
+                    </a:lnB>
+                  </a:tcPr>
+                </a:tc>
+                <a:tc>
+                  <a:txBody>
+                    <a:bodyPr/>
+                    <a:lstStyle/>
+                    <a:p>
+                      <a:pPr indent="0" lvl="0" marL="0" rtl="0" algn="l">
+                        <a:spcBef>
+                          <a:spcPts val="0"/>
+                        </a:spcBef>
+                        <a:spcAft>
+                          <a:spcPts val="0"/>
+                        </a:spcAft>
+                        <a:buNone/>
+                      </a:pPr>
+                      <a:r>
+                        <a:rPr lang="en-US" sz="900">
+                          <a:latin typeface="Times New Roman"/>
+                          <a:ea typeface="Times New Roman"/>
+                          <a:cs typeface="Times New Roman"/>
+                          <a:sym typeface="Times New Roman"/>
+                        </a:rPr>
+                        <a:t>71%</a:t>
+                      </a:r>
+                    </a:p>
+                  </a:txBody>
+                  <a:tcPr marT="45720" marB="45720" marR="45720" marL="45720">
+                    <a:lnL cap="flat" cmpd="sng" w="19050">
+                      <a:solidFill>
+                        <a:srgbClr val="262626"/>
+                      </a:solidFill>
+                      <a:prstDash val="solid"/>
+                      <a:round/>
+                      <a:headEnd len="sm" w="sm" type="none"/>
+                      <a:tailEnd len="sm" w="sm" type="none"/>
+                    </a:lnL>
+                    <a:lnR cap="flat" cmpd="sng" w="19050">
+                      <a:solidFill>
+                        <a:srgbClr val="262626"/>
+                      </a:solidFill>
+                      <a:prstDash val="solid"/>
+                      <a:round/>
+                      <a:headEnd len="sm" w="sm" type="none"/>
+                      <a:tailEnd len="sm" w="sm" type="none"/>
+                    </a:lnR>
+                    <a:lnT cap="flat" cmpd="sng" w="19050">
+                      <a:solidFill>
+                        <a:srgbClr val="262626"/>
+                      </a:solidFill>
+                      <a:prstDash val="solid"/>
+                      <a:round/>
+                      <a:headEnd len="sm" w="sm" type="none"/>
+                      <a:tailEnd len="sm" w="sm" type="none"/>
+                    </a:lnT>
+                    <a:lnB cap="flat" cmpd="sng" w="19050">
+                      <a:solidFill>
+                        <a:srgbClr val="262626"/>
+                      </a:solidFill>
+                      <a:prstDash val="solid"/>
+                      <a:round/>
+                      <a:headEnd len="sm" w="sm" type="none"/>
+                      <a:tailEnd len="sm" w="sm" type="none"/>
+                    </a:lnB>
+                  </a:tcPr>
+                </a:tc>
               </a:tr>
-              <a:tr h="420000">
+              <a:tr h="360000">
+                <a:tc>
+                  <a:txBody>
+                    <a:bodyPr/>
+                    <a:lstStyle/>
+                    <a:p>
+                      <a:pPr indent="0" lvl="0" marL="0" rtl="0" algn="l">
+                        <a:spcBef>
+                          <a:spcPts val="0"/>
+                        </a:spcBef>
+                        <a:spcAft>
+                          <a:spcPts val="0"/>
+                        </a:spcAft>
+                        <a:buNone/>
+                      </a:pPr>
+                      <a:r>
+                        <a:rPr lang="en-US" sz="900">
+                          <a:latin typeface="Times New Roman"/>
+                          <a:ea typeface="Times New Roman"/>
+                          <a:cs typeface="Times New Roman"/>
+                          <a:sym typeface="Times New Roman"/>
+                        </a:rPr>
+                        <a:t>t_low raised by 0.14</a:t>
+                      </a:r>
+                    </a:p>
+                  </a:txBody>
+                  <a:tcPr marT="45720" marB="45720" marR="45720" marL="45720">
+                    <a:lnL cap="flat" cmpd="sng" w="19050">
+                      <a:solidFill>
+                        <a:srgbClr val="262626"/>
+                      </a:solidFill>
+                      <a:prstDash val="solid"/>
+                      <a:round/>
+                      <a:headEnd len="sm" w="sm" type="none"/>
+                      <a:tailEnd len="sm" w="sm" type="none"/>
+                    </a:lnL>
+                    <a:lnR cap="flat" cmpd="sng" w="19050">
+                      <a:solidFill>
+                        <a:srgbClr val="262626"/>
+                      </a:solidFill>
+                      <a:prstDash val="solid"/>
+                      <a:round/>
+                      <a:headEnd len="sm" w="sm" type="none"/>
+                      <a:tailEnd len="sm" w="sm" type="none"/>
+                    </a:lnR>
+                    <a:lnT cap="flat" cmpd="sng" w="19050">
+                      <a:solidFill>
+                        <a:srgbClr val="262626"/>
+                      </a:solidFill>
+                      <a:prstDash val="solid"/>
+                      <a:round/>
+                      <a:headEnd len="sm" w="sm" type="none"/>
+                      <a:tailEnd len="sm" w="sm" type="none"/>
+                    </a:lnT>
+                    <a:lnB cap="flat" cmpd="sng" w="19050">
+                      <a:solidFill>
+                        <a:srgbClr val="262626"/>
+                      </a:solidFill>
+                      <a:prstDash val="solid"/>
+                      <a:round/>
+                      <a:headEnd len="sm" w="sm" type="none"/>
+                      <a:tailEnd len="sm" w="sm" type="none"/>
+                    </a:lnB>
+                  </a:tcPr>
+                </a:tc>
+                <a:tc>
+                  <a:txBody>
+                    <a:bodyPr/>
+                    <a:lstStyle/>
+                    <a:p>
+                      <a:pPr indent="0" lvl="0" marL="0" rtl="0" algn="l">
+                        <a:spcBef>
+                          <a:spcPts val="0"/>
+                        </a:spcBef>
+                        <a:spcAft>
+                          <a:spcPts val="0"/>
+                        </a:spcAft>
+                        <a:buNone/>
+                      </a:pPr>
+                      <a:r>
+                        <a:rPr lang="en-US" sz="900">
+                          <a:latin typeface="Times New Roman"/>
+                          <a:ea typeface="Times New Roman"/>
+                          <a:cs typeface="Times New Roman"/>
+                          <a:sym typeface="Times New Roman"/>
+                        </a:rPr>
+                        <a:t>+ 0.14</a:t>
+                      </a:r>
+                    </a:p>
+                  </a:txBody>
+                  <a:tcPr marT="45720" marB="45720" marR="45720" marL="45720">
+                    <a:lnL cap="flat" cmpd="sng" w="19050">
+                      <a:solidFill>
+                        <a:srgbClr val="262626"/>
+                      </a:solidFill>
+                      <a:prstDash val="solid"/>
+                      <a:round/>
+                      <a:headEnd len="sm" w="sm" type="none"/>
+                      <a:tailEnd len="sm" w="sm" type="none"/>
+                    </a:lnL>
+                    <a:lnR cap="flat" cmpd="sng" w="19050">
+                      <a:solidFill>
+                        <a:srgbClr val="262626"/>
+                      </a:solidFill>
+                      <a:prstDash val="solid"/>
+                      <a:round/>
+                      <a:headEnd len="sm" w="sm" type="none"/>
+                      <a:tailEnd len="sm" w="sm" type="none"/>
+                    </a:lnR>
+                    <a:lnT cap="flat" cmpd="sng" w="19050">
+                      <a:solidFill>
+                        <a:srgbClr val="262626"/>
+                      </a:solidFill>
+                      <a:prstDash val="solid"/>
+                      <a:round/>
+                      <a:headEnd len="sm" w="sm" type="none"/>
+                      <a:tailEnd len="sm" w="sm" type="none"/>
+                    </a:lnT>
+                    <a:lnB cap="flat" cmpd="sng" w="19050">
+                      <a:solidFill>
+                        <a:srgbClr val="262626"/>
+                      </a:solidFill>
+                      <a:prstDash val="solid"/>
+                      <a:round/>
+                      <a:headEnd len="sm" w="sm" type="none"/>
+                      <a:tailEnd len="sm" w="sm" type="none"/>
+                    </a:lnB>
+                  </a:tcPr>
+                </a:tc>
+                <a:tc>
+                  <a:txBody>
+                    <a:bodyPr/>
+                    <a:lstStyle/>
+                    <a:p>
+                      <a:pPr indent="0" lvl="0" marL="0" rtl="0" algn="l">
+                        <a:spcBef>
+                          <a:spcPts val="0"/>
+                        </a:spcBef>
+                        <a:spcAft>
+                          <a:spcPts val="0"/>
+                        </a:spcAft>
+                        <a:buNone/>
+                      </a:pPr>
+                      <a:r>
+                        <a:rPr lang="en-US" sz="900">
+                          <a:latin typeface="Times New Roman"/>
+                          <a:ea typeface="Times New Roman"/>
+                          <a:cs typeface="Times New Roman"/>
+                          <a:sym typeface="Times New Roman"/>
+                        </a:rPr>
+                        <a:t>same</a:t>
+                      </a:r>
+                    </a:p>
+                  </a:txBody>
+                  <a:tcPr marT="45720" marB="45720" marR="45720" marL="45720">
+                    <a:lnL cap="flat" cmpd="sng" w="19050">
+                      <a:solidFill>
+                        <a:srgbClr val="262626"/>
+                      </a:solidFill>
+                      <a:prstDash val="solid"/>
+                      <a:round/>
+                      <a:headEnd len="sm" w="sm" type="none"/>
+                      <a:tailEnd len="sm" w="sm" type="none"/>
+                    </a:lnL>
+                    <a:lnR cap="flat" cmpd="sng" w="19050">
+                      <a:solidFill>
+                        <a:srgbClr val="262626"/>
+                      </a:solidFill>
+                      <a:prstDash val="solid"/>
+                      <a:round/>
+                      <a:headEnd len="sm" w="sm" type="none"/>
+                      <a:tailEnd len="sm" w="sm" type="none"/>
+                    </a:lnR>
+                    <a:lnT cap="flat" cmpd="sng" w="19050">
+                      <a:solidFill>
+                        <a:srgbClr val="262626"/>
+                      </a:solidFill>
+                      <a:prstDash val="solid"/>
+                      <a:round/>
+                      <a:headEnd len="sm" w="sm" type="none"/>
+                      <a:tailEnd len="sm" w="sm" type="none"/>
+                    </a:lnT>
+                    <a:lnB cap="flat" cmpd="sng" w="19050">
+                      <a:solidFill>
+                        <a:srgbClr val="262626"/>
+                      </a:solidFill>
+                      <a:prstDash val="solid"/>
+                      <a:round/>
+                      <a:headEnd len="sm" w="sm" type="none"/>
+                      <a:tailEnd len="sm" w="sm" type="none"/>
+                    </a:lnB>
+                  </a:tcPr>
+                </a:tc>
+                <a:tc>
+                  <a:txBody>
+                    <a:bodyPr/>
+                    <a:lstStyle/>
+                    <a:p>
+                      <a:pPr indent="0" lvl="0" marL="0" rtl="0" algn="l">
+                        <a:spcBef>
+                          <a:spcPts val="0"/>
+                        </a:spcBef>
+                        <a:spcAft>
+                          <a:spcPts val="0"/>
+                        </a:spcAft>
+                        <a:buNone/>
+                      </a:pPr>
+                      <a:r>
+                        <a:rPr lang="en-US" sz="900">
+                          <a:latin typeface="Times New Roman"/>
+                          <a:ea typeface="Times New Roman"/>
+                          <a:cs typeface="Times New Roman"/>
+                          <a:sym typeface="Times New Roman"/>
+                        </a:rPr>
+                        <a:t>0.906</a:t>
+                      </a:r>
+                    </a:p>
+                  </a:txBody>
+                  <a:tcPr marT="45720" marB="45720" marR="45720" marL="45720">
+                    <a:lnL cap="flat" cmpd="sng" w="19050">
+                      <a:solidFill>
+                        <a:srgbClr val="262626"/>
+                      </a:solidFill>
+                      <a:prstDash val="solid"/>
+                      <a:round/>
+                      <a:headEnd len="sm" w="sm" type="none"/>
+                      <a:tailEnd len="sm" w="sm" type="none"/>
+                    </a:lnL>
+                    <a:lnR cap="flat" cmpd="sng" w="19050">
+                      <a:solidFill>
+                        <a:srgbClr val="262626"/>
+                      </a:solidFill>
+                      <a:prstDash val="solid"/>
+                      <a:round/>
+                      <a:headEnd len="sm" w="sm" type="none"/>
+                      <a:tailEnd len="sm" w="sm" type="none"/>
+                    </a:lnR>
+                    <a:lnT cap="flat" cmpd="sng" w="19050">
+                      <a:solidFill>
+                        <a:srgbClr val="262626"/>
+                      </a:solidFill>
+                      <a:prstDash val="solid"/>
+                      <a:round/>
+                      <a:headEnd len="sm" w="sm" type="none"/>
+                      <a:tailEnd len="sm" w="sm" type="none"/>
+                    </a:lnT>
+                    <a:lnB cap="flat" cmpd="sng" w="19050">
+                      <a:solidFill>
+                        <a:srgbClr val="262626"/>
+                      </a:solidFill>
+                      <a:prstDash val="solid"/>
+                      <a:round/>
+                      <a:headEnd len="sm" w="sm" type="none"/>
+                      <a:tailEnd len="sm" w="sm" type="none"/>
+                    </a:lnB>
+                  </a:tcPr>
+                </a:tc>
+                <a:tc>
+                  <a:txBody>
+                    <a:bodyPr/>
+                    <a:lstStyle/>
+                    <a:p>
+                      <a:pPr indent="0" lvl="0" marL="0" rtl="0" algn="l">
+                        <a:spcBef>
+                          <a:spcPts val="0"/>
+                        </a:spcBef>
+                        <a:spcAft>
+                          <a:spcPts val="0"/>
+                        </a:spcAft>
+                        <a:buNone/>
+                      </a:pPr>
+                      <a:r>
+                        <a:rPr lang="en-US" sz="900">
+                          <a:latin typeface="Times New Roman"/>
+                          <a:ea typeface="Times New Roman"/>
+                          <a:cs typeface="Times New Roman"/>
+                          <a:sym typeface="Times New Roman"/>
+                        </a:rPr>
+                        <a:t>0.260</a:t>
+                      </a:r>
+                    </a:p>
+                  </a:txBody>
+                  <a:tcPr marT="45720" marB="45720" marR="45720" marL="45720">
+                    <a:lnL cap="flat" cmpd="sng" w="19050">
+                      <a:solidFill>
+                        <a:srgbClr val="262626"/>
+                      </a:solidFill>
+                      <a:prstDash val="solid"/>
+                      <a:round/>
+                      <a:headEnd len="sm" w="sm" type="none"/>
+                      <a:tailEnd len="sm" w="sm" type="none"/>
+                    </a:lnL>
+                    <a:lnR cap="flat" cmpd="sng" w="19050">
+                      <a:solidFill>
+                        <a:srgbClr val="262626"/>
+                      </a:solidFill>
+                      <a:prstDash val="solid"/>
+                      <a:round/>
+                      <a:headEnd len="sm" w="sm" type="none"/>
+                      <a:tailEnd len="sm" w="sm" type="none"/>
+                    </a:lnR>
+                    <a:lnT cap="flat" cmpd="sng" w="19050">
+                      <a:solidFill>
+                        <a:srgbClr val="262626"/>
+                      </a:solidFill>
+                      <a:prstDash val="solid"/>
+                      <a:round/>
+                      <a:headEnd len="sm" w="sm" type="none"/>
+                      <a:tailEnd len="sm" w="sm" type="none"/>
+                    </a:lnT>
+                    <a:lnB cap="flat" cmpd="sng" w="19050">
+                      <a:solidFill>
+                        <a:srgbClr val="262626"/>
+                      </a:solidFill>
+                      <a:prstDash val="solid"/>
+                      <a:round/>
+                      <a:headEnd len="sm" w="sm" type="none"/>
+                      <a:tailEnd len="sm" w="sm" type="none"/>
+                    </a:lnB>
+                  </a:tcPr>
+                </a:tc>
+                <a:tc>
+                  <a:txBody>
+                    <a:bodyPr/>
+                    <a:lstStyle/>
+                    <a:p>
+                      <a:pPr indent="0" lvl="0" marL="0" rtl="0" algn="l">
+                        <a:spcBef>
+                          <a:spcPts val="0"/>
+                        </a:spcBef>
+                        <a:spcAft>
+                          <a:spcPts val="0"/>
+                        </a:spcAft>
+                        <a:buNone/>
+                      </a:pPr>
+                      <a:r>
+                        <a:rPr lang="en-US" sz="900">
+                          <a:latin typeface="Times New Roman"/>
+                          <a:ea typeface="Times New Roman"/>
+                          <a:cs typeface="Times New Roman"/>
+                          <a:sym typeface="Times New Roman"/>
+                        </a:rPr>
+                        <a:t>0.404</a:t>
+                      </a:r>
+                    </a:p>
+                  </a:txBody>
+                  <a:tcPr marT="45720" marB="45720" marR="45720" marL="45720">
+                    <a:lnL cap="flat" cmpd="sng" w="19050">
+                      <a:solidFill>
+                        <a:srgbClr val="262626"/>
+                      </a:solidFill>
+                      <a:prstDash val="solid"/>
+                      <a:round/>
+                      <a:headEnd len="sm" w="sm" type="none"/>
+                      <a:tailEnd len="sm" w="sm" type="none"/>
+                    </a:lnL>
+                    <a:lnR cap="flat" cmpd="sng" w="19050">
+                      <a:solidFill>
+                        <a:srgbClr val="262626"/>
+                      </a:solidFill>
+                      <a:prstDash val="solid"/>
+                      <a:round/>
+                      <a:headEnd len="sm" w="sm" type="none"/>
+                      <a:tailEnd len="sm" w="sm" type="none"/>
+                    </a:lnR>
+                    <a:lnT cap="flat" cmpd="sng" w="19050">
+                      <a:solidFill>
+                        <a:srgbClr val="262626"/>
+                      </a:solidFill>
+                      <a:prstDash val="solid"/>
+                      <a:round/>
+                      <a:headEnd len="sm" w="sm" type="none"/>
+                      <a:tailEnd len="sm" w="sm" type="none"/>
+                    </a:lnT>
+                    <a:lnB cap="flat" cmpd="sng" w="19050">
+                      <a:solidFill>
+                        <a:srgbClr val="262626"/>
+                      </a:solidFill>
+                      <a:prstDash val="solid"/>
+                      <a:round/>
+                      <a:headEnd len="sm" w="sm" type="none"/>
+                      <a:tailEnd len="sm" w="sm" type="none"/>
+                    </a:lnB>
+                  </a:tcPr>
+                </a:tc>
+                <a:tc>
+                  <a:txBody>
+                    <a:bodyPr/>
+                    <a:lstStyle/>
+                    <a:p>
+                      <a:pPr indent="0" lvl="0" marL="0" rtl="0" algn="l">
+                        <a:spcBef>
+                          <a:spcPts val="0"/>
+                        </a:spcBef>
+                        <a:spcAft>
+                          <a:spcPts val="0"/>
+                        </a:spcAft>
+                        <a:buNone/>
+                      </a:pPr>
+                      <a:r>
+                        <a:rPr lang="en-US" sz="900">
+                          <a:latin typeface="Times New Roman"/>
+                          <a:ea typeface="Times New Roman"/>
+                          <a:cs typeface="Times New Roman"/>
+                          <a:sym typeface="Times New Roman"/>
+                        </a:rPr>
+                        <a:t>61%</a:t>
+                      </a:r>
+                    </a:p>
+                  </a:txBody>
+                  <a:tcPr marT="45720" marB="45720" marR="45720" marL="45720">
+                    <a:lnL cap="flat" cmpd="sng" w="19050">
+                      <a:solidFill>
+                        <a:srgbClr val="262626"/>
+                      </a:solidFill>
+                      <a:prstDash val="solid"/>
+                      <a:round/>
+                      <a:headEnd len="sm" w="sm" type="none"/>
+                      <a:tailEnd len="sm" w="sm" type="none"/>
+                    </a:lnL>
+                    <a:lnR cap="flat" cmpd="sng" w="19050">
+                      <a:solidFill>
+                        <a:srgbClr val="262626"/>
+                      </a:solidFill>
+                      <a:prstDash val="solid"/>
+                      <a:round/>
+                      <a:headEnd len="sm" w="sm" type="none"/>
+                      <a:tailEnd len="sm" w="sm" type="none"/>
+                    </a:lnR>
+                    <a:lnT cap="flat" cmpd="sng" w="19050">
+                      <a:solidFill>
+                        <a:srgbClr val="262626"/>
+                      </a:solidFill>
+                      <a:prstDash val="solid"/>
+                      <a:round/>
+                      <a:headEnd len="sm" w="sm" type="none"/>
+                      <a:tailEnd len="sm" w="sm" type="none"/>
+                    </a:lnT>
+                    <a:lnB cap="flat" cmpd="sng" w="19050">
+                      <a:solidFill>
+                        <a:srgbClr val="262626"/>
+                      </a:solidFill>
+                      <a:prstDash val="solid"/>
+                      <a:round/>
+                      <a:headEnd len="sm" w="sm" type="none"/>
+                      <a:tailEnd len="sm" w="sm" type="none"/>
+                    </a:lnB>
+                  </a:tcPr>
+                </a:tc>
+              </a:tr>
+              <a:tr h="360000">
                 <a:tc>
                   <a:txBody>
                     <a:bodyPr/>
@@ -20811,7 +21711,7 @@
                           <a:cs typeface="Times New Roman"/>
                           <a:sym typeface="Times New Roman"/>
                         </a:rPr>
-                        <a:t>robust</a:t>
+                        <a:t>78%</a:t>
                       </a:r>
                     </a:p>
                   </a:txBody>
@@ -20855,7 +21755,7 @@
                   </a:tcPr>
                 </a:tc>
               </a:tr>
-              <a:tr h="420000">
+              <a:tr h="360000">
                 <a:tc>
                   <a:txBody>
                     <a:bodyPr/>
@@ -21261,7 +22161,7 @@
                           <a:cs typeface="Times New Roman"/>
                           <a:sym typeface="Times New Roman"/>
                         </a:rPr>
-                        <a:t>P falls</a:t>
+                        <a:t>68%</a:t>
                       </a:r>
                     </a:p>
                   </a:txBody>
@@ -21305,7 +22205,7 @@
                   </a:tcPr>
                 </a:tc>
               </a:tr>
-              <a:tr h="420000">
+              <a:tr h="360000">
                 <a:tc>
                   <a:txBody>
                     <a:bodyPr/>
@@ -21711,457 +22611,7 @@
                           <a:cs typeface="Times New Roman"/>
                           <a:sym typeface="Times New Roman"/>
                         </a:rPr>
-                        <a:t>fails</a:t>
-                      </a:r>
-                    </a:p>
-                  </a:txBody>
-                  <a:tcPr marT="45720" marB="45720" marR="45720" marL="45720">
-                    <a:lnL cap="flat" cmpd="sng" w="19050">
-                      <a:solidFill>
-                        <a:srgbClr val="262626"/>
-                      </a:solidFill>
-                      <a:prstDash val="solid"/>
-                      <a:round/>
-                      <a:headEnd len="sm" w="sm" type="none"/>
-                      <a:tailEnd len="sm" w="sm" type="none"/>
-                    </a:lnL>
-                    <a:lnR cap="flat" cmpd="sng" w="19050">
-                      <a:solidFill>
-                        <a:srgbClr val="262626"/>
-                      </a:solidFill>
-                      <a:prstDash val="solid"/>
-                      <a:round/>
-                      <a:headEnd len="sm" w="sm" type="none"/>
-                      <a:tailEnd len="sm" w="sm" type="none"/>
-                    </a:lnR>
-                    <a:lnT cap="flat" cmpd="sng" w="19050">
-                      <a:solidFill>
-                        <a:srgbClr val="262626"/>
-                      </a:solidFill>
-                      <a:prstDash val="solid"/>
-                      <a:round/>
-                      <a:headEnd len="sm" w="sm" type="none"/>
-                      <a:tailEnd len="sm" w="sm" type="none"/>
-                    </a:lnT>
-                    <a:lnB cap="flat" cmpd="sng" w="19050">
-                      <a:solidFill>
-                        <a:srgbClr val="262626"/>
-                      </a:solidFill>
-                      <a:prstDash val="solid"/>
-                      <a:round/>
-                      <a:headEnd len="sm" w="sm" type="none"/>
-                      <a:tailEnd len="sm" w="sm" type="none"/>
-                    </a:lnB>
-                  </a:tcPr>
-                </a:tc>
-              </a:tr>
-              <a:tr h="420000">
-                <a:tc>
-                  <a:txBody>
-                    <a:bodyPr/>
-                    <a:lstStyle/>
-                    <a:p>
-                      <a:pPr indent="0" lvl="0" marL="0" rtl="0" algn="l">
-                        <a:spcBef>
-                          <a:spcPts val="0"/>
-                        </a:spcBef>
-                        <a:spcAft>
-                          <a:spcPts val="0"/>
-                        </a:spcAft>
-                        <a:buNone/>
-                      </a:pPr>
-                      <a:r>
-                        <a:rPr lang="en-US" sz="900">
-                          <a:latin typeface="Times New Roman"/>
-                          <a:ea typeface="Times New Roman"/>
-                          <a:cs typeface="Times New Roman"/>
-                          <a:sym typeface="Times New Roman"/>
-                        </a:rPr>
-                        <a:t>BM25 / MinHash forced to precision 0.80</a:t>
-                      </a:r>
-                    </a:p>
-                  </a:txBody>
-                  <a:tcPr marT="45720" marB="45720" marR="45720" marL="45720">
-                    <a:lnL cap="flat" cmpd="sng" w="19050">
-                      <a:solidFill>
-                        <a:srgbClr val="262626"/>
-                      </a:solidFill>
-                      <a:prstDash val="solid"/>
-                      <a:round/>
-                      <a:headEnd len="sm" w="sm" type="none"/>
-                      <a:tailEnd len="sm" w="sm" type="none"/>
-                    </a:lnL>
-                    <a:lnR cap="flat" cmpd="sng" w="19050">
-                      <a:solidFill>
-                        <a:srgbClr val="262626"/>
-                      </a:solidFill>
-                      <a:prstDash val="solid"/>
-                      <a:round/>
-                      <a:headEnd len="sm" w="sm" type="none"/>
-                      <a:tailEnd len="sm" w="sm" type="none"/>
-                    </a:lnR>
-                    <a:lnT cap="flat" cmpd="sng" w="19050">
-                      <a:solidFill>
-                        <a:srgbClr val="262626"/>
-                      </a:solidFill>
-                      <a:prstDash val="solid"/>
-                      <a:round/>
-                      <a:headEnd len="sm" w="sm" type="none"/>
-                      <a:tailEnd len="sm" w="sm" type="none"/>
-                    </a:lnT>
-                    <a:lnB cap="flat" cmpd="sng" w="19050">
-                      <a:solidFill>
-                        <a:srgbClr val="262626"/>
-                      </a:solidFill>
-                      <a:prstDash val="solid"/>
-                      <a:round/>
-                      <a:headEnd len="sm" w="sm" type="none"/>
-                      <a:tailEnd len="sm" w="sm" type="none"/>
-                    </a:lnB>
-                  </a:tcPr>
-                </a:tc>
-                <a:tc>
-                  <a:txBody>
-                    <a:bodyPr/>
-                    <a:lstStyle/>
-                    <a:p>
-                      <a:pPr indent="0" lvl="0" marL="0" rtl="0" algn="l">
-                        <a:spcBef>
-                          <a:spcPts val="0"/>
-                        </a:spcBef>
-                        <a:spcAft>
-                          <a:spcPts val="0"/>
-                        </a:spcAft>
-                        <a:buNone/>
-                      </a:pPr>
-                      <a:r>
-                        <a:rPr lang="en-US" sz="900">
-                          <a:latin typeface="Times New Roman"/>
-                          <a:ea typeface="Times New Roman"/>
-                          <a:cs typeface="Times New Roman"/>
-                          <a:sym typeface="Times New Roman"/>
-                        </a:rPr>
-                        <a:t>–</a:t>
-                      </a:r>
-                    </a:p>
-                  </a:txBody>
-                  <a:tcPr marT="45720" marB="45720" marR="45720" marL="45720">
-                    <a:lnL cap="flat" cmpd="sng" w="19050">
-                      <a:solidFill>
-                        <a:srgbClr val="262626"/>
-                      </a:solidFill>
-                      <a:prstDash val="solid"/>
-                      <a:round/>
-                      <a:headEnd len="sm" w="sm" type="none"/>
-                      <a:tailEnd len="sm" w="sm" type="none"/>
-                    </a:lnL>
-                    <a:lnR cap="flat" cmpd="sng" w="19050">
-                      <a:solidFill>
-                        <a:srgbClr val="262626"/>
-                      </a:solidFill>
-                      <a:prstDash val="solid"/>
-                      <a:round/>
-                      <a:headEnd len="sm" w="sm" type="none"/>
-                      <a:tailEnd len="sm" w="sm" type="none"/>
-                    </a:lnR>
-                    <a:lnT cap="flat" cmpd="sng" w="19050">
-                      <a:solidFill>
-                        <a:srgbClr val="262626"/>
-                      </a:solidFill>
-                      <a:prstDash val="solid"/>
-                      <a:round/>
-                      <a:headEnd len="sm" w="sm" type="none"/>
-                      <a:tailEnd len="sm" w="sm" type="none"/>
-                    </a:lnT>
-                    <a:lnB cap="flat" cmpd="sng" w="19050">
-                      <a:solidFill>
-                        <a:srgbClr val="262626"/>
-                      </a:solidFill>
-                      <a:prstDash val="solid"/>
-                      <a:round/>
-                      <a:headEnd len="sm" w="sm" type="none"/>
-                      <a:tailEnd len="sm" w="sm" type="none"/>
-                    </a:lnB>
-                  </a:tcPr>
-                </a:tc>
-                <a:tc>
-                  <a:txBody>
-                    <a:bodyPr/>
-                    <a:lstStyle/>
-                    <a:p>
-                      <a:pPr indent="0" lvl="0" marL="0" rtl="0" algn="l">
-                        <a:spcBef>
-                          <a:spcPts val="0"/>
-                        </a:spcBef>
-                        <a:spcAft>
-                          <a:spcPts val="0"/>
-                        </a:spcAft>
-                        <a:buNone/>
-                      </a:pPr>
-                      <a:r>
-                        <a:rPr lang="en-US" sz="900">
-                          <a:latin typeface="Times New Roman"/>
-                          <a:ea typeface="Times New Roman"/>
-                          <a:cs typeface="Times New Roman"/>
-                          <a:sym typeface="Times New Roman"/>
-                        </a:rPr>
-                        <a:t>–</a:t>
-                      </a:r>
-                    </a:p>
-                  </a:txBody>
-                  <a:tcPr marT="45720" marB="45720" marR="45720" marL="45720">
-                    <a:lnL cap="flat" cmpd="sng" w="19050">
-                      <a:solidFill>
-                        <a:srgbClr val="262626"/>
-                      </a:solidFill>
-                      <a:prstDash val="solid"/>
-                      <a:round/>
-                      <a:headEnd len="sm" w="sm" type="none"/>
-                      <a:tailEnd len="sm" w="sm" type="none"/>
-                    </a:lnL>
-                    <a:lnR cap="flat" cmpd="sng" w="19050">
-                      <a:solidFill>
-                        <a:srgbClr val="262626"/>
-                      </a:solidFill>
-                      <a:prstDash val="solid"/>
-                      <a:round/>
-                      <a:headEnd len="sm" w="sm" type="none"/>
-                      <a:tailEnd len="sm" w="sm" type="none"/>
-                    </a:lnR>
-                    <a:lnT cap="flat" cmpd="sng" w="19050">
-                      <a:solidFill>
-                        <a:srgbClr val="262626"/>
-                      </a:solidFill>
-                      <a:prstDash val="solid"/>
-                      <a:round/>
-                      <a:headEnd len="sm" w="sm" type="none"/>
-                      <a:tailEnd len="sm" w="sm" type="none"/>
-                    </a:lnT>
-                    <a:lnB cap="flat" cmpd="sng" w="19050">
-                      <a:solidFill>
-                        <a:srgbClr val="262626"/>
-                      </a:solidFill>
-                      <a:prstDash val="solid"/>
-                      <a:round/>
-                      <a:headEnd len="sm" w="sm" type="none"/>
-                      <a:tailEnd len="sm" w="sm" type="none"/>
-                    </a:lnB>
-                  </a:tcPr>
-                </a:tc>
-                <a:tc>
-                  <a:txBody>
-                    <a:bodyPr/>
-                    <a:lstStyle/>
-                    <a:p>
-                      <a:pPr indent="0" lvl="0" marL="0" rtl="0" algn="l">
-                        <a:spcBef>
-                          <a:spcPts val="0"/>
-                        </a:spcBef>
-                        <a:spcAft>
-                          <a:spcPts val="0"/>
-                        </a:spcAft>
-                        <a:buNone/>
-                      </a:pPr>
-                      <a:r>
-                        <a:rPr lang="en-US" sz="900">
-                          <a:latin typeface="Times New Roman"/>
-                          <a:ea typeface="Times New Roman"/>
-                          <a:cs typeface="Times New Roman"/>
-                          <a:sym typeface="Times New Roman"/>
-                        </a:rPr>
-                        <a:t>≈ 0.80</a:t>
-                      </a:r>
-                    </a:p>
-                  </a:txBody>
-                  <a:tcPr marT="45720" marB="45720" marR="45720" marL="45720">
-                    <a:lnL cap="flat" cmpd="sng" w="19050">
-                      <a:solidFill>
-                        <a:srgbClr val="262626"/>
-                      </a:solidFill>
-                      <a:prstDash val="solid"/>
-                      <a:round/>
-                      <a:headEnd len="sm" w="sm" type="none"/>
-                      <a:tailEnd len="sm" w="sm" type="none"/>
-                    </a:lnL>
-                    <a:lnR cap="flat" cmpd="sng" w="19050">
-                      <a:solidFill>
-                        <a:srgbClr val="262626"/>
-                      </a:solidFill>
-                      <a:prstDash val="solid"/>
-                      <a:round/>
-                      <a:headEnd len="sm" w="sm" type="none"/>
-                      <a:tailEnd len="sm" w="sm" type="none"/>
-                    </a:lnR>
-                    <a:lnT cap="flat" cmpd="sng" w="19050">
-                      <a:solidFill>
-                        <a:srgbClr val="262626"/>
-                      </a:solidFill>
-                      <a:prstDash val="solid"/>
-                      <a:round/>
-                      <a:headEnd len="sm" w="sm" type="none"/>
-                      <a:tailEnd len="sm" w="sm" type="none"/>
-                    </a:lnT>
-                    <a:lnB cap="flat" cmpd="sng" w="19050">
-                      <a:solidFill>
-                        <a:srgbClr val="262626"/>
-                      </a:solidFill>
-                      <a:prstDash val="solid"/>
-                      <a:round/>
-                      <a:headEnd len="sm" w="sm" type="none"/>
-                      <a:tailEnd len="sm" w="sm" type="none"/>
-                    </a:lnB>
-                  </a:tcPr>
-                </a:tc>
-                <a:tc>
-                  <a:txBody>
-                    <a:bodyPr/>
-                    <a:lstStyle/>
-                    <a:p>
-                      <a:pPr indent="0" lvl="0" marL="0" rtl="0" algn="l">
-                        <a:spcBef>
-                          <a:spcPts val="0"/>
-                        </a:spcBef>
-                        <a:spcAft>
-                          <a:spcPts val="0"/>
-                        </a:spcAft>
-                        <a:buNone/>
-                      </a:pPr>
-                      <a:r>
-                        <a:rPr lang="en-US" sz="900">
-                          <a:latin typeface="Times New Roman"/>
-                          <a:ea typeface="Times New Roman"/>
-                          <a:cs typeface="Times New Roman"/>
-                          <a:sym typeface="Times New Roman"/>
-                        </a:rPr>
-                        <a:t>0.01</a:t>
-                      </a:r>
-                    </a:p>
-                  </a:txBody>
-                  <a:tcPr marT="45720" marB="45720" marR="45720" marL="45720">
-                    <a:lnL cap="flat" cmpd="sng" w="19050">
-                      <a:solidFill>
-                        <a:srgbClr val="262626"/>
-                      </a:solidFill>
-                      <a:prstDash val="solid"/>
-                      <a:round/>
-                      <a:headEnd len="sm" w="sm" type="none"/>
-                      <a:tailEnd len="sm" w="sm" type="none"/>
-                    </a:lnL>
-                    <a:lnR cap="flat" cmpd="sng" w="19050">
-                      <a:solidFill>
-                        <a:srgbClr val="262626"/>
-                      </a:solidFill>
-                      <a:prstDash val="solid"/>
-                      <a:round/>
-                      <a:headEnd len="sm" w="sm" type="none"/>
-                      <a:tailEnd len="sm" w="sm" type="none"/>
-                    </a:lnR>
-                    <a:lnT cap="flat" cmpd="sng" w="19050">
-                      <a:solidFill>
-                        <a:srgbClr val="262626"/>
-                      </a:solidFill>
-                      <a:prstDash val="solid"/>
-                      <a:round/>
-                      <a:headEnd len="sm" w="sm" type="none"/>
-                      <a:tailEnd len="sm" w="sm" type="none"/>
-                    </a:lnT>
-                    <a:lnB cap="flat" cmpd="sng" w="19050">
-                      <a:solidFill>
-                        <a:srgbClr val="262626"/>
-                      </a:solidFill>
-                      <a:prstDash val="solid"/>
-                      <a:round/>
-                      <a:headEnd len="sm" w="sm" type="none"/>
-                      <a:tailEnd len="sm" w="sm" type="none"/>
-                    </a:lnB>
-                  </a:tcPr>
-                </a:tc>
-                <a:tc>
-                  <a:txBody>
-                    <a:bodyPr/>
-                    <a:lstStyle/>
-                    <a:p>
-                      <a:pPr indent="0" lvl="0" marL="0" rtl="0" algn="l">
-                        <a:spcBef>
-                          <a:spcPts val="0"/>
-                        </a:spcBef>
-                        <a:spcAft>
-                          <a:spcPts val="0"/>
-                        </a:spcAft>
-                        <a:buNone/>
-                      </a:pPr>
-                      <a:r>
-                        <a:rPr lang="en-US" sz="900">
-                          <a:latin typeface="Times New Roman"/>
-                          <a:ea typeface="Times New Roman"/>
-                          <a:cs typeface="Times New Roman"/>
-                          <a:sym typeface="Times New Roman"/>
-                        </a:rPr>
-                        <a:t>–</a:t>
-                      </a:r>
-                    </a:p>
-                  </a:txBody>
-                  <a:tcPr marT="45720" marB="45720" marR="45720" marL="45720">
-                    <a:lnL cap="flat" cmpd="sng" w="19050">
-                      <a:solidFill>
-                        <a:srgbClr val="262626"/>
-                      </a:solidFill>
-                      <a:prstDash val="solid"/>
-                      <a:round/>
-                      <a:headEnd len="sm" w="sm" type="none"/>
-                      <a:tailEnd len="sm" w="sm" type="none"/>
-                    </a:lnL>
-                    <a:lnR cap="flat" cmpd="sng" w="19050">
-                      <a:solidFill>
-                        <a:srgbClr val="262626"/>
-                      </a:solidFill>
-                      <a:prstDash val="solid"/>
-                      <a:round/>
-                      <a:headEnd len="sm" w="sm" type="none"/>
-                      <a:tailEnd len="sm" w="sm" type="none"/>
-                    </a:lnR>
-                    <a:lnT cap="flat" cmpd="sng" w="19050">
-                      <a:solidFill>
-                        <a:srgbClr val="262626"/>
-                      </a:solidFill>
-                      <a:prstDash val="solid"/>
-                      <a:round/>
-                      <a:headEnd len="sm" w="sm" type="none"/>
-                      <a:tailEnd len="sm" w="sm" type="none"/>
-                    </a:lnT>
-                    <a:lnB cap="flat" cmpd="sng" w="19050">
-                      <a:solidFill>
-                        <a:srgbClr val="262626"/>
-                      </a:solidFill>
-                      <a:prstDash val="solid"/>
-                      <a:round/>
-                      <a:headEnd len="sm" w="sm" type="none"/>
-                      <a:tailEnd len="sm" w="sm" type="none"/>
-                    </a:lnB>
-                  </a:tcPr>
-                </a:tc>
-                <a:tc>
-                  <a:txBody>
-                    <a:bodyPr/>
-                    <a:lstStyle/>
-                    <a:p>
-                      <a:pPr indent="0" lvl="0" marL="0" rtl="0" algn="l">
-                        <a:spcBef>
-                          <a:spcPts val="0"/>
-                        </a:spcBef>
-                        <a:spcAft>
-                          <a:spcPts val="0"/>
-                        </a:spcAft>
-                        <a:buNone/>
-                      </a:pPr>
-                      <a:r>
-                        <a:rPr lang="en-US" sz="900">
-                          <a:latin typeface="Times New Roman"/>
-                          <a:ea typeface="Times New Roman"/>
-                          <a:cs typeface="Times New Roman"/>
-                          <a:sym typeface="Times New Roman"/>
-                        </a:rPr>
-                        <a:t>fails</a:t>
+                        <a:t>0%</a:t>
                       </a:r>
                     </a:p>
                   </a:txBody>
@@ -22400,7 +22850,7 @@
                 <a:cs typeface="Times New Roman"/>
                 <a:sym typeface="Times New Roman"/>
               </a:rPr>
-              <a:t xml:space="preserve">Play Store held-out halves pooled. Final values calibrated on all Play Store data (t_low 0.26, t_high 0.8306) are reused unchanged on Firefox, Thunderbird and unseen apps (precision 0.87–0.96). Raising t_low changes which complaints reach the judge, so those cells need new LLM calls and are not shown.</a:t>
+              <a:t xml:space="preserve">Play Store held-out halves pooled, live judge calls. Recall is stable across settings; a higher t_low raises precision and cuts LLM calls, so the 20th-percentile rule is conservative. Final values (t_low 0.26, t_high 0.8306) transfer unchanged to Firefox, Thunderbird and unseen apps (precision 0.87–0.96).</a:t>
             </a:r>
           </a:p>
         </p:txBody>

</xml_diff>

<commit_message>
Deck: short-text t_low setting in the calibration table
</commit_message>
<xml_diff>
--- a/reports/ppt/InsightDesk_final.pptx
+++ b/reports/ppt/InsightDesk_final.pptx
@@ -19037,7 +19037,7 @@
         </p:nvGraphicFramePr>
         <p:xfrm>
           <a:off x="497000" y="1500000"/>
-          <a:ext cx="8150000" cy="2800000"/>
+          <a:ext cx="8100000" cy="2800000"/>
         </p:xfrm>
         <a:graphic>
           <a:graphicData uri="http://schemas.openxmlformats.org/drawingml/2006/table">
@@ -19047,13 +19047,13 @@
                 <a:tableStyleId>{ADC876BD-21E3-499D-94FC-3D607E5DCE7B}</a:tableStyleId>
               </a:tblPr>
               <a:tblGrid>
-                <a:gridCol w="2350000"/>
-                <a:gridCol w="1450000"/>
-                <a:gridCol w="1450000"/>
+                <a:gridCol w="2450000"/>
+                <a:gridCol w="1300000"/>
+                <a:gridCol w="1350000"/>
                 <a:gridCol w="850000"/>
                 <a:gridCol w="750000"/>
                 <a:gridCol w="650000"/>
-                <a:gridCol w="650000"/>
+                <a:gridCol w="750000"/>
               </a:tblGrid>
               <a:tr h="280000">
                 <a:tc>
@@ -19521,13 +19521,13 @@
                         <a:buNone/>
                       </a:pPr>
                       <a:r>
-                        <a:rPr b="1" lang="en-US" sz="900">
+                        <a:rPr lang="en-US" sz="900">
                           <a:latin typeface="Times New Roman"/>
                           <a:ea typeface="Times New Roman"/>
                           <a:cs typeface="Times New Roman"/>
                           <a:sym typeface="Times New Roman"/>
                         </a:rPr>
-                        <a:t>Calibrated on tuning half (deployed)</a:t>
+                        <a:t>Original calibration (long-text channels)</a:t>
                       </a:r>
                     </a:p>
                   </a:txBody>
@@ -19585,7 +19585,7 @@
                         <a:buNone/>
                       </a:pPr>
                       <a:r>
-                        <a:rPr b="1" lang="en-US" sz="900">
+                        <a:rPr lang="en-US" sz="900">
                           <a:latin typeface="Times New Roman"/>
                           <a:ea typeface="Times New Roman"/>
                           <a:cs typeface="Times New Roman"/>
@@ -19649,7 +19649,7 @@
                         <a:buNone/>
                       </a:pPr>
                       <a:r>
-                        <a:rPr b="1" lang="en-US" sz="900">
+                        <a:rPr lang="en-US" sz="900">
                           <a:latin typeface="Times New Roman"/>
                           <a:ea typeface="Times New Roman"/>
                           <a:cs typeface="Times New Roman"/>
@@ -19713,7 +19713,7 @@
                         <a:buNone/>
                       </a:pPr>
                       <a:r>
-                        <a:rPr b="1" lang="en-US" sz="900">
+                        <a:rPr lang="en-US" sz="900">
                           <a:latin typeface="Times New Roman"/>
                           <a:ea typeface="Times New Roman"/>
                           <a:cs typeface="Times New Roman"/>
@@ -19777,7 +19777,7 @@
                         <a:buNone/>
                       </a:pPr>
                       <a:r>
-                        <a:rPr b="1" lang="en-US" sz="900">
+                        <a:rPr lang="en-US" sz="900">
                           <a:latin typeface="Times New Roman"/>
                           <a:ea typeface="Times New Roman"/>
                           <a:cs typeface="Times New Roman"/>
@@ -19841,7 +19841,7 @@
                         <a:buNone/>
                       </a:pPr>
                       <a:r>
-                        <a:rPr b="1" lang="en-US" sz="900">
+                        <a:rPr lang="en-US" sz="900">
                           <a:latin typeface="Times New Roman"/>
                           <a:ea typeface="Times New Roman"/>
                           <a:cs typeface="Times New Roman"/>
@@ -19905,13 +19905,463 @@
                         <a:buNone/>
                       </a:pPr>
                       <a:r>
+                        <a:rPr lang="en-US" sz="900">
+                          <a:latin typeface="Times New Roman"/>
+                          <a:ea typeface="Times New Roman"/>
+                          <a:cs typeface="Times New Roman"/>
+                          <a:sym typeface="Times New Roman"/>
+                        </a:rPr>
+                        <a:t>86%</a:t>
+                      </a:r>
+                    </a:p>
+                  </a:txBody>
+                  <a:tcPr marT="45720" marB="45720" marR="45720" marL="45720">
+                    <a:lnL cap="flat" cmpd="sng" w="19050">
+                      <a:solidFill>
+                        <a:srgbClr val="262626"/>
+                      </a:solidFill>
+                      <a:prstDash val="solid"/>
+                      <a:round/>
+                      <a:headEnd len="sm" w="sm" type="none"/>
+                      <a:tailEnd len="sm" w="sm" type="none"/>
+                    </a:lnL>
+                    <a:lnR cap="flat" cmpd="sng" w="19050">
+                      <a:solidFill>
+                        <a:srgbClr val="262626"/>
+                      </a:solidFill>
+                      <a:prstDash val="solid"/>
+                      <a:round/>
+                      <a:headEnd len="sm" w="sm" type="none"/>
+                      <a:tailEnd len="sm" w="sm" type="none"/>
+                    </a:lnR>
+                    <a:lnT cap="flat" cmpd="sng" w="19050">
+                      <a:solidFill>
+                        <a:srgbClr val="262626"/>
+                      </a:solidFill>
+                      <a:prstDash val="solid"/>
+                      <a:round/>
+                      <a:headEnd len="sm" w="sm" type="none"/>
+                      <a:tailEnd len="sm" w="sm" type="none"/>
+                    </a:lnT>
+                    <a:lnB cap="flat" cmpd="sng" w="19050">
+                      <a:solidFill>
+                        <a:srgbClr val="262626"/>
+                      </a:solidFill>
+                      <a:prstDash val="solid"/>
+                      <a:round/>
+                      <a:headEnd len="sm" w="sm" type="none"/>
+                      <a:tailEnd len="sm" w="sm" type="none"/>
+                    </a:lnB>
+                  </a:tcPr>
+                </a:tc>
+              </a:tr>
+              <a:tr h="360000">
+                <a:tc>
+                  <a:txBody>
+                    <a:bodyPr/>
+                    <a:lstStyle/>
+                    <a:p>
+                      <a:pPr indent="0" lvl="0" marL="0" rtl="0" algn="l">
+                        <a:spcBef>
+                          <a:spcPts val="0"/>
+                        </a:spcBef>
+                        <a:spcAft>
+                          <a:spcPts val="0"/>
+                        </a:spcAft>
+                        <a:buNone/>
+                      </a:pPr>
+                      <a:r>
                         <a:rPr b="1" lang="en-US" sz="900">
                           <a:latin typeface="Times New Roman"/>
                           <a:ea typeface="Times New Roman"/>
                           <a:cs typeface="Times New Roman"/>
                           <a:sym typeface="Times New Roman"/>
                         </a:rPr>
-                        <a:t>86%</a:t>
+                        <a:t>Short-text setting (deployed)</a:t>
+                      </a:r>
+                    </a:p>
+                  </a:txBody>
+                  <a:tcPr marT="45720" marB="45720" marR="45720" marL="45720">
+                    <a:lnL cap="flat" cmpd="sng" w="19050">
+                      <a:solidFill>
+                        <a:srgbClr val="262626"/>
+                      </a:solidFill>
+                      <a:prstDash val="solid"/>
+                      <a:round/>
+                      <a:headEnd len="sm" w="sm" type="none"/>
+                      <a:tailEnd len="sm" w="sm" type="none"/>
+                    </a:lnL>
+                    <a:lnR cap="flat" cmpd="sng" w="19050">
+                      <a:solidFill>
+                        <a:srgbClr val="262626"/>
+                      </a:solidFill>
+                      <a:prstDash val="solid"/>
+                      <a:round/>
+                      <a:headEnd len="sm" w="sm" type="none"/>
+                      <a:tailEnd len="sm" w="sm" type="none"/>
+                    </a:lnR>
+                    <a:lnT cap="flat" cmpd="sng" w="19050">
+                      <a:solidFill>
+                        <a:srgbClr val="262626"/>
+                      </a:solidFill>
+                      <a:prstDash val="solid"/>
+                      <a:round/>
+                      <a:headEnd len="sm" w="sm" type="none"/>
+                      <a:tailEnd len="sm" w="sm" type="none"/>
+                    </a:lnT>
+                    <a:lnB cap="flat" cmpd="sng" w="19050">
+                      <a:solidFill>
+                        <a:srgbClr val="262626"/>
+                      </a:solidFill>
+                      <a:prstDash val="solid"/>
+                      <a:round/>
+                      <a:headEnd len="sm" w="sm" type="none"/>
+                      <a:tailEnd len="sm" w="sm" type="none"/>
+                    </a:lnB>
+                  </a:tcPr>
+                </a:tc>
+                <a:tc>
+                  <a:txBody>
+                    <a:bodyPr/>
+                    <a:lstStyle/>
+                    <a:p>
+                      <a:pPr indent="0" lvl="0" marL="0" rtl="0" algn="l">
+                        <a:spcBef>
+                          <a:spcPts val="0"/>
+                        </a:spcBef>
+                        <a:spcAft>
+                          <a:spcPts val="0"/>
+                        </a:spcAft>
+                        <a:buNone/>
+                      </a:pPr>
+                      <a:r>
+                        <a:rPr b="1" lang="en-US" sz="900">
+                          <a:latin typeface="Times New Roman"/>
+                          <a:ea typeface="Times New Roman"/>
+                          <a:cs typeface="Times New Roman"/>
+                          <a:sym typeface="Times New Roman"/>
+                        </a:rPr>
+                        <a:t>0.40</a:t>
+                      </a:r>
+                    </a:p>
+                  </a:txBody>
+                  <a:tcPr marT="45720" marB="45720" marR="45720" marL="45720">
+                    <a:lnL cap="flat" cmpd="sng" w="19050">
+                      <a:solidFill>
+                        <a:srgbClr val="262626"/>
+                      </a:solidFill>
+                      <a:prstDash val="solid"/>
+                      <a:round/>
+                      <a:headEnd len="sm" w="sm" type="none"/>
+                      <a:tailEnd len="sm" w="sm" type="none"/>
+                    </a:lnL>
+                    <a:lnR cap="flat" cmpd="sng" w="19050">
+                      <a:solidFill>
+                        <a:srgbClr val="262626"/>
+                      </a:solidFill>
+                      <a:prstDash val="solid"/>
+                      <a:round/>
+                      <a:headEnd len="sm" w="sm" type="none"/>
+                      <a:tailEnd len="sm" w="sm" type="none"/>
+                    </a:lnR>
+                    <a:lnT cap="flat" cmpd="sng" w="19050">
+                      <a:solidFill>
+                        <a:srgbClr val="262626"/>
+                      </a:solidFill>
+                      <a:prstDash val="solid"/>
+                      <a:round/>
+                      <a:headEnd len="sm" w="sm" type="none"/>
+                      <a:tailEnd len="sm" w="sm" type="none"/>
+                    </a:lnT>
+                    <a:lnB cap="flat" cmpd="sng" w="19050">
+                      <a:solidFill>
+                        <a:srgbClr val="262626"/>
+                      </a:solidFill>
+                      <a:prstDash val="solid"/>
+                      <a:round/>
+                      <a:headEnd len="sm" w="sm" type="none"/>
+                      <a:tailEnd len="sm" w="sm" type="none"/>
+                    </a:lnB>
+                  </a:tcPr>
+                </a:tc>
+                <a:tc>
+                  <a:txBody>
+                    <a:bodyPr/>
+                    <a:lstStyle/>
+                    <a:p>
+                      <a:pPr indent="0" lvl="0" marL="0" rtl="0" algn="l">
+                        <a:spcBef>
+                          <a:spcPts val="0"/>
+                        </a:spcBef>
+                        <a:spcAft>
+                          <a:spcPts val="0"/>
+                        </a:spcAft>
+                        <a:buNone/>
+                      </a:pPr>
+                      <a:r>
+                        <a:rPr b="1" lang="en-US" sz="900">
+                          <a:latin typeface="Times New Roman"/>
+                          <a:ea typeface="Times New Roman"/>
+                          <a:cs typeface="Times New Roman"/>
+                          <a:sym typeface="Times New Roman"/>
+                        </a:rPr>
+                        <a:t>same</a:t>
+                      </a:r>
+                    </a:p>
+                  </a:txBody>
+                  <a:tcPr marT="45720" marB="45720" marR="45720" marL="45720">
+                    <a:lnL cap="flat" cmpd="sng" w="19050">
+                      <a:solidFill>
+                        <a:srgbClr val="262626"/>
+                      </a:solidFill>
+                      <a:prstDash val="solid"/>
+                      <a:round/>
+                      <a:headEnd len="sm" w="sm" type="none"/>
+                      <a:tailEnd len="sm" w="sm" type="none"/>
+                    </a:lnL>
+                    <a:lnR cap="flat" cmpd="sng" w="19050">
+                      <a:solidFill>
+                        <a:srgbClr val="262626"/>
+                      </a:solidFill>
+                      <a:prstDash val="solid"/>
+                      <a:round/>
+                      <a:headEnd len="sm" w="sm" type="none"/>
+                      <a:tailEnd len="sm" w="sm" type="none"/>
+                    </a:lnR>
+                    <a:lnT cap="flat" cmpd="sng" w="19050">
+                      <a:solidFill>
+                        <a:srgbClr val="262626"/>
+                      </a:solidFill>
+                      <a:prstDash val="solid"/>
+                      <a:round/>
+                      <a:headEnd len="sm" w="sm" type="none"/>
+                      <a:tailEnd len="sm" w="sm" type="none"/>
+                    </a:lnT>
+                    <a:lnB cap="flat" cmpd="sng" w="19050">
+                      <a:solidFill>
+                        <a:srgbClr val="262626"/>
+                      </a:solidFill>
+                      <a:prstDash val="solid"/>
+                      <a:round/>
+                      <a:headEnd len="sm" w="sm" type="none"/>
+                      <a:tailEnd len="sm" w="sm" type="none"/>
+                    </a:lnB>
+                  </a:tcPr>
+                </a:tc>
+                <a:tc>
+                  <a:txBody>
+                    <a:bodyPr/>
+                    <a:lstStyle/>
+                    <a:p>
+                      <a:pPr indent="0" lvl="0" marL="0" rtl="0" algn="l">
+                        <a:spcBef>
+                          <a:spcPts val="0"/>
+                        </a:spcBef>
+                        <a:spcAft>
+                          <a:spcPts val="0"/>
+                        </a:spcAft>
+                        <a:buNone/>
+                      </a:pPr>
+                      <a:r>
+                        <a:rPr b="1" lang="en-US" sz="900">
+                          <a:latin typeface="Times New Roman"/>
+                          <a:ea typeface="Times New Roman"/>
+                          <a:cs typeface="Times New Roman"/>
+                          <a:sym typeface="Times New Roman"/>
+                        </a:rPr>
+                        <a:t>0.883</a:t>
+                      </a:r>
+                    </a:p>
+                  </a:txBody>
+                  <a:tcPr marT="45720" marB="45720" marR="45720" marL="45720">
+                    <a:lnL cap="flat" cmpd="sng" w="19050">
+                      <a:solidFill>
+                        <a:srgbClr val="262626"/>
+                      </a:solidFill>
+                      <a:prstDash val="solid"/>
+                      <a:round/>
+                      <a:headEnd len="sm" w="sm" type="none"/>
+                      <a:tailEnd len="sm" w="sm" type="none"/>
+                    </a:lnL>
+                    <a:lnR cap="flat" cmpd="sng" w="19050">
+                      <a:solidFill>
+                        <a:srgbClr val="262626"/>
+                      </a:solidFill>
+                      <a:prstDash val="solid"/>
+                      <a:round/>
+                      <a:headEnd len="sm" w="sm" type="none"/>
+                      <a:tailEnd len="sm" w="sm" type="none"/>
+                    </a:lnR>
+                    <a:lnT cap="flat" cmpd="sng" w="19050">
+                      <a:solidFill>
+                        <a:srgbClr val="262626"/>
+                      </a:solidFill>
+                      <a:prstDash val="solid"/>
+                      <a:round/>
+                      <a:headEnd len="sm" w="sm" type="none"/>
+                      <a:tailEnd len="sm" w="sm" type="none"/>
+                    </a:lnT>
+                    <a:lnB cap="flat" cmpd="sng" w="19050">
+                      <a:solidFill>
+                        <a:srgbClr val="262626"/>
+                      </a:solidFill>
+                      <a:prstDash val="solid"/>
+                      <a:round/>
+                      <a:headEnd len="sm" w="sm" type="none"/>
+                      <a:tailEnd len="sm" w="sm" type="none"/>
+                    </a:lnB>
+                  </a:tcPr>
+                </a:tc>
+                <a:tc>
+                  <a:txBody>
+                    <a:bodyPr/>
+                    <a:lstStyle/>
+                    <a:p>
+                      <a:pPr indent="0" lvl="0" marL="0" rtl="0" algn="l">
+                        <a:spcBef>
+                          <a:spcPts val="0"/>
+                        </a:spcBef>
+                        <a:spcAft>
+                          <a:spcPts val="0"/>
+                        </a:spcAft>
+                        <a:buNone/>
+                      </a:pPr>
+                      <a:r>
+                        <a:rPr b="1" lang="en-US" sz="900">
+                          <a:latin typeface="Times New Roman"/>
+                          <a:ea typeface="Times New Roman"/>
+                          <a:cs typeface="Times New Roman"/>
+                          <a:sym typeface="Times New Roman"/>
+                        </a:rPr>
+                        <a:t>0.284</a:t>
+                      </a:r>
+                    </a:p>
+                  </a:txBody>
+                  <a:tcPr marT="45720" marB="45720" marR="45720" marL="45720">
+                    <a:lnL cap="flat" cmpd="sng" w="19050">
+                      <a:solidFill>
+                        <a:srgbClr val="262626"/>
+                      </a:solidFill>
+                      <a:prstDash val="solid"/>
+                      <a:round/>
+                      <a:headEnd len="sm" w="sm" type="none"/>
+                      <a:tailEnd len="sm" w="sm" type="none"/>
+                    </a:lnL>
+                    <a:lnR cap="flat" cmpd="sng" w="19050">
+                      <a:solidFill>
+                        <a:srgbClr val="262626"/>
+                      </a:solidFill>
+                      <a:prstDash val="solid"/>
+                      <a:round/>
+                      <a:headEnd len="sm" w="sm" type="none"/>
+                      <a:tailEnd len="sm" w="sm" type="none"/>
+                    </a:lnR>
+                    <a:lnT cap="flat" cmpd="sng" w="19050">
+                      <a:solidFill>
+                        <a:srgbClr val="262626"/>
+                      </a:solidFill>
+                      <a:prstDash val="solid"/>
+                      <a:round/>
+                      <a:headEnd len="sm" w="sm" type="none"/>
+                      <a:tailEnd len="sm" w="sm" type="none"/>
+                    </a:lnT>
+                    <a:lnB cap="flat" cmpd="sng" w="19050">
+                      <a:solidFill>
+                        <a:srgbClr val="262626"/>
+                      </a:solidFill>
+                      <a:prstDash val="solid"/>
+                      <a:round/>
+                      <a:headEnd len="sm" w="sm" type="none"/>
+                      <a:tailEnd len="sm" w="sm" type="none"/>
+                    </a:lnB>
+                  </a:tcPr>
+                </a:tc>
+                <a:tc>
+                  <a:txBody>
+                    <a:bodyPr/>
+                    <a:lstStyle/>
+                    <a:p>
+                      <a:pPr indent="0" lvl="0" marL="0" rtl="0" algn="l">
+                        <a:spcBef>
+                          <a:spcPts val="0"/>
+                        </a:spcBef>
+                        <a:spcAft>
+                          <a:spcPts val="0"/>
+                        </a:spcAft>
+                        <a:buNone/>
+                      </a:pPr>
+                      <a:r>
+                        <a:rPr b="1" lang="en-US" sz="900">
+                          <a:latin typeface="Times New Roman"/>
+                          <a:ea typeface="Times New Roman"/>
+                          <a:cs typeface="Times New Roman"/>
+                          <a:sym typeface="Times New Roman"/>
+                        </a:rPr>
+                        <a:t>0.430</a:t>
+                      </a:r>
+                    </a:p>
+                  </a:txBody>
+                  <a:tcPr marT="45720" marB="45720" marR="45720" marL="45720">
+                    <a:lnL cap="flat" cmpd="sng" w="19050">
+                      <a:solidFill>
+                        <a:srgbClr val="262626"/>
+                      </a:solidFill>
+                      <a:prstDash val="solid"/>
+                      <a:round/>
+                      <a:headEnd len="sm" w="sm" type="none"/>
+                      <a:tailEnd len="sm" w="sm" type="none"/>
+                    </a:lnL>
+                    <a:lnR cap="flat" cmpd="sng" w="19050">
+                      <a:solidFill>
+                        <a:srgbClr val="262626"/>
+                      </a:solidFill>
+                      <a:prstDash val="solid"/>
+                      <a:round/>
+                      <a:headEnd len="sm" w="sm" type="none"/>
+                      <a:tailEnd len="sm" w="sm" type="none"/>
+                    </a:lnR>
+                    <a:lnT cap="flat" cmpd="sng" w="19050">
+                      <a:solidFill>
+                        <a:srgbClr val="262626"/>
+                      </a:solidFill>
+                      <a:prstDash val="solid"/>
+                      <a:round/>
+                      <a:headEnd len="sm" w="sm" type="none"/>
+                      <a:tailEnd len="sm" w="sm" type="none"/>
+                    </a:lnT>
+                    <a:lnB cap="flat" cmpd="sng" w="19050">
+                      <a:solidFill>
+                        <a:srgbClr val="262626"/>
+                      </a:solidFill>
+                      <a:prstDash val="solid"/>
+                      <a:round/>
+                      <a:headEnd len="sm" w="sm" type="none"/>
+                      <a:tailEnd len="sm" w="sm" type="none"/>
+                    </a:lnB>
+                  </a:tcPr>
+                </a:tc>
+                <a:tc>
+                  <a:txBody>
+                    <a:bodyPr/>
+                    <a:lstStyle/>
+                    <a:p>
+                      <a:pPr indent="0" lvl="0" marL="0" rtl="0" algn="l">
+                        <a:spcBef>
+                          <a:spcPts val="0"/>
+                        </a:spcBef>
+                        <a:spcAft>
+                          <a:spcPts val="0"/>
+                        </a:spcAft>
+                        <a:buNone/>
+                      </a:pPr>
+                      <a:r>
+                        <a:rPr b="1" lang="en-US" sz="900">
+                          <a:latin typeface="Times New Roman"/>
+                          <a:ea typeface="Times New Roman"/>
+                          <a:cs typeface="Times New Roman"/>
+                          <a:sym typeface="Times New Roman"/>
+                        </a:rPr>
+                        <a:t>66%</a:t>
                       </a:r>
                     </a:p>
                   </a:txBody>
@@ -20427,7 +20877,7 @@
                           <a:cs typeface="Times New Roman"/>
                           <a:sym typeface="Times New Roman"/>
                         </a:rPr>
-                        <a:t>t_low raised by 0.09</a:t>
+                        <a:t>t_low raised by 0.14</a:t>
                       </a:r>
                     </a:p>
                   </a:txBody>
@@ -20491,7 +20941,7 @@
                           <a:cs typeface="Times New Roman"/>
                           <a:sym typeface="Times New Roman"/>
                         </a:rPr>
-                        <a:t>+ 0.09</a:t>
+                        <a:t>+ 0.14</a:t>
                       </a:r>
                     </a:p>
                   </a:txBody>
@@ -20619,7 +21069,7 @@
                           <a:cs typeface="Times New Roman"/>
                           <a:sym typeface="Times New Roman"/>
                         </a:rPr>
-                        <a:t>0.867</a:t>
+                        <a:t>0.906</a:t>
                       </a:r>
                     </a:p>
                   </a:txBody>
@@ -20683,7 +21133,7 @@
                           <a:cs typeface="Times New Roman"/>
                           <a:sym typeface="Times New Roman"/>
                         </a:rPr>
-                        <a:t>0.264</a:t>
+                        <a:t>0.260</a:t>
                       </a:r>
                     </a:p>
                   </a:txBody>
@@ -20811,7 +21261,7 @@
                           <a:cs typeface="Times New Roman"/>
                           <a:sym typeface="Times New Roman"/>
                         </a:rPr>
-                        <a:t>71%</a:t>
+                        <a:t>61%</a:t>
                       </a:r>
                     </a:p>
                   </a:txBody>
@@ -20877,71 +21327,7 @@
                           <a:cs typeface="Times New Roman"/>
                           <a:sym typeface="Times New Roman"/>
                         </a:rPr>
-                        <a:t>t_low raised by 0.14</a:t>
-                      </a:r>
-                    </a:p>
-                  </a:txBody>
-                  <a:tcPr marT="45720" marB="45720" marR="45720" marL="45720">
-                    <a:lnL cap="flat" cmpd="sng" w="19050">
-                      <a:solidFill>
-                        <a:srgbClr val="262626"/>
-                      </a:solidFill>
-                      <a:prstDash val="solid"/>
-                      <a:round/>
-                      <a:headEnd len="sm" w="sm" type="none"/>
-                      <a:tailEnd len="sm" w="sm" type="none"/>
-                    </a:lnL>
-                    <a:lnR cap="flat" cmpd="sng" w="19050">
-                      <a:solidFill>
-                        <a:srgbClr val="262626"/>
-                      </a:solidFill>
-                      <a:prstDash val="solid"/>
-                      <a:round/>
-                      <a:headEnd len="sm" w="sm" type="none"/>
-                      <a:tailEnd len="sm" w="sm" type="none"/>
-                    </a:lnR>
-                    <a:lnT cap="flat" cmpd="sng" w="19050">
-                      <a:solidFill>
-                        <a:srgbClr val="262626"/>
-                      </a:solidFill>
-                      <a:prstDash val="solid"/>
-                      <a:round/>
-                      <a:headEnd len="sm" w="sm" type="none"/>
-                      <a:tailEnd len="sm" w="sm" type="none"/>
-                    </a:lnT>
-                    <a:lnB cap="flat" cmpd="sng" w="19050">
-                      <a:solidFill>
-                        <a:srgbClr val="262626"/>
-                      </a:solidFill>
-                      <a:prstDash val="solid"/>
-                      <a:round/>
-                      <a:headEnd len="sm" w="sm" type="none"/>
-                      <a:tailEnd len="sm" w="sm" type="none"/>
-                    </a:lnB>
-                  </a:tcPr>
-                </a:tc>
-                <a:tc>
-                  <a:txBody>
-                    <a:bodyPr/>
-                    <a:lstStyle/>
-                    <a:p>
-                      <a:pPr indent="0" lvl="0" marL="0" rtl="0" algn="l">
-                        <a:spcBef>
-                          <a:spcPts val="0"/>
-                        </a:spcBef>
-                        <a:spcAft>
-                          <a:spcPts val="0"/>
-                        </a:spcAft>
-                        <a:buNone/>
-                      </a:pPr>
-                      <a:r>
-                        <a:rPr lang="en-US" sz="900">
-                          <a:latin typeface="Times New Roman"/>
-                          <a:ea typeface="Times New Roman"/>
-                          <a:cs typeface="Times New Roman"/>
-                          <a:sym typeface="Times New Roman"/>
-                        </a:rPr>
-                        <a:t>+ 0.14</a:t>
+                        <a:t>t_high lowered by 0.08</a:t>
                       </a:r>
                     </a:p>
                   </a:txBody>
@@ -21069,392 +21455,6 @@
                           <a:cs typeface="Times New Roman"/>
                           <a:sym typeface="Times New Roman"/>
                         </a:rPr>
-                        <a:t>0.906</a:t>
-                      </a:r>
-                    </a:p>
-                  </a:txBody>
-                  <a:tcPr marT="45720" marB="45720" marR="45720" marL="45720">
-                    <a:lnL cap="flat" cmpd="sng" w="19050">
-                      <a:solidFill>
-                        <a:srgbClr val="262626"/>
-                      </a:solidFill>
-                      <a:prstDash val="solid"/>
-                      <a:round/>
-                      <a:headEnd len="sm" w="sm" type="none"/>
-                      <a:tailEnd len="sm" w="sm" type="none"/>
-                    </a:lnL>
-                    <a:lnR cap="flat" cmpd="sng" w="19050">
-                      <a:solidFill>
-                        <a:srgbClr val="262626"/>
-                      </a:solidFill>
-                      <a:prstDash val="solid"/>
-                      <a:round/>
-                      <a:headEnd len="sm" w="sm" type="none"/>
-                      <a:tailEnd len="sm" w="sm" type="none"/>
-                    </a:lnR>
-                    <a:lnT cap="flat" cmpd="sng" w="19050">
-                      <a:solidFill>
-                        <a:srgbClr val="262626"/>
-                      </a:solidFill>
-                      <a:prstDash val="solid"/>
-                      <a:round/>
-                      <a:headEnd len="sm" w="sm" type="none"/>
-                      <a:tailEnd len="sm" w="sm" type="none"/>
-                    </a:lnT>
-                    <a:lnB cap="flat" cmpd="sng" w="19050">
-                      <a:solidFill>
-                        <a:srgbClr val="262626"/>
-                      </a:solidFill>
-                      <a:prstDash val="solid"/>
-                      <a:round/>
-                      <a:headEnd len="sm" w="sm" type="none"/>
-                      <a:tailEnd len="sm" w="sm" type="none"/>
-                    </a:lnB>
-                  </a:tcPr>
-                </a:tc>
-                <a:tc>
-                  <a:txBody>
-                    <a:bodyPr/>
-                    <a:lstStyle/>
-                    <a:p>
-                      <a:pPr indent="0" lvl="0" marL="0" rtl="0" algn="l">
-                        <a:spcBef>
-                          <a:spcPts val="0"/>
-                        </a:spcBef>
-                        <a:spcAft>
-                          <a:spcPts val="0"/>
-                        </a:spcAft>
-                        <a:buNone/>
-                      </a:pPr>
-                      <a:r>
-                        <a:rPr lang="en-US" sz="900">
-                          <a:latin typeface="Times New Roman"/>
-                          <a:ea typeface="Times New Roman"/>
-                          <a:cs typeface="Times New Roman"/>
-                          <a:sym typeface="Times New Roman"/>
-                        </a:rPr>
-                        <a:t>0.260</a:t>
-                      </a:r>
-                    </a:p>
-                  </a:txBody>
-                  <a:tcPr marT="45720" marB="45720" marR="45720" marL="45720">
-                    <a:lnL cap="flat" cmpd="sng" w="19050">
-                      <a:solidFill>
-                        <a:srgbClr val="262626"/>
-                      </a:solidFill>
-                      <a:prstDash val="solid"/>
-                      <a:round/>
-                      <a:headEnd len="sm" w="sm" type="none"/>
-                      <a:tailEnd len="sm" w="sm" type="none"/>
-                    </a:lnL>
-                    <a:lnR cap="flat" cmpd="sng" w="19050">
-                      <a:solidFill>
-                        <a:srgbClr val="262626"/>
-                      </a:solidFill>
-                      <a:prstDash val="solid"/>
-                      <a:round/>
-                      <a:headEnd len="sm" w="sm" type="none"/>
-                      <a:tailEnd len="sm" w="sm" type="none"/>
-                    </a:lnR>
-                    <a:lnT cap="flat" cmpd="sng" w="19050">
-                      <a:solidFill>
-                        <a:srgbClr val="262626"/>
-                      </a:solidFill>
-                      <a:prstDash val="solid"/>
-                      <a:round/>
-                      <a:headEnd len="sm" w="sm" type="none"/>
-                      <a:tailEnd len="sm" w="sm" type="none"/>
-                    </a:lnT>
-                    <a:lnB cap="flat" cmpd="sng" w="19050">
-                      <a:solidFill>
-                        <a:srgbClr val="262626"/>
-                      </a:solidFill>
-                      <a:prstDash val="solid"/>
-                      <a:round/>
-                      <a:headEnd len="sm" w="sm" type="none"/>
-                      <a:tailEnd len="sm" w="sm" type="none"/>
-                    </a:lnB>
-                  </a:tcPr>
-                </a:tc>
-                <a:tc>
-                  <a:txBody>
-                    <a:bodyPr/>
-                    <a:lstStyle/>
-                    <a:p>
-                      <a:pPr indent="0" lvl="0" marL="0" rtl="0" algn="l">
-                        <a:spcBef>
-                          <a:spcPts val="0"/>
-                        </a:spcBef>
-                        <a:spcAft>
-                          <a:spcPts val="0"/>
-                        </a:spcAft>
-                        <a:buNone/>
-                      </a:pPr>
-                      <a:r>
-                        <a:rPr lang="en-US" sz="900">
-                          <a:latin typeface="Times New Roman"/>
-                          <a:ea typeface="Times New Roman"/>
-                          <a:cs typeface="Times New Roman"/>
-                          <a:sym typeface="Times New Roman"/>
-                        </a:rPr>
-                        <a:t>0.404</a:t>
-                      </a:r>
-                    </a:p>
-                  </a:txBody>
-                  <a:tcPr marT="45720" marB="45720" marR="45720" marL="45720">
-                    <a:lnL cap="flat" cmpd="sng" w="19050">
-                      <a:solidFill>
-                        <a:srgbClr val="262626"/>
-                      </a:solidFill>
-                      <a:prstDash val="solid"/>
-                      <a:round/>
-                      <a:headEnd len="sm" w="sm" type="none"/>
-                      <a:tailEnd len="sm" w="sm" type="none"/>
-                    </a:lnL>
-                    <a:lnR cap="flat" cmpd="sng" w="19050">
-                      <a:solidFill>
-                        <a:srgbClr val="262626"/>
-                      </a:solidFill>
-                      <a:prstDash val="solid"/>
-                      <a:round/>
-                      <a:headEnd len="sm" w="sm" type="none"/>
-                      <a:tailEnd len="sm" w="sm" type="none"/>
-                    </a:lnR>
-                    <a:lnT cap="flat" cmpd="sng" w="19050">
-                      <a:solidFill>
-                        <a:srgbClr val="262626"/>
-                      </a:solidFill>
-                      <a:prstDash val="solid"/>
-                      <a:round/>
-                      <a:headEnd len="sm" w="sm" type="none"/>
-                      <a:tailEnd len="sm" w="sm" type="none"/>
-                    </a:lnT>
-                    <a:lnB cap="flat" cmpd="sng" w="19050">
-                      <a:solidFill>
-                        <a:srgbClr val="262626"/>
-                      </a:solidFill>
-                      <a:prstDash val="solid"/>
-                      <a:round/>
-                      <a:headEnd len="sm" w="sm" type="none"/>
-                      <a:tailEnd len="sm" w="sm" type="none"/>
-                    </a:lnB>
-                  </a:tcPr>
-                </a:tc>
-                <a:tc>
-                  <a:txBody>
-                    <a:bodyPr/>
-                    <a:lstStyle/>
-                    <a:p>
-                      <a:pPr indent="0" lvl="0" marL="0" rtl="0" algn="l">
-                        <a:spcBef>
-                          <a:spcPts val="0"/>
-                        </a:spcBef>
-                        <a:spcAft>
-                          <a:spcPts val="0"/>
-                        </a:spcAft>
-                        <a:buNone/>
-                      </a:pPr>
-                      <a:r>
-                        <a:rPr lang="en-US" sz="900">
-                          <a:latin typeface="Times New Roman"/>
-                          <a:ea typeface="Times New Roman"/>
-                          <a:cs typeface="Times New Roman"/>
-                          <a:sym typeface="Times New Roman"/>
-                        </a:rPr>
-                        <a:t>61%</a:t>
-                      </a:r>
-                    </a:p>
-                  </a:txBody>
-                  <a:tcPr marT="45720" marB="45720" marR="45720" marL="45720">
-                    <a:lnL cap="flat" cmpd="sng" w="19050">
-                      <a:solidFill>
-                        <a:srgbClr val="262626"/>
-                      </a:solidFill>
-                      <a:prstDash val="solid"/>
-                      <a:round/>
-                      <a:headEnd len="sm" w="sm" type="none"/>
-                      <a:tailEnd len="sm" w="sm" type="none"/>
-                    </a:lnL>
-                    <a:lnR cap="flat" cmpd="sng" w="19050">
-                      <a:solidFill>
-                        <a:srgbClr val="262626"/>
-                      </a:solidFill>
-                      <a:prstDash val="solid"/>
-                      <a:round/>
-                      <a:headEnd len="sm" w="sm" type="none"/>
-                      <a:tailEnd len="sm" w="sm" type="none"/>
-                    </a:lnR>
-                    <a:lnT cap="flat" cmpd="sng" w="19050">
-                      <a:solidFill>
-                        <a:srgbClr val="262626"/>
-                      </a:solidFill>
-                      <a:prstDash val="solid"/>
-                      <a:round/>
-                      <a:headEnd len="sm" w="sm" type="none"/>
-                      <a:tailEnd len="sm" w="sm" type="none"/>
-                    </a:lnT>
-                    <a:lnB cap="flat" cmpd="sng" w="19050">
-                      <a:solidFill>
-                        <a:srgbClr val="262626"/>
-                      </a:solidFill>
-                      <a:prstDash val="solid"/>
-                      <a:round/>
-                      <a:headEnd len="sm" w="sm" type="none"/>
-                      <a:tailEnd len="sm" w="sm" type="none"/>
-                    </a:lnB>
-                  </a:tcPr>
-                </a:tc>
-              </a:tr>
-              <a:tr h="360000">
-                <a:tc>
-                  <a:txBody>
-                    <a:bodyPr/>
-                    <a:lstStyle/>
-                    <a:p>
-                      <a:pPr indent="0" lvl="0" marL="0" rtl="0" algn="l">
-                        <a:spcBef>
-                          <a:spcPts val="0"/>
-                        </a:spcBef>
-                        <a:spcAft>
-                          <a:spcPts val="0"/>
-                        </a:spcAft>
-                        <a:buNone/>
-                      </a:pPr>
-                      <a:r>
-                        <a:rPr lang="en-US" sz="900">
-                          <a:latin typeface="Times New Roman"/>
-                          <a:ea typeface="Times New Roman"/>
-                          <a:cs typeface="Times New Roman"/>
-                          <a:sym typeface="Times New Roman"/>
-                        </a:rPr>
-                        <a:t>t_high lowered by 0.08</a:t>
-                      </a:r>
-                    </a:p>
-                  </a:txBody>
-                  <a:tcPr marT="45720" marB="45720" marR="45720" marL="45720">
-                    <a:lnL cap="flat" cmpd="sng" w="19050">
-                      <a:solidFill>
-                        <a:srgbClr val="262626"/>
-                      </a:solidFill>
-                      <a:prstDash val="solid"/>
-                      <a:round/>
-                      <a:headEnd len="sm" w="sm" type="none"/>
-                      <a:tailEnd len="sm" w="sm" type="none"/>
-                    </a:lnL>
-                    <a:lnR cap="flat" cmpd="sng" w="19050">
-                      <a:solidFill>
-                        <a:srgbClr val="262626"/>
-                      </a:solidFill>
-                      <a:prstDash val="solid"/>
-                      <a:round/>
-                      <a:headEnd len="sm" w="sm" type="none"/>
-                      <a:tailEnd len="sm" w="sm" type="none"/>
-                    </a:lnR>
-                    <a:lnT cap="flat" cmpd="sng" w="19050">
-                      <a:solidFill>
-                        <a:srgbClr val="262626"/>
-                      </a:solidFill>
-                      <a:prstDash val="solid"/>
-                      <a:round/>
-                      <a:headEnd len="sm" w="sm" type="none"/>
-                      <a:tailEnd len="sm" w="sm" type="none"/>
-                    </a:lnT>
-                    <a:lnB cap="flat" cmpd="sng" w="19050">
-                      <a:solidFill>
-                        <a:srgbClr val="262626"/>
-                      </a:solidFill>
-                      <a:prstDash val="solid"/>
-                      <a:round/>
-                      <a:headEnd len="sm" w="sm" type="none"/>
-                      <a:tailEnd len="sm" w="sm" type="none"/>
-                    </a:lnB>
-                  </a:tcPr>
-                </a:tc>
-                <a:tc>
-                  <a:txBody>
-                    <a:bodyPr/>
-                    <a:lstStyle/>
-                    <a:p>
-                      <a:pPr indent="0" lvl="0" marL="0" rtl="0" algn="l">
-                        <a:spcBef>
-                          <a:spcPts val="0"/>
-                        </a:spcBef>
-                        <a:spcAft>
-                          <a:spcPts val="0"/>
-                        </a:spcAft>
-                        <a:buNone/>
-                      </a:pPr>
-                      <a:r>
-                        <a:rPr lang="en-US" sz="900">
-                          <a:latin typeface="Times New Roman"/>
-                          <a:ea typeface="Times New Roman"/>
-                          <a:cs typeface="Times New Roman"/>
-                          <a:sym typeface="Times New Roman"/>
-                        </a:rPr>
-                        <a:t>same</a:t>
-                      </a:r>
-                    </a:p>
-                  </a:txBody>
-                  <a:tcPr marT="45720" marB="45720" marR="45720" marL="45720">
-                    <a:lnL cap="flat" cmpd="sng" w="19050">
-                      <a:solidFill>
-                        <a:srgbClr val="262626"/>
-                      </a:solidFill>
-                      <a:prstDash val="solid"/>
-                      <a:round/>
-                      <a:headEnd len="sm" w="sm" type="none"/>
-                      <a:tailEnd len="sm" w="sm" type="none"/>
-                    </a:lnL>
-                    <a:lnR cap="flat" cmpd="sng" w="19050">
-                      <a:solidFill>
-                        <a:srgbClr val="262626"/>
-                      </a:solidFill>
-                      <a:prstDash val="solid"/>
-                      <a:round/>
-                      <a:headEnd len="sm" w="sm" type="none"/>
-                      <a:tailEnd len="sm" w="sm" type="none"/>
-                    </a:lnR>
-                    <a:lnT cap="flat" cmpd="sng" w="19050">
-                      <a:solidFill>
-                        <a:srgbClr val="262626"/>
-                      </a:solidFill>
-                      <a:prstDash val="solid"/>
-                      <a:round/>
-                      <a:headEnd len="sm" w="sm" type="none"/>
-                      <a:tailEnd len="sm" w="sm" type="none"/>
-                    </a:lnT>
-                    <a:lnB cap="flat" cmpd="sng" w="19050">
-                      <a:solidFill>
-                        <a:srgbClr val="262626"/>
-                      </a:solidFill>
-                      <a:prstDash val="solid"/>
-                      <a:round/>
-                      <a:headEnd len="sm" w="sm" type="none"/>
-                      <a:tailEnd len="sm" w="sm" type="none"/>
-                    </a:lnB>
-                  </a:tcPr>
-                </a:tc>
-                <a:tc>
-                  <a:txBody>
-                    <a:bodyPr/>
-                    <a:lstStyle/>
-                    <a:p>
-                      <a:pPr indent="0" lvl="0" marL="0" rtl="0" algn="l">
-                        <a:spcBef>
-                          <a:spcPts val="0"/>
-                        </a:spcBef>
-                        <a:spcAft>
-                          <a:spcPts val="0"/>
-                        </a:spcAft>
-                        <a:buNone/>
-                      </a:pPr>
-                      <a:r>
-                        <a:rPr lang="en-US" sz="900">
-                          <a:latin typeface="Times New Roman"/>
-                          <a:ea typeface="Times New Roman"/>
-                          <a:cs typeface="Times New Roman"/>
-                          <a:sym typeface="Times New Roman"/>
-                        </a:rPr>
                         <a:t>− 0.08</a:t>
                       </a:r>
                     </a:p>
@@ -21777,7 +21777,7 @@
                           <a:cs typeface="Times New Roman"/>
                           <a:sym typeface="Times New Roman"/>
                         </a:rPr>
-                        <a:t>t_high lowered by 0.13</a:t>
+                        <a:t>Unseen apps: 0.26 → 0.40</a:t>
                       </a:r>
                     </a:p>
                   </a:txBody>
@@ -21841,7 +21841,7 @@
                           <a:cs typeface="Times New Roman"/>
                           <a:sym typeface="Times New Roman"/>
                         </a:rPr>
-                        <a:t>same</a:t>
+                        <a:t>0.26 → 0.40</a:t>
                       </a:r>
                     </a:p>
                   </a:txBody>
@@ -21905,7 +21905,7 @@
                           <a:cs typeface="Times New Roman"/>
                           <a:sym typeface="Times New Roman"/>
                         </a:rPr>
-                        <a:t>− 0.13</a:t>
+                        <a:t>0.8306</a:t>
                       </a:r>
                     </a:p>
                   </a:txBody>
@@ -21969,7 +21969,7 @@
                           <a:cs typeface="Times New Roman"/>
                           <a:sym typeface="Times New Roman"/>
                         </a:rPr>
-                        <a:t>0.722</a:t>
+                        <a:t>0.608 → 0.635</a:t>
                       </a:r>
                     </a:p>
                   </a:txBody>
@@ -22033,329 +22033,7 @@
                           <a:cs typeface="Times New Roman"/>
                           <a:sym typeface="Times New Roman"/>
                         </a:rPr>
-                        <a:t>0.246</a:t>
-                      </a:r>
-                    </a:p>
-                  </a:txBody>
-                  <a:tcPr marT="45720" marB="45720" marR="45720" marL="45720">
-                    <a:lnL cap="flat" cmpd="sng" w="19050">
-                      <a:solidFill>
-                        <a:srgbClr val="262626"/>
-                      </a:solidFill>
-                      <a:prstDash val="solid"/>
-                      <a:round/>
-                      <a:headEnd len="sm" w="sm" type="none"/>
-                      <a:tailEnd len="sm" w="sm" type="none"/>
-                    </a:lnL>
-                    <a:lnR cap="flat" cmpd="sng" w="19050">
-                      <a:solidFill>
-                        <a:srgbClr val="262626"/>
-                      </a:solidFill>
-                      <a:prstDash val="solid"/>
-                      <a:round/>
-                      <a:headEnd len="sm" w="sm" type="none"/>
-                      <a:tailEnd len="sm" w="sm" type="none"/>
-                    </a:lnR>
-                    <a:lnT cap="flat" cmpd="sng" w="19050">
-                      <a:solidFill>
-                        <a:srgbClr val="262626"/>
-                      </a:solidFill>
-                      <a:prstDash val="solid"/>
-                      <a:round/>
-                      <a:headEnd len="sm" w="sm" type="none"/>
-                      <a:tailEnd len="sm" w="sm" type="none"/>
-                    </a:lnT>
-                    <a:lnB cap="flat" cmpd="sng" w="19050">
-                      <a:solidFill>
-                        <a:srgbClr val="262626"/>
-                      </a:solidFill>
-                      <a:prstDash val="solid"/>
-                      <a:round/>
-                      <a:headEnd len="sm" w="sm" type="none"/>
-                      <a:tailEnd len="sm" w="sm" type="none"/>
-                    </a:lnB>
-                  </a:tcPr>
-                </a:tc>
-                <a:tc>
-                  <a:txBody>
-                    <a:bodyPr/>
-                    <a:lstStyle/>
-                    <a:p>
-                      <a:pPr indent="0" lvl="0" marL="0" rtl="0" algn="l">
-                        <a:spcBef>
-                          <a:spcPts val="0"/>
-                        </a:spcBef>
-                        <a:spcAft>
-                          <a:spcPts val="0"/>
-                        </a:spcAft>
-                        <a:buNone/>
-                      </a:pPr>
-                      <a:r>
-                        <a:rPr lang="en-US" sz="900">
-                          <a:latin typeface="Times New Roman"/>
-                          <a:ea typeface="Times New Roman"/>
-                          <a:cs typeface="Times New Roman"/>
-                          <a:sym typeface="Times New Roman"/>
-                        </a:rPr>
-                        <a:t>0.367</a:t>
-                      </a:r>
-                    </a:p>
-                  </a:txBody>
-                  <a:tcPr marT="45720" marB="45720" marR="45720" marL="45720">
-                    <a:lnL cap="flat" cmpd="sng" w="19050">
-                      <a:solidFill>
-                        <a:srgbClr val="262626"/>
-                      </a:solidFill>
-                      <a:prstDash val="solid"/>
-                      <a:round/>
-                      <a:headEnd len="sm" w="sm" type="none"/>
-                      <a:tailEnd len="sm" w="sm" type="none"/>
-                    </a:lnL>
-                    <a:lnR cap="flat" cmpd="sng" w="19050">
-                      <a:solidFill>
-                        <a:srgbClr val="262626"/>
-                      </a:solidFill>
-                      <a:prstDash val="solid"/>
-                      <a:round/>
-                      <a:headEnd len="sm" w="sm" type="none"/>
-                      <a:tailEnd len="sm" w="sm" type="none"/>
-                    </a:lnR>
-                    <a:lnT cap="flat" cmpd="sng" w="19050">
-                      <a:solidFill>
-                        <a:srgbClr val="262626"/>
-                      </a:solidFill>
-                      <a:prstDash val="solid"/>
-                      <a:round/>
-                      <a:headEnd len="sm" w="sm" type="none"/>
-                      <a:tailEnd len="sm" w="sm" type="none"/>
-                    </a:lnT>
-                    <a:lnB cap="flat" cmpd="sng" w="19050">
-                      <a:solidFill>
-                        <a:srgbClr val="262626"/>
-                      </a:solidFill>
-                      <a:prstDash val="solid"/>
-                      <a:round/>
-                      <a:headEnd len="sm" w="sm" type="none"/>
-                      <a:tailEnd len="sm" w="sm" type="none"/>
-                    </a:lnB>
-                  </a:tcPr>
-                </a:tc>
-                <a:tc>
-                  <a:txBody>
-                    <a:bodyPr/>
-                    <a:lstStyle/>
-                    <a:p>
-                      <a:pPr indent="0" lvl="0" marL="0" rtl="0" algn="l">
-                        <a:spcBef>
-                          <a:spcPts val="0"/>
-                        </a:spcBef>
-                        <a:spcAft>
-                          <a:spcPts val="0"/>
-                        </a:spcAft>
-                        <a:buNone/>
-                      </a:pPr>
-                      <a:r>
-                        <a:rPr lang="en-US" sz="900">
-                          <a:latin typeface="Times New Roman"/>
-                          <a:ea typeface="Times New Roman"/>
-                          <a:cs typeface="Times New Roman"/>
-                          <a:sym typeface="Times New Roman"/>
-                        </a:rPr>
-                        <a:t>68%</a:t>
-                      </a:r>
-                    </a:p>
-                  </a:txBody>
-                  <a:tcPr marT="45720" marB="45720" marR="45720" marL="45720">
-                    <a:lnL cap="flat" cmpd="sng" w="19050">
-                      <a:solidFill>
-                        <a:srgbClr val="262626"/>
-                      </a:solidFill>
-                      <a:prstDash val="solid"/>
-                      <a:round/>
-                      <a:headEnd len="sm" w="sm" type="none"/>
-                      <a:tailEnd len="sm" w="sm" type="none"/>
-                    </a:lnL>
-                    <a:lnR cap="flat" cmpd="sng" w="19050">
-                      <a:solidFill>
-                        <a:srgbClr val="262626"/>
-                      </a:solidFill>
-                      <a:prstDash val="solid"/>
-                      <a:round/>
-                      <a:headEnd len="sm" w="sm" type="none"/>
-                      <a:tailEnd len="sm" w="sm" type="none"/>
-                    </a:lnR>
-                    <a:lnT cap="flat" cmpd="sng" w="19050">
-                      <a:solidFill>
-                        <a:srgbClr val="262626"/>
-                      </a:solidFill>
-                      <a:prstDash val="solid"/>
-                      <a:round/>
-                      <a:headEnd len="sm" w="sm" type="none"/>
-                      <a:tailEnd len="sm" w="sm" type="none"/>
-                    </a:lnT>
-                    <a:lnB cap="flat" cmpd="sng" w="19050">
-                      <a:solidFill>
-                        <a:srgbClr val="262626"/>
-                      </a:solidFill>
-                      <a:prstDash val="solid"/>
-                      <a:round/>
-                      <a:headEnd len="sm" w="sm" type="none"/>
-                      <a:tailEnd len="sm" w="sm" type="none"/>
-                    </a:lnB>
-                  </a:tcPr>
-                </a:tc>
-              </a:tr>
-              <a:tr h="360000">
-                <a:tc>
-                  <a:txBody>
-                    <a:bodyPr/>
-                    <a:lstStyle/>
-                    <a:p>
-                      <a:pPr indent="0" lvl="0" marL="0" rtl="0" algn="l">
-                        <a:spcBef>
-                          <a:spcPts val="0"/>
-                        </a:spcBef>
-                        <a:spcAft>
-                          <a:spcPts val="0"/>
-                        </a:spcAft>
-                        <a:buNone/>
-                      </a:pPr>
-                      <a:r>
-                        <a:rPr lang="en-US" sz="900">
-                          <a:latin typeface="Times New Roman"/>
-                          <a:ea typeface="Times New Roman"/>
-                          <a:cs typeface="Times New Roman"/>
-                          <a:sym typeface="Times New Roman"/>
-                        </a:rPr>
-                        <a:t>Single cosine threshold, no judge</a:t>
-                      </a:r>
-                    </a:p>
-                  </a:txBody>
-                  <a:tcPr marT="45720" marB="45720" marR="45720" marL="45720">
-                    <a:lnL cap="flat" cmpd="sng" w="19050">
-                      <a:solidFill>
-                        <a:srgbClr val="262626"/>
-                      </a:solidFill>
-                      <a:prstDash val="solid"/>
-                      <a:round/>
-                      <a:headEnd len="sm" w="sm" type="none"/>
-                      <a:tailEnd len="sm" w="sm" type="none"/>
-                    </a:lnL>
-                    <a:lnR cap="flat" cmpd="sng" w="19050">
-                      <a:solidFill>
-                        <a:srgbClr val="262626"/>
-                      </a:solidFill>
-                      <a:prstDash val="solid"/>
-                      <a:round/>
-                      <a:headEnd len="sm" w="sm" type="none"/>
-                      <a:tailEnd len="sm" w="sm" type="none"/>
-                    </a:lnR>
-                    <a:lnT cap="flat" cmpd="sng" w="19050">
-                      <a:solidFill>
-                        <a:srgbClr val="262626"/>
-                      </a:solidFill>
-                      <a:prstDash val="solid"/>
-                      <a:round/>
-                      <a:headEnd len="sm" w="sm" type="none"/>
-                      <a:tailEnd len="sm" w="sm" type="none"/>
-                    </a:lnT>
-                    <a:lnB cap="flat" cmpd="sng" w="19050">
-                      <a:solidFill>
-                        <a:srgbClr val="262626"/>
-                      </a:solidFill>
-                      <a:prstDash val="solid"/>
-                      <a:round/>
-                      <a:headEnd len="sm" w="sm" type="none"/>
-                      <a:tailEnd len="sm" w="sm" type="none"/>
-                    </a:lnB>
-                  </a:tcPr>
-                </a:tc>
-                <a:tc>
-                  <a:txBody>
-                    <a:bodyPr/>
-                    <a:lstStyle/>
-                    <a:p>
-                      <a:pPr indent="0" lvl="0" marL="0" rtl="0" algn="l">
-                        <a:spcBef>
-                          <a:spcPts val="0"/>
-                        </a:spcBef>
-                        <a:spcAft>
-                          <a:spcPts val="0"/>
-                        </a:spcAft>
-                        <a:buNone/>
-                      </a:pPr>
-                      <a:r>
-                        <a:rPr lang="en-US" sz="900">
-                          <a:latin typeface="Times New Roman"/>
-                          <a:ea typeface="Times New Roman"/>
-                          <a:cs typeface="Times New Roman"/>
-                          <a:sym typeface="Times New Roman"/>
-                        </a:rPr>
-                        <a:t>one cut</a:t>
-                      </a:r>
-                    </a:p>
-                  </a:txBody>
-                  <a:tcPr marT="45720" marB="45720" marR="45720" marL="45720">
-                    <a:lnL cap="flat" cmpd="sng" w="19050">
-                      <a:solidFill>
-                        <a:srgbClr val="262626"/>
-                      </a:solidFill>
-                      <a:prstDash val="solid"/>
-                      <a:round/>
-                      <a:headEnd len="sm" w="sm" type="none"/>
-                      <a:tailEnd len="sm" w="sm" type="none"/>
-                    </a:lnL>
-                    <a:lnR cap="flat" cmpd="sng" w="19050">
-                      <a:solidFill>
-                        <a:srgbClr val="262626"/>
-                      </a:solidFill>
-                      <a:prstDash val="solid"/>
-                      <a:round/>
-                      <a:headEnd len="sm" w="sm" type="none"/>
-                      <a:tailEnd len="sm" w="sm" type="none"/>
-                    </a:lnR>
-                    <a:lnT cap="flat" cmpd="sng" w="19050">
-                      <a:solidFill>
-                        <a:srgbClr val="262626"/>
-                      </a:solidFill>
-                      <a:prstDash val="solid"/>
-                      <a:round/>
-                      <a:headEnd len="sm" w="sm" type="none"/>
-                      <a:tailEnd len="sm" w="sm" type="none"/>
-                    </a:lnT>
-                    <a:lnB cap="flat" cmpd="sng" w="19050">
-                      <a:solidFill>
-                        <a:srgbClr val="262626"/>
-                      </a:solidFill>
-                      <a:prstDash val="solid"/>
-                      <a:round/>
-                      <a:headEnd len="sm" w="sm" type="none"/>
-                      <a:tailEnd len="sm" w="sm" type="none"/>
-                    </a:lnB>
-                  </a:tcPr>
-                </a:tc>
-                <a:tc>
-                  <a:txBody>
-                    <a:bodyPr/>
-                    <a:lstStyle/>
-                    <a:p>
-                      <a:pPr indent="0" lvl="0" marL="0" rtl="0" algn="l">
-                        <a:spcBef>
-                          <a:spcPts val="0"/>
-                        </a:spcBef>
-                        <a:spcAft>
-                          <a:spcPts val="0"/>
-                        </a:spcAft>
-                        <a:buNone/>
-                      </a:pPr>
-                      <a:r>
-                        <a:rPr lang="en-US" sz="900">
-                          <a:latin typeface="Times New Roman"/>
-                          <a:ea typeface="Times New Roman"/>
-                          <a:cs typeface="Times New Roman"/>
-                          <a:sym typeface="Times New Roman"/>
-                        </a:rPr>
-                        <a:t>one cut</a:t>
+                        <a:t>0.284 → 0.255</a:t>
                       </a:r>
                     </a:p>
                   </a:txBody>
@@ -22483,7 +22161,73 @@
                           <a:cs typeface="Times New Roman"/>
                           <a:sym typeface="Times New Roman"/>
                         </a:rPr>
-                        <a:t>–</a:t>
+                        <a:t>94% → 77%</a:t>
+                      </a:r>
+                    </a:p>
+                  </a:txBody>
+                  <a:tcPr marT="45720" marB="45720" marR="45720" marL="45720">
+                    <a:lnL cap="flat" cmpd="sng" w="19050">
+                      <a:solidFill>
+                        <a:srgbClr val="262626"/>
+                      </a:solidFill>
+                      <a:prstDash val="solid"/>
+                      <a:round/>
+                      <a:headEnd len="sm" w="sm" type="none"/>
+                      <a:tailEnd len="sm" w="sm" type="none"/>
+                    </a:lnL>
+                    <a:lnR cap="flat" cmpd="sng" w="19050">
+                      <a:solidFill>
+                        <a:srgbClr val="262626"/>
+                      </a:solidFill>
+                      <a:prstDash val="solid"/>
+                      <a:round/>
+                      <a:headEnd len="sm" w="sm" type="none"/>
+                      <a:tailEnd len="sm" w="sm" type="none"/>
+                    </a:lnR>
+                    <a:lnT cap="flat" cmpd="sng" w="19050">
+                      <a:solidFill>
+                        <a:srgbClr val="262626"/>
+                      </a:solidFill>
+                      <a:prstDash val="solid"/>
+                      <a:round/>
+                      <a:headEnd len="sm" w="sm" type="none"/>
+                      <a:tailEnd len="sm" w="sm" type="none"/>
+                    </a:lnT>
+                    <a:lnB cap="flat" cmpd="sng" w="19050">
+                      <a:solidFill>
+                        <a:srgbClr val="262626"/>
+                      </a:solidFill>
+                      <a:prstDash val="solid"/>
+                      <a:round/>
+                      <a:headEnd len="sm" w="sm" type="none"/>
+                      <a:tailEnd len="sm" w="sm" type="none"/>
+                    </a:lnB>
+                  </a:tcPr>
+                </a:tc>
+              </a:tr>
+              <a:tr h="360000">
+                <a:tc>
+                  <a:txBody>
+                    <a:bodyPr/>
+                    <a:lstStyle/>
+                    <a:p>
+                      <a:pPr indent="0" lvl="0" marL="0" rtl="0" algn="l">
+                        <a:spcBef>
+                          <a:spcPts val="0"/>
+                        </a:spcBef>
+                        <a:spcAft>
+                          <a:spcPts val="0"/>
+                        </a:spcAft>
+                        <a:buNone/>
+                      </a:pPr>
+                      <a:r>
+                        <a:rPr lang="en-US" sz="900">
+                          <a:latin typeface="Times New Roman"/>
+                          <a:ea typeface="Times New Roman"/>
+                          <a:cs typeface="Times New Roman"/>
+                          <a:sym typeface="Times New Roman"/>
+                        </a:rPr>
+                        <a:t>Bug reports: 0.26 → 0.40</a:t>
                       </a:r>
                     </a:p>
                   </a:txBody>
@@ -22547,7 +22291,7 @@
                           <a:cs typeface="Times New Roman"/>
                           <a:sym typeface="Times New Roman"/>
                         </a:rPr>
-                        <a:t>≈ 0.10</a:t>
+                        <a:t>0.26 → 0.40</a:t>
                       </a:r>
                     </a:p>
                   </a:txBody>
@@ -22611,7 +22355,263 @@
                           <a:cs typeface="Times New Roman"/>
                           <a:sym typeface="Times New Roman"/>
                         </a:rPr>
-                        <a:t>0%</a:t>
+                        <a:t>0.8306</a:t>
+                      </a:r>
+                    </a:p>
+                  </a:txBody>
+                  <a:tcPr marT="45720" marB="45720" marR="45720" marL="45720">
+                    <a:lnL cap="flat" cmpd="sng" w="19050">
+                      <a:solidFill>
+                        <a:srgbClr val="262626"/>
+                      </a:solidFill>
+                      <a:prstDash val="solid"/>
+                      <a:round/>
+                      <a:headEnd len="sm" w="sm" type="none"/>
+                      <a:tailEnd len="sm" w="sm" type="none"/>
+                    </a:lnL>
+                    <a:lnR cap="flat" cmpd="sng" w="19050">
+                      <a:solidFill>
+                        <a:srgbClr val="262626"/>
+                      </a:solidFill>
+                      <a:prstDash val="solid"/>
+                      <a:round/>
+                      <a:headEnd len="sm" w="sm" type="none"/>
+                      <a:tailEnd len="sm" w="sm" type="none"/>
+                    </a:lnR>
+                    <a:lnT cap="flat" cmpd="sng" w="19050">
+                      <a:solidFill>
+                        <a:srgbClr val="262626"/>
+                      </a:solidFill>
+                      <a:prstDash val="solid"/>
+                      <a:round/>
+                      <a:headEnd len="sm" w="sm" type="none"/>
+                      <a:tailEnd len="sm" w="sm" type="none"/>
+                    </a:lnT>
+                    <a:lnB cap="flat" cmpd="sng" w="19050">
+                      <a:solidFill>
+                        <a:srgbClr val="262626"/>
+                      </a:solidFill>
+                      <a:prstDash val="solid"/>
+                      <a:round/>
+                      <a:headEnd len="sm" w="sm" type="none"/>
+                      <a:tailEnd len="sm" w="sm" type="none"/>
+                    </a:lnB>
+                  </a:tcPr>
+                </a:tc>
+                <a:tc>
+                  <a:txBody>
+                    <a:bodyPr/>
+                    <a:lstStyle/>
+                    <a:p>
+                      <a:pPr indent="0" lvl="0" marL="0" rtl="0" algn="l">
+                        <a:spcBef>
+                          <a:spcPts val="0"/>
+                        </a:spcBef>
+                        <a:spcAft>
+                          <a:spcPts val="0"/>
+                        </a:spcAft>
+                        <a:buNone/>
+                      </a:pPr>
+                      <a:r>
+                        <a:rPr lang="en-US" sz="900">
+                          <a:latin typeface="Times New Roman"/>
+                          <a:ea typeface="Times New Roman"/>
+                          <a:cs typeface="Times New Roman"/>
+                          <a:sym typeface="Times New Roman"/>
+                        </a:rPr>
+                        <a:t>0.908 → 0.912</a:t>
+                      </a:r>
+                    </a:p>
+                  </a:txBody>
+                  <a:tcPr marT="45720" marB="45720" marR="45720" marL="45720">
+                    <a:lnL cap="flat" cmpd="sng" w="19050">
+                      <a:solidFill>
+                        <a:srgbClr val="262626"/>
+                      </a:solidFill>
+                      <a:prstDash val="solid"/>
+                      <a:round/>
+                      <a:headEnd len="sm" w="sm" type="none"/>
+                      <a:tailEnd len="sm" w="sm" type="none"/>
+                    </a:lnL>
+                    <a:lnR cap="flat" cmpd="sng" w="19050">
+                      <a:solidFill>
+                        <a:srgbClr val="262626"/>
+                      </a:solidFill>
+                      <a:prstDash val="solid"/>
+                      <a:round/>
+                      <a:headEnd len="sm" w="sm" type="none"/>
+                      <a:tailEnd len="sm" w="sm" type="none"/>
+                    </a:lnR>
+                    <a:lnT cap="flat" cmpd="sng" w="19050">
+                      <a:solidFill>
+                        <a:srgbClr val="262626"/>
+                      </a:solidFill>
+                      <a:prstDash val="solid"/>
+                      <a:round/>
+                      <a:headEnd len="sm" w="sm" type="none"/>
+                      <a:tailEnd len="sm" w="sm" type="none"/>
+                    </a:lnT>
+                    <a:lnB cap="flat" cmpd="sng" w="19050">
+                      <a:solidFill>
+                        <a:srgbClr val="262626"/>
+                      </a:solidFill>
+                      <a:prstDash val="solid"/>
+                      <a:round/>
+                      <a:headEnd len="sm" w="sm" type="none"/>
+                      <a:tailEnd len="sm" w="sm" type="none"/>
+                    </a:lnB>
+                  </a:tcPr>
+                </a:tc>
+                <a:tc>
+                  <a:txBody>
+                    <a:bodyPr/>
+                    <a:lstStyle/>
+                    <a:p>
+                      <a:pPr indent="0" lvl="0" marL="0" rtl="0" algn="l">
+                        <a:spcBef>
+                          <a:spcPts val="0"/>
+                        </a:spcBef>
+                        <a:spcAft>
+                          <a:spcPts val="0"/>
+                        </a:spcAft>
+                        <a:buNone/>
+                      </a:pPr>
+                      <a:r>
+                        <a:rPr lang="en-US" sz="900">
+                          <a:latin typeface="Times New Roman"/>
+                          <a:ea typeface="Times New Roman"/>
+                          <a:cs typeface="Times New Roman"/>
+                          <a:sym typeface="Times New Roman"/>
+                        </a:rPr>
+                        <a:t>0.578 → 0.571</a:t>
+                      </a:r>
+                    </a:p>
+                  </a:txBody>
+                  <a:tcPr marT="45720" marB="45720" marR="45720" marL="45720">
+                    <a:lnL cap="flat" cmpd="sng" w="19050">
+                      <a:solidFill>
+                        <a:srgbClr val="262626"/>
+                      </a:solidFill>
+                      <a:prstDash val="solid"/>
+                      <a:round/>
+                      <a:headEnd len="sm" w="sm" type="none"/>
+                      <a:tailEnd len="sm" w="sm" type="none"/>
+                    </a:lnL>
+                    <a:lnR cap="flat" cmpd="sng" w="19050">
+                      <a:solidFill>
+                        <a:srgbClr val="262626"/>
+                      </a:solidFill>
+                      <a:prstDash val="solid"/>
+                      <a:round/>
+                      <a:headEnd len="sm" w="sm" type="none"/>
+                      <a:tailEnd len="sm" w="sm" type="none"/>
+                    </a:lnR>
+                    <a:lnT cap="flat" cmpd="sng" w="19050">
+                      <a:solidFill>
+                        <a:srgbClr val="262626"/>
+                      </a:solidFill>
+                      <a:prstDash val="solid"/>
+                      <a:round/>
+                      <a:headEnd len="sm" w="sm" type="none"/>
+                      <a:tailEnd len="sm" w="sm" type="none"/>
+                    </a:lnT>
+                    <a:lnB cap="flat" cmpd="sng" w="19050">
+                      <a:solidFill>
+                        <a:srgbClr val="262626"/>
+                      </a:solidFill>
+                      <a:prstDash val="solid"/>
+                      <a:round/>
+                      <a:headEnd len="sm" w="sm" type="none"/>
+                      <a:tailEnd len="sm" w="sm" type="none"/>
+                    </a:lnB>
+                  </a:tcPr>
+                </a:tc>
+                <a:tc>
+                  <a:txBody>
+                    <a:bodyPr/>
+                    <a:lstStyle/>
+                    <a:p>
+                      <a:pPr indent="0" lvl="0" marL="0" rtl="0" algn="l">
+                        <a:spcBef>
+                          <a:spcPts val="0"/>
+                        </a:spcBef>
+                        <a:spcAft>
+                          <a:spcPts val="0"/>
+                        </a:spcAft>
+                        <a:buNone/>
+                      </a:pPr>
+                      <a:r>
+                        <a:rPr lang="en-US" sz="900">
+                          <a:latin typeface="Times New Roman"/>
+                          <a:ea typeface="Times New Roman"/>
+                          <a:cs typeface="Times New Roman"/>
+                          <a:sym typeface="Times New Roman"/>
+                        </a:rPr>
+                        <a:t>–</a:t>
+                      </a:r>
+                    </a:p>
+                  </a:txBody>
+                  <a:tcPr marT="45720" marB="45720" marR="45720" marL="45720">
+                    <a:lnL cap="flat" cmpd="sng" w="19050">
+                      <a:solidFill>
+                        <a:srgbClr val="262626"/>
+                      </a:solidFill>
+                      <a:prstDash val="solid"/>
+                      <a:round/>
+                      <a:headEnd len="sm" w="sm" type="none"/>
+                      <a:tailEnd len="sm" w="sm" type="none"/>
+                    </a:lnL>
+                    <a:lnR cap="flat" cmpd="sng" w="19050">
+                      <a:solidFill>
+                        <a:srgbClr val="262626"/>
+                      </a:solidFill>
+                      <a:prstDash val="solid"/>
+                      <a:round/>
+                      <a:headEnd len="sm" w="sm" type="none"/>
+                      <a:tailEnd len="sm" w="sm" type="none"/>
+                    </a:lnR>
+                    <a:lnT cap="flat" cmpd="sng" w="19050">
+                      <a:solidFill>
+                        <a:srgbClr val="262626"/>
+                      </a:solidFill>
+                      <a:prstDash val="solid"/>
+                      <a:round/>
+                      <a:headEnd len="sm" w="sm" type="none"/>
+                      <a:tailEnd len="sm" w="sm" type="none"/>
+                    </a:lnT>
+                    <a:lnB cap="flat" cmpd="sng" w="19050">
+                      <a:solidFill>
+                        <a:srgbClr val="262626"/>
+                      </a:solidFill>
+                      <a:prstDash val="solid"/>
+                      <a:round/>
+                      <a:headEnd len="sm" w="sm" type="none"/>
+                      <a:tailEnd len="sm" w="sm" type="none"/>
+                    </a:lnB>
+                  </a:tcPr>
+                </a:tc>
+                <a:tc>
+                  <a:txBody>
+                    <a:bodyPr/>
+                    <a:lstStyle/>
+                    <a:p>
+                      <a:pPr indent="0" lvl="0" marL="0" rtl="0" algn="l">
+                        <a:spcBef>
+                          <a:spcPts val="0"/>
+                        </a:spcBef>
+                        <a:spcAft>
+                          <a:spcPts val="0"/>
+                        </a:spcAft>
+                        <a:buNone/>
+                      </a:pPr>
+                      <a:r>
+                        <a:rPr lang="en-US" sz="900">
+                          <a:latin typeface="Times New Roman"/>
+                          <a:ea typeface="Times New Roman"/>
+                          <a:cs typeface="Times New Roman"/>
+                          <a:sym typeface="Times New Roman"/>
+                        </a:rPr>
+                        <a:t>96% → 90%</a:t>
                       </a:r>
                     </a:p>
                   </a:txBody>
@@ -22815,7 +22815,7 @@
         <p:spPr>
           <a:xfrm>
             <a:off x="497000" y="4360000"/>
-            <a:ext cx="8150000" cy="420000"/>
+            <a:ext cx="8100000" cy="420000"/>
           </a:xfrm>
           <a:prstGeom prst="rect">
             <a:avLst/>
@@ -22850,7 +22850,7 @@
                 <a:cs typeface="Times New Roman"/>
                 <a:sym typeface="Times New Roman"/>
               </a:rPr>
-              <a:t xml:space="preserve">Play Store held-out halves pooled, live judge calls. Recall is stable across settings; a higher t_low raises precision and cuts LLM calls, so the 20th-percentile rule is conservative. Final values (t_low 0.26, t_high 0.8306) transfer unchanged to Firefox, Thunderbird and unseen apps (precision 0.87–0.96).</a:t>
+              <a:t xml:space="preserve">Play Store held-out halves pooled, live judge calls. t_low = 0.40 was confirmed on unseen short reviews under a rule written before the run and is used for app reviews and chat; it changed little on long bug reports, so tickets and bug reports keep 0.26. t_high 0.8306 transfers unchanged everywhere.</a:t>
             </a:r>
           </a:p>
         </p:txBody>

</xml_diff>

<commit_message>
Deck: 3 annotators (Fleiss kappa), Endava full-run result in the datasets table
</commit_message>
<xml_diff>
--- a/reports/ppt/InsightDesk_final.pptx
+++ b/reports/ppt/InsightDesk_final.pptx
@@ -27760,7 +27760,7 @@
                           <a:cs typeface="Times New Roman"/>
                           <a:sym typeface="Times New Roman"/>
                         </a:rPr>
-                        <a:t>2 team annotators, written codebook</a:t>
+                        <a:t>3 team annotators, written codebook</a:t>
                       </a:r>
                     </a:p>
                   </a:txBody>
@@ -27824,7 +27824,7 @@
                           <a:cs typeface="Times New Roman"/>
                           <a:sym typeface="Times New Roman"/>
                         </a:rPr>
-                        <a:t>κ = 0.74; LLM labellers agree with humans at κ 0.68–0.70</a:t>
+                        <a:t>Fleiss κ = 0.74 across all 3; LLM labellers agree with humans at κ 0.68–0.70</a:t>
                       </a:r>
                     </a:p>
                   </a:txBody>
@@ -28984,7 +28984,7 @@
                           <a:cs typeface="Times New Roman"/>
                           <a:sym typeface="Times New Roman"/>
                         </a:rPr>
-                        <a:t>350 of 1,000</a:t>
+                        <a:t>1,000 tickets</a:t>
                       </a:r>
                     </a:p>
                   </a:txBody>
@@ -29112,7 +29112,7 @@
                           <a:cs typeface="Times New Roman"/>
                           <a:sym typeface="Times New Roman"/>
                         </a:rPr>
-                        <a:t>Partial run, preliminary</a:t>
+                        <a:t>Case precision 0.90 vs 0.66 (cross-encoder); F1 tied</a:t>
                       </a:r>
                     </a:p>
                   </a:txBody>

</xml_diff>

<commit_message>
Deck: deployed short-text results (P 0.83, R 0.35, F1 0.49), new problem statement, charts, flowchart band, slide order
Co-Authored-By: Claude Opus 5.5 <noreply@anthropic.com>
</commit_message>
<xml_diff>
--- a/reports/ppt/InsightDesk_final.pptx
+++ b/reports/ppt/InsightDesk_final.pptx
@@ -19,10 +19,10 @@
     <p:sldId id="262" r:id="rId13"/>
     <p:sldId id="263" r:id="rId14"/>
     <p:sldId id="275" r:id="rId26"/>
+    <p:sldId id="279" r:id="rId30"/>
+    <p:sldId id="278" r:id="rId29"/>
     <p:sldId id="276" r:id="rId27"/>
     <p:sldId id="277" r:id="rId28"/>
-    <p:sldId id="278" r:id="rId29"/>
-    <p:sldId id="279" r:id="rId30"/>
     <p:sldId id="264" r:id="rId15"/>
     <p:sldId id="273" r:id="rId24"/>
     <p:sldId id="274" r:id="rId25"/>
@@ -9845,8 +9845,8 @@
         </p:nvSpPr>
         <p:spPr>
           <a:xfrm>
-            <a:off x="686435" y="1648460"/>
-            <a:ext cx="7764780" cy="2457450"/>
+            <a:off x="686435" y="1960000"/>
+            <a:ext cx="7764780" cy="2700000"/>
           </a:xfrm>
           <a:prstGeom prst="rect">
             <a:avLst/>
@@ -9881,7 +9881,7 @@
                 <a:cs typeface="Times New Roman"/>
                 <a:sym typeface="Times New Roman"/>
               </a:rPr>
-              <a:t xml:space="preserve">InsightDesk turns raw customer complaints into problem cases as they arrive. Similarity retrieval narrows each complaint to a few candidate cases, calibrated thresholds settle the clear ones, and an LLM judge decides the rest; a re-joining pass merges split cases. On real reviews it reaches precision 0.80 and the highest F1 of every method tested, and it transfers unchanged to bug reports. A Poisson CUSUM and a vague-complaint alarm detect incidents that the usual z-score misses, and every escalation is approved by a person before an email reaches the department.</a:t>
+              <a:t xml:space="preserve">InsightDesk turns raw customer complaints into problem cases as they arrive. Similarity retrieval narrows each complaint to a few candidate cases, calibrated thresholds settle the clear ones, and an LLM judge decides the rest; a re-joining pass merges split cases. On real reviews it reaches precision 0.83, recall 0.35 and F1 0.49, the highest of every method tested; a higher lower threshold for short-text channels improved precision and recall together while cutting LLM calls by about a quarter, and the same upper threshold transfers unchanged to bug reports (F1 0.78). A Poisson CUSUM and a vague-complaint alarm detect incidents that the usual z-score misses, and every escalation is approved by a person before an email reaches the department.</a:t>
             </a:r>
           </a:p>
         </p:txBody>
@@ -13349,153 +13349,6 @@
           </a:graphicData>
         </a:graphic>
       </p:graphicFrame>
-      <p:graphicFrame>
-        <p:nvGraphicFramePr>
-          <p:cNvPr id="73" name="Google Shape;73;p11"/>
-          <p:cNvGraphicFramePr/>
-          <p:nvPr/>
-        </p:nvGraphicFramePr>
-        <p:xfrm>
-          <a:off x="152400" y="152400"/>
-          <a:ext cx="3000000" cy="3000000"/>
-        </p:xfrm>
-        <a:graphic>
-          <a:graphicData uri="http://schemas.openxmlformats.org/drawingml/2006/table">
-            <a:tbl>
-              <a:tblPr>
-                <a:noFill/>
-                <a:tableStyleId>{AE357F98-E37F-4722-A336-238EF99134D1}</a:tableStyleId>
-              </a:tblPr>
-              <a:tblGrid>
-                <a:gridCol w="19050"/>
-              </a:tblGrid>
-              <a:tr h="19050">
-                <a:tc>
-                  <a:txBody>
-                    <a:bodyPr/>
-                    <a:lstStyle/>
-                    <a:p>
-                      <a:pPr indent="0" lvl="0" marL="0" rtl="0" algn="l">
-                        <a:spcBef>
-                          <a:spcPts val="0"/>
-                        </a:spcBef>
-                        <a:spcAft>
-                          <a:spcPts val="0"/>
-                        </a:spcAft>
-                        <a:buNone/>
-                      </a:pPr>
-                      <a:r>
-                        <a:t/>
-                      </a:r>
-                      <a:endParaRPr/>
-                    </a:p>
-                  </a:txBody>
-                  <a:tcPr marT="91425" marB="91425" marR="91425" marL="91425"/>
-                </a:tc>
-              </a:tr>
-            </a:tbl>
-          </a:graphicData>
-        </a:graphic>
-      </p:graphicFrame>
-      <p:graphicFrame>
-        <p:nvGraphicFramePr>
-          <p:cNvPr id="74" name="Google Shape;74;p11"/>
-          <p:cNvGraphicFramePr/>
-          <p:nvPr/>
-        </p:nvGraphicFramePr>
-        <p:xfrm>
-          <a:off x="304800" y="304800"/>
-          <a:ext cx="3000000" cy="3000000"/>
-        </p:xfrm>
-        <a:graphic>
-          <a:graphicData uri="http://schemas.openxmlformats.org/drawingml/2006/table">
-            <a:tbl>
-              <a:tblPr>
-                <a:noFill/>
-                <a:tableStyleId>{AE357F98-E37F-4722-A336-238EF99134D1}</a:tableStyleId>
-              </a:tblPr>
-              <a:tblGrid>
-                <a:gridCol w="1209675"/>
-              </a:tblGrid>
-              <a:tr h="190500">
-                <a:tc>
-                  <a:txBody>
-                    <a:bodyPr/>
-                    <a:lstStyle/>
-                    <a:p>
-                      <a:pPr indent="0" lvl="0" marL="0" rtl="0" algn="l">
-                        <a:lnSpc>
-                          <a:spcPct val="115000"/>
-                        </a:lnSpc>
-                        <a:spcBef>
-                          <a:spcPts val="0"/>
-                        </a:spcBef>
-                        <a:spcAft>
-                          <a:spcPts val="0"/>
-                        </a:spcAft>
-                        <a:buNone/>
-                      </a:pPr>
-                      <a:r>
-                        <a:t/>
-                      </a:r>
-                      <a:endParaRPr b="1" sz="1100"/>
-                    </a:p>
-                  </a:txBody>
-                  <a:tcPr marT="91425" marB="91425" marR="91425" marL="91425"/>
-                </a:tc>
-              </a:tr>
-            </a:tbl>
-          </a:graphicData>
-        </a:graphic>
-      </p:graphicFrame>
-      <p:graphicFrame>
-        <p:nvGraphicFramePr>
-          <p:cNvPr id="75" name="Google Shape;75;p11"/>
-          <p:cNvGraphicFramePr/>
-          <p:nvPr/>
-        </p:nvGraphicFramePr>
-        <p:xfrm>
-          <a:off x="304800" y="304800"/>
-          <a:ext cx="3000000" cy="3000000"/>
-        </p:xfrm>
-        <a:graphic>
-          <a:graphicData uri="http://schemas.openxmlformats.org/drawingml/2006/table">
-            <a:tbl>
-              <a:tblPr>
-                <a:noFill/>
-                <a:tableStyleId>{AE357F98-E37F-4722-A336-238EF99134D1}</a:tableStyleId>
-              </a:tblPr>
-              <a:tblGrid>
-                <a:gridCol w="19050"/>
-              </a:tblGrid>
-              <a:tr h="19050">
-                <a:tc>
-                  <a:txBody>
-                    <a:bodyPr/>
-                    <a:lstStyle/>
-                    <a:p>
-                      <a:pPr indent="0" lvl="0" marL="0" rtl="0" algn="l">
-                        <a:spcBef>
-                          <a:spcPts val="0"/>
-                        </a:spcBef>
-                        <a:spcAft>
-                          <a:spcPts val="0"/>
-                        </a:spcAft>
-                        <a:buNone/>
-                      </a:pPr>
-                      <a:r>
-                        <a:t/>
-                      </a:r>
-                      <a:endParaRPr/>
-                    </a:p>
-                  </a:txBody>
-                  <a:tcPr marT="91425" marB="91425" marR="91425" marL="91425"/>
-                </a:tc>
-              </a:tr>
-            </a:tbl>
-          </a:graphicData>
-        </a:graphic>
-      </p:graphicFrame>
     </p:spTree>
   </p:cSld>
   <p:clrMapOvr>
@@ -15483,153 +15336,6 @@
                       <a:tailEnd len="sm" w="sm" type="none"/>
                     </a:lnB>
                   </a:tcPr>
-                </a:tc>
-              </a:tr>
-            </a:tbl>
-          </a:graphicData>
-        </a:graphic>
-      </p:graphicFrame>
-      <p:graphicFrame>
-        <p:nvGraphicFramePr>
-          <p:cNvPr id="73" name="Google Shape;73;p11"/>
-          <p:cNvGraphicFramePr/>
-          <p:nvPr/>
-        </p:nvGraphicFramePr>
-        <p:xfrm>
-          <a:off x="152400" y="152400"/>
-          <a:ext cx="3000000" cy="3000000"/>
-        </p:xfrm>
-        <a:graphic>
-          <a:graphicData uri="http://schemas.openxmlformats.org/drawingml/2006/table">
-            <a:tbl>
-              <a:tblPr>
-                <a:noFill/>
-                <a:tableStyleId>{AE357F98-E37F-4722-A336-238EF99134D1}</a:tableStyleId>
-              </a:tblPr>
-              <a:tblGrid>
-                <a:gridCol w="19050"/>
-              </a:tblGrid>
-              <a:tr h="19050">
-                <a:tc>
-                  <a:txBody>
-                    <a:bodyPr/>
-                    <a:lstStyle/>
-                    <a:p>
-                      <a:pPr indent="0" lvl="0" marL="0" rtl="0" algn="l">
-                        <a:spcBef>
-                          <a:spcPts val="0"/>
-                        </a:spcBef>
-                        <a:spcAft>
-                          <a:spcPts val="0"/>
-                        </a:spcAft>
-                        <a:buNone/>
-                      </a:pPr>
-                      <a:r>
-                        <a:t/>
-                      </a:r>
-                      <a:endParaRPr/>
-                    </a:p>
-                  </a:txBody>
-                  <a:tcPr marT="91425" marB="91425" marR="91425" marL="91425"/>
-                </a:tc>
-              </a:tr>
-            </a:tbl>
-          </a:graphicData>
-        </a:graphic>
-      </p:graphicFrame>
-      <p:graphicFrame>
-        <p:nvGraphicFramePr>
-          <p:cNvPr id="74" name="Google Shape;74;p11"/>
-          <p:cNvGraphicFramePr/>
-          <p:nvPr/>
-        </p:nvGraphicFramePr>
-        <p:xfrm>
-          <a:off x="304800" y="304800"/>
-          <a:ext cx="3000000" cy="3000000"/>
-        </p:xfrm>
-        <a:graphic>
-          <a:graphicData uri="http://schemas.openxmlformats.org/drawingml/2006/table">
-            <a:tbl>
-              <a:tblPr>
-                <a:noFill/>
-                <a:tableStyleId>{AE357F98-E37F-4722-A336-238EF99134D1}</a:tableStyleId>
-              </a:tblPr>
-              <a:tblGrid>
-                <a:gridCol w="1209675"/>
-              </a:tblGrid>
-              <a:tr h="190500">
-                <a:tc>
-                  <a:txBody>
-                    <a:bodyPr/>
-                    <a:lstStyle/>
-                    <a:p>
-                      <a:pPr indent="0" lvl="0" marL="0" rtl="0" algn="l">
-                        <a:lnSpc>
-                          <a:spcPct val="115000"/>
-                        </a:lnSpc>
-                        <a:spcBef>
-                          <a:spcPts val="0"/>
-                        </a:spcBef>
-                        <a:spcAft>
-                          <a:spcPts val="0"/>
-                        </a:spcAft>
-                        <a:buNone/>
-                      </a:pPr>
-                      <a:r>
-                        <a:t/>
-                      </a:r>
-                      <a:endParaRPr b="1" sz="1100"/>
-                    </a:p>
-                  </a:txBody>
-                  <a:tcPr marT="91425" marB="91425" marR="91425" marL="91425"/>
-                </a:tc>
-              </a:tr>
-            </a:tbl>
-          </a:graphicData>
-        </a:graphic>
-      </p:graphicFrame>
-      <p:graphicFrame>
-        <p:nvGraphicFramePr>
-          <p:cNvPr id="75" name="Google Shape;75;p11"/>
-          <p:cNvGraphicFramePr/>
-          <p:nvPr/>
-        </p:nvGraphicFramePr>
-        <p:xfrm>
-          <a:off x="304800" y="304800"/>
-          <a:ext cx="3000000" cy="3000000"/>
-        </p:xfrm>
-        <a:graphic>
-          <a:graphicData uri="http://schemas.openxmlformats.org/drawingml/2006/table">
-            <a:tbl>
-              <a:tblPr>
-                <a:noFill/>
-                <a:tableStyleId>{AE357F98-E37F-4722-A336-238EF99134D1}</a:tableStyleId>
-              </a:tblPr>
-              <a:tblGrid>
-                <a:gridCol w="19050"/>
-              </a:tblGrid>
-              <a:tr h="19050">
-                <a:tc>
-                  <a:txBody>
-                    <a:bodyPr/>
-                    <a:lstStyle/>
-                    <a:p>
-                      <a:pPr indent="0" lvl="0" marL="0" rtl="0" algn="l">
-                        <a:spcBef>
-                          <a:spcPts val="0"/>
-                        </a:spcBef>
-                        <a:spcAft>
-                          <a:spcPts val="0"/>
-                        </a:spcAft>
-                        <a:buNone/>
-                      </a:pPr>
-                      <a:r>
-                        <a:t/>
-                      </a:r>
-                      <a:endParaRPr/>
-                    </a:p>
-                  </a:txBody>
-                  <a:tcPr marT="91425" marB="91425" marR="91425" marL="91425"/>
                 </a:tc>
               </a:tr>
             </a:tbl>
@@ -17431,7 +17137,7 @@
                           <a:cs typeface="Times New Roman"/>
                           <a:sym typeface="Times New Roman"/>
                         </a:rPr>
-                        <a:t>3</a:t>
+                        <a:t>3.</a:t>
                       </a:r>
                       <a:r>
                         <a:rPr lang="en-US" sz="1200" u="none" cap="none" strike="noStrike">
@@ -17440,7 +17146,7 @@
                           <a:cs typeface="Times New Roman"/>
                           <a:sym typeface="Times New Roman"/>
                         </a:rPr>
-                        <a:t>.</a:t>
+                        <a:t/>
                       </a:r>
                       <a:endParaRPr sz="1200" u="none" cap="none" strike="noStrike">
                         <a:latin typeface="Times New Roman"/>
@@ -17484,7 +17190,7 @@
                           <a:cs typeface="Times New Roman"/>
                           <a:sym typeface="Times New Roman"/>
                         </a:rPr>
-                        <a:t>Objective of Project</a:t>
+                        <a:t>Objectives</a:t>
                       </a:r>
                       <a:endParaRPr sz="1200">
                         <a:solidFill>
@@ -17530,7 +17236,7 @@
                           <a:cs typeface="Times New Roman"/>
                           <a:sym typeface="Times New Roman"/>
                         </a:rPr>
-                        <a:t>4</a:t>
+                        <a:t>4.</a:t>
                       </a:r>
                       <a:r>
                         <a:rPr lang="en-US" sz="1200" u="none" cap="none" strike="noStrike">
@@ -17539,7 +17245,7 @@
                           <a:cs typeface="Times New Roman"/>
                           <a:sym typeface="Times New Roman"/>
                         </a:rPr>
-                        <a:t>.</a:t>
+                        <a:t/>
                       </a:r>
                       <a:endParaRPr sz="1200" u="none" cap="none" strike="noStrike">
                         <a:latin typeface="Times New Roman"/>
@@ -17580,7 +17286,7 @@
                           <a:cs typeface="Times New Roman"/>
                           <a:sym typeface="Times New Roman"/>
                         </a:rPr>
-                        <a:t>Implementation</a:t>
+                        <a:t>Flow Diagram</a:t>
                       </a:r>
                       <a:endParaRPr sz="1200" u="none" cap="none" strike="noStrike">
                         <a:latin typeface="Times New Roman"/>
@@ -17623,7 +17329,7 @@
                           <a:cs typeface="Times New Roman"/>
                           <a:sym typeface="Times New Roman"/>
                         </a:rPr>
-                        <a:t>5</a:t>
+                        <a:t>5.</a:t>
                       </a:r>
                       <a:r>
                         <a:rPr lang="en-US" sz="1200" u="none" cap="none" strike="noStrike">
@@ -17632,7 +17338,7 @@
                           <a:cs typeface="Times New Roman"/>
                           <a:sym typeface="Times New Roman"/>
                         </a:rPr>
-                        <a:t>.</a:t>
+                        <a:t/>
                       </a:r>
                       <a:endParaRPr sz="1200" u="none" cap="none" strike="noStrike">
                         <a:latin typeface="Times New Roman"/>
@@ -17676,7 +17382,7 @@
                           <a:cs typeface="Times New Roman"/>
                           <a:sym typeface="Times New Roman"/>
                         </a:rPr>
-                        <a:t>Flow diagram</a:t>
+                        <a:t>Implementation &amp; Formulation</a:t>
                       </a:r>
                       <a:endParaRPr sz="1200" u="none" cap="none" strike="noStrike"/>
                     </a:p>
@@ -17714,7 +17420,7 @@
                           <a:cs typeface="Times New Roman"/>
                           <a:sym typeface="Times New Roman"/>
                         </a:rPr>
-                        <a:t>        </a:t>
+                        <a:t>6.</a:t>
                       </a:r>
                       <a:r>
                         <a:rPr lang="en-US" sz="1200">
@@ -17723,7 +17429,7 @@
                           <a:cs typeface="Times New Roman"/>
                           <a:sym typeface="Times New Roman"/>
                         </a:rPr>
-                        <a:t>6</a:t>
+                        <a:t/>
                       </a:r>
                       <a:r>
                         <a:rPr lang="en-US" sz="1200" u="none" cap="none" strike="noStrike">
@@ -17732,7 +17438,7 @@
                           <a:cs typeface="Times New Roman"/>
                           <a:sym typeface="Times New Roman"/>
                         </a:rPr>
-                        <a:t>.</a:t>
+                        <a:t/>
                       </a:r>
                       <a:endParaRPr sz="1200" u="none" cap="none" strike="noStrike">
                         <a:latin typeface="Times New Roman"/>
@@ -17776,7 +17482,7 @@
                           <a:cs typeface="Times New Roman"/>
                           <a:sym typeface="Times New Roman"/>
                         </a:rPr>
-                        <a:t>Applications</a:t>
+                        <a:t>Datasets &amp; Calibration</a:t>
                       </a:r>
                       <a:endParaRPr sz="1200" u="none" cap="none" strike="noStrike"/>
                     </a:p>
@@ -17814,7 +17520,7 @@
                           <a:cs typeface="Times New Roman"/>
                           <a:sym typeface="Times New Roman"/>
                         </a:rPr>
-                        <a:t>7</a:t>
+                        <a:t>7.</a:t>
                       </a:r>
                       <a:r>
                         <a:rPr lang="en-US" sz="1200" u="none" cap="none" strike="noStrike">
@@ -17823,7 +17529,7 @@
                           <a:cs typeface="Times New Roman"/>
                           <a:sym typeface="Times New Roman"/>
                         </a:rPr>
-                        <a:t>.</a:t>
+                        <a:t/>
                       </a:r>
                       <a:endParaRPr sz="1200" u="none" cap="none" strike="noStrike">
                         <a:latin typeface="Times New Roman"/>
@@ -17867,7 +17573,7 @@
                           <a:cs typeface="Times New Roman"/>
                           <a:sym typeface="Times New Roman"/>
                         </a:rPr>
-                        <a:t>Future Scope</a:t>
+                        <a:t>Results</a:t>
                       </a:r>
                       <a:endParaRPr sz="1200" u="none" cap="none" strike="noStrike"/>
                     </a:p>
@@ -17939,7 +17645,7 @@
                           <a:cs typeface="Times New Roman"/>
                           <a:sym typeface="Times New Roman"/>
                         </a:rPr>
-                        <a:t>References</a:t>
+                        <a:t>Applications &amp; Future Scope</a:t>
                       </a:r>
                       <a:endParaRPr sz="1200" u="none" cap="none" strike="noStrike">
                         <a:solidFill>
@@ -17985,7 +17691,7 @@
                           <a:cs typeface="Times New Roman"/>
                           <a:sym typeface="Times New Roman"/>
                         </a:rPr>
-                        <a:t>9</a:t>
+                        <a:t>9.</a:t>
                       </a:r>
                       <a:r>
                         <a:rPr lang="en-US" sz="1200" u="none" cap="none" strike="noStrike">
@@ -17994,7 +17700,7 @@
                           <a:cs typeface="Times New Roman"/>
                           <a:sym typeface="Times New Roman"/>
                         </a:rPr>
-                        <a:t>.</a:t>
+                        <a:t/>
                       </a:r>
                       <a:endParaRPr sz="1200" u="none" cap="none" strike="noStrike">
                         <a:latin typeface="Times New Roman"/>
@@ -18038,7 +17744,7 @@
                           <a:cs typeface="Times New Roman"/>
                           <a:sym typeface="Times New Roman"/>
                         </a:rPr>
-                        <a:t>Conclusion</a:t>
+                        <a:t>Conclusion &amp; References</a:t>
                       </a:r>
                       <a:endParaRPr sz="1200" u="none" cap="none" strike="noStrike"/>
                     </a:p>
@@ -18589,7 +18295,7 @@
                 <a:cs typeface="Times New Roman"/>
                 <a:sym typeface="Times New Roman"/>
               </a:rPr>
-              <a:t xml:space="preserve"> t_low = 20th percentile of similarities of true duplicate pairs  →  0.26 (80% of duplicates stay reachable).</a:t>
+              <a:t xml:space="preserve"> t_low = 20th percentile of similarities of true duplicate pairs  →  0.26 for tickets and bug reports; 0.40 for short texts (app reviews, chat), confirmed on unseen apps.</a:t>
             </a:r>
           </a:p>
           <a:p>
@@ -19036,7 +18742,7 @@
           <p:nvPr/>
         </p:nvGraphicFramePr>
         <p:xfrm>
-          <a:off x="497000" y="1500000"/>
+          <a:off x="497000" y="1580000"/>
           <a:ext cx="8100000" cy="2800000"/>
         </p:xfrm>
         <a:graphic>
@@ -19521,13 +19227,13 @@
                         <a:buNone/>
                       </a:pPr>
                       <a:r>
-                        <a:rPr lang="en-US" sz="900">
+                        <a:rPr b="1" lang="en-US" sz="900">
                           <a:latin typeface="Times New Roman"/>
                           <a:ea typeface="Times New Roman"/>
                           <a:cs typeface="Times New Roman"/>
                           <a:sym typeface="Times New Roman"/>
                         </a:rPr>
-                        <a:t>Original calibration (long-text channels)</a:t>
+                        <a:t>Short-text setting (deployed)</a:t>
                       </a:r>
                     </a:p>
                   </a:txBody>
@@ -19585,13 +19291,13 @@
                         <a:buNone/>
                       </a:pPr>
                       <a:r>
-                        <a:rPr lang="en-US" sz="900">
+                        <a:rPr b="1" lang="en-US" sz="900">
                           <a:latin typeface="Times New Roman"/>
                           <a:ea typeface="Times New Roman"/>
                           <a:cs typeface="Times New Roman"/>
                           <a:sym typeface="Times New Roman"/>
                         </a:rPr>
-                        <a:t>20th pct. of duplicates</a:t>
+                        <a:t>0.40</a:t>
                       </a:r>
                     </a:p>
                   </a:txBody>
@@ -19649,13 +19355,463 @@
                         <a:buNone/>
                       </a:pPr>
                       <a:r>
+                        <a:rPr b="1" lang="en-US" sz="900">
+                          <a:latin typeface="Times New Roman"/>
+                          <a:ea typeface="Times New Roman"/>
+                          <a:cs typeface="Times New Roman"/>
+                          <a:sym typeface="Times New Roman"/>
+                        </a:rPr>
+                        <a:t>0.8306</a:t>
+                      </a:r>
+                    </a:p>
+                  </a:txBody>
+                  <a:tcPr marT="45720" marB="45720" marR="45720" marL="45720">
+                    <a:lnL cap="flat" cmpd="sng" w="19050">
+                      <a:solidFill>
+                        <a:srgbClr val="262626"/>
+                      </a:solidFill>
+                      <a:prstDash val="solid"/>
+                      <a:round/>
+                      <a:headEnd len="sm" w="sm" type="none"/>
+                      <a:tailEnd len="sm" w="sm" type="none"/>
+                    </a:lnL>
+                    <a:lnR cap="flat" cmpd="sng" w="19050">
+                      <a:solidFill>
+                        <a:srgbClr val="262626"/>
+                      </a:solidFill>
+                      <a:prstDash val="solid"/>
+                      <a:round/>
+                      <a:headEnd len="sm" w="sm" type="none"/>
+                      <a:tailEnd len="sm" w="sm" type="none"/>
+                    </a:lnR>
+                    <a:lnT cap="flat" cmpd="sng" w="19050">
+                      <a:solidFill>
+                        <a:srgbClr val="262626"/>
+                      </a:solidFill>
+                      <a:prstDash val="solid"/>
+                      <a:round/>
+                      <a:headEnd len="sm" w="sm" type="none"/>
+                      <a:tailEnd len="sm" w="sm" type="none"/>
+                    </a:lnT>
+                    <a:lnB cap="flat" cmpd="sng" w="19050">
+                      <a:solidFill>
+                        <a:srgbClr val="262626"/>
+                      </a:solidFill>
+                      <a:prstDash val="solid"/>
+                      <a:round/>
+                      <a:headEnd len="sm" w="sm" type="none"/>
+                      <a:tailEnd len="sm" w="sm" type="none"/>
+                    </a:lnB>
+                  </a:tcPr>
+                </a:tc>
+                <a:tc>
+                  <a:txBody>
+                    <a:bodyPr/>
+                    <a:lstStyle/>
+                    <a:p>
+                      <a:pPr indent="0" lvl="0" marL="0" rtl="0" algn="l">
+                        <a:spcBef>
+                          <a:spcPts val="0"/>
+                        </a:spcBef>
+                        <a:spcAft>
+                          <a:spcPts val="0"/>
+                        </a:spcAft>
+                        <a:buNone/>
+                      </a:pPr>
+                      <a:r>
+                        <a:rPr b="1" lang="en-US" sz="900">
+                          <a:latin typeface="Times New Roman"/>
+                          <a:ea typeface="Times New Roman"/>
+                          <a:cs typeface="Times New Roman"/>
+                          <a:sym typeface="Times New Roman"/>
+                        </a:rPr>
+                        <a:t>0.883</a:t>
+                      </a:r>
+                    </a:p>
+                  </a:txBody>
+                  <a:tcPr marT="45720" marB="45720" marR="45720" marL="45720">
+                    <a:lnL cap="flat" cmpd="sng" w="19050">
+                      <a:solidFill>
+                        <a:srgbClr val="262626"/>
+                      </a:solidFill>
+                      <a:prstDash val="solid"/>
+                      <a:round/>
+                      <a:headEnd len="sm" w="sm" type="none"/>
+                      <a:tailEnd len="sm" w="sm" type="none"/>
+                    </a:lnL>
+                    <a:lnR cap="flat" cmpd="sng" w="19050">
+                      <a:solidFill>
+                        <a:srgbClr val="262626"/>
+                      </a:solidFill>
+                      <a:prstDash val="solid"/>
+                      <a:round/>
+                      <a:headEnd len="sm" w="sm" type="none"/>
+                      <a:tailEnd len="sm" w="sm" type="none"/>
+                    </a:lnR>
+                    <a:lnT cap="flat" cmpd="sng" w="19050">
+                      <a:solidFill>
+                        <a:srgbClr val="262626"/>
+                      </a:solidFill>
+                      <a:prstDash val="solid"/>
+                      <a:round/>
+                      <a:headEnd len="sm" w="sm" type="none"/>
+                      <a:tailEnd len="sm" w="sm" type="none"/>
+                    </a:lnT>
+                    <a:lnB cap="flat" cmpd="sng" w="19050">
+                      <a:solidFill>
+                        <a:srgbClr val="262626"/>
+                      </a:solidFill>
+                      <a:prstDash val="solid"/>
+                      <a:round/>
+                      <a:headEnd len="sm" w="sm" type="none"/>
+                      <a:tailEnd len="sm" w="sm" type="none"/>
+                    </a:lnB>
+                  </a:tcPr>
+                </a:tc>
+                <a:tc>
+                  <a:txBody>
+                    <a:bodyPr/>
+                    <a:lstStyle/>
+                    <a:p>
+                      <a:pPr indent="0" lvl="0" marL="0" rtl="0" algn="l">
+                        <a:spcBef>
+                          <a:spcPts val="0"/>
+                        </a:spcBef>
+                        <a:spcAft>
+                          <a:spcPts val="0"/>
+                        </a:spcAft>
+                        <a:buNone/>
+                      </a:pPr>
+                      <a:r>
+                        <a:rPr b="1" lang="en-US" sz="900">
+                          <a:latin typeface="Times New Roman"/>
+                          <a:ea typeface="Times New Roman"/>
+                          <a:cs typeface="Times New Roman"/>
+                          <a:sym typeface="Times New Roman"/>
+                        </a:rPr>
+                        <a:t>0.284</a:t>
+                      </a:r>
+                    </a:p>
+                  </a:txBody>
+                  <a:tcPr marT="45720" marB="45720" marR="45720" marL="45720">
+                    <a:lnL cap="flat" cmpd="sng" w="19050">
+                      <a:solidFill>
+                        <a:srgbClr val="262626"/>
+                      </a:solidFill>
+                      <a:prstDash val="solid"/>
+                      <a:round/>
+                      <a:headEnd len="sm" w="sm" type="none"/>
+                      <a:tailEnd len="sm" w="sm" type="none"/>
+                    </a:lnL>
+                    <a:lnR cap="flat" cmpd="sng" w="19050">
+                      <a:solidFill>
+                        <a:srgbClr val="262626"/>
+                      </a:solidFill>
+                      <a:prstDash val="solid"/>
+                      <a:round/>
+                      <a:headEnd len="sm" w="sm" type="none"/>
+                      <a:tailEnd len="sm" w="sm" type="none"/>
+                    </a:lnR>
+                    <a:lnT cap="flat" cmpd="sng" w="19050">
+                      <a:solidFill>
+                        <a:srgbClr val="262626"/>
+                      </a:solidFill>
+                      <a:prstDash val="solid"/>
+                      <a:round/>
+                      <a:headEnd len="sm" w="sm" type="none"/>
+                      <a:tailEnd len="sm" w="sm" type="none"/>
+                    </a:lnT>
+                    <a:lnB cap="flat" cmpd="sng" w="19050">
+                      <a:solidFill>
+                        <a:srgbClr val="262626"/>
+                      </a:solidFill>
+                      <a:prstDash val="solid"/>
+                      <a:round/>
+                      <a:headEnd len="sm" w="sm" type="none"/>
+                      <a:tailEnd len="sm" w="sm" type="none"/>
+                    </a:lnB>
+                  </a:tcPr>
+                </a:tc>
+                <a:tc>
+                  <a:txBody>
+                    <a:bodyPr/>
+                    <a:lstStyle/>
+                    <a:p>
+                      <a:pPr indent="0" lvl="0" marL="0" rtl="0" algn="l">
+                        <a:spcBef>
+                          <a:spcPts val="0"/>
+                        </a:spcBef>
+                        <a:spcAft>
+                          <a:spcPts val="0"/>
+                        </a:spcAft>
+                        <a:buNone/>
+                      </a:pPr>
+                      <a:r>
+                        <a:rPr b="1" lang="en-US" sz="900">
+                          <a:latin typeface="Times New Roman"/>
+                          <a:ea typeface="Times New Roman"/>
+                          <a:cs typeface="Times New Roman"/>
+                          <a:sym typeface="Times New Roman"/>
+                        </a:rPr>
+                        <a:t>0.430</a:t>
+                      </a:r>
+                    </a:p>
+                  </a:txBody>
+                  <a:tcPr marT="45720" marB="45720" marR="45720" marL="45720">
+                    <a:lnL cap="flat" cmpd="sng" w="19050">
+                      <a:solidFill>
+                        <a:srgbClr val="262626"/>
+                      </a:solidFill>
+                      <a:prstDash val="solid"/>
+                      <a:round/>
+                      <a:headEnd len="sm" w="sm" type="none"/>
+                      <a:tailEnd len="sm" w="sm" type="none"/>
+                    </a:lnL>
+                    <a:lnR cap="flat" cmpd="sng" w="19050">
+                      <a:solidFill>
+                        <a:srgbClr val="262626"/>
+                      </a:solidFill>
+                      <a:prstDash val="solid"/>
+                      <a:round/>
+                      <a:headEnd len="sm" w="sm" type="none"/>
+                      <a:tailEnd len="sm" w="sm" type="none"/>
+                    </a:lnR>
+                    <a:lnT cap="flat" cmpd="sng" w="19050">
+                      <a:solidFill>
+                        <a:srgbClr val="262626"/>
+                      </a:solidFill>
+                      <a:prstDash val="solid"/>
+                      <a:round/>
+                      <a:headEnd len="sm" w="sm" type="none"/>
+                      <a:tailEnd len="sm" w="sm" type="none"/>
+                    </a:lnT>
+                    <a:lnB cap="flat" cmpd="sng" w="19050">
+                      <a:solidFill>
+                        <a:srgbClr val="262626"/>
+                      </a:solidFill>
+                      <a:prstDash val="solid"/>
+                      <a:round/>
+                      <a:headEnd len="sm" w="sm" type="none"/>
+                      <a:tailEnd len="sm" w="sm" type="none"/>
+                    </a:lnB>
+                  </a:tcPr>
+                </a:tc>
+                <a:tc>
+                  <a:txBody>
+                    <a:bodyPr/>
+                    <a:lstStyle/>
+                    <a:p>
+                      <a:pPr indent="0" lvl="0" marL="0" rtl="0" algn="l">
+                        <a:spcBef>
+                          <a:spcPts val="0"/>
+                        </a:spcBef>
+                        <a:spcAft>
+                          <a:spcPts val="0"/>
+                        </a:spcAft>
+                        <a:buNone/>
+                      </a:pPr>
+                      <a:r>
+                        <a:rPr b="1" lang="en-US" sz="900">
+                          <a:latin typeface="Times New Roman"/>
+                          <a:ea typeface="Times New Roman"/>
+                          <a:cs typeface="Times New Roman"/>
+                          <a:sym typeface="Times New Roman"/>
+                        </a:rPr>
+                        <a:t>66%</a:t>
+                      </a:r>
+                    </a:p>
+                  </a:txBody>
+                  <a:tcPr marT="45720" marB="45720" marR="45720" marL="45720">
+                    <a:lnL cap="flat" cmpd="sng" w="19050">
+                      <a:solidFill>
+                        <a:srgbClr val="262626"/>
+                      </a:solidFill>
+                      <a:prstDash val="solid"/>
+                      <a:round/>
+                      <a:headEnd len="sm" w="sm" type="none"/>
+                      <a:tailEnd len="sm" w="sm" type="none"/>
+                    </a:lnL>
+                    <a:lnR cap="flat" cmpd="sng" w="19050">
+                      <a:solidFill>
+                        <a:srgbClr val="262626"/>
+                      </a:solidFill>
+                      <a:prstDash val="solid"/>
+                      <a:round/>
+                      <a:headEnd len="sm" w="sm" type="none"/>
+                      <a:tailEnd len="sm" w="sm" type="none"/>
+                    </a:lnR>
+                    <a:lnT cap="flat" cmpd="sng" w="19050">
+                      <a:solidFill>
+                        <a:srgbClr val="262626"/>
+                      </a:solidFill>
+                      <a:prstDash val="solid"/>
+                      <a:round/>
+                      <a:headEnd len="sm" w="sm" type="none"/>
+                      <a:tailEnd len="sm" w="sm" type="none"/>
+                    </a:lnT>
+                    <a:lnB cap="flat" cmpd="sng" w="19050">
+                      <a:solidFill>
+                        <a:srgbClr val="262626"/>
+                      </a:solidFill>
+                      <a:prstDash val="solid"/>
+                      <a:round/>
+                      <a:headEnd len="sm" w="sm" type="none"/>
+                      <a:tailEnd len="sm" w="sm" type="none"/>
+                    </a:lnB>
+                  </a:tcPr>
+                </a:tc>
+              </a:tr>
+              <a:tr h="360000">
+                <a:tc>
+                  <a:txBody>
+                    <a:bodyPr/>
+                    <a:lstStyle/>
+                    <a:p>
+                      <a:pPr indent="0" lvl="0" marL="0" rtl="0" algn="l">
+                        <a:spcBef>
+                          <a:spcPts val="0"/>
+                        </a:spcBef>
+                        <a:spcAft>
+                          <a:spcPts val="0"/>
+                        </a:spcAft>
+                        <a:buNone/>
+                      </a:pPr>
+                      <a:r>
                         <a:rPr lang="en-US" sz="900">
                           <a:latin typeface="Times New Roman"/>
                           <a:ea typeface="Times New Roman"/>
                           <a:cs typeface="Times New Roman"/>
                           <a:sym typeface="Times New Roman"/>
                         </a:rPr>
-                        <a:t>precision ≥ 0.97</a:t>
+                        <a:t>Long-text setting (tickets, bug reports)</a:t>
+                      </a:r>
+                    </a:p>
+                  </a:txBody>
+                  <a:tcPr marT="45720" marB="45720" marR="45720" marL="45720">
+                    <a:lnL cap="flat" cmpd="sng" w="19050">
+                      <a:solidFill>
+                        <a:srgbClr val="262626"/>
+                      </a:solidFill>
+                      <a:prstDash val="solid"/>
+                      <a:round/>
+                      <a:headEnd len="sm" w="sm" type="none"/>
+                      <a:tailEnd len="sm" w="sm" type="none"/>
+                    </a:lnL>
+                    <a:lnR cap="flat" cmpd="sng" w="19050">
+                      <a:solidFill>
+                        <a:srgbClr val="262626"/>
+                      </a:solidFill>
+                      <a:prstDash val="solid"/>
+                      <a:round/>
+                      <a:headEnd len="sm" w="sm" type="none"/>
+                      <a:tailEnd len="sm" w="sm" type="none"/>
+                    </a:lnR>
+                    <a:lnT cap="flat" cmpd="sng" w="19050">
+                      <a:solidFill>
+                        <a:srgbClr val="262626"/>
+                      </a:solidFill>
+                      <a:prstDash val="solid"/>
+                      <a:round/>
+                      <a:headEnd len="sm" w="sm" type="none"/>
+                      <a:tailEnd len="sm" w="sm" type="none"/>
+                    </a:lnT>
+                    <a:lnB cap="flat" cmpd="sng" w="19050">
+                      <a:solidFill>
+                        <a:srgbClr val="262626"/>
+                      </a:solidFill>
+                      <a:prstDash val="solid"/>
+                      <a:round/>
+                      <a:headEnd len="sm" w="sm" type="none"/>
+                      <a:tailEnd len="sm" w="sm" type="none"/>
+                    </a:lnB>
+                  </a:tcPr>
+                </a:tc>
+                <a:tc>
+                  <a:txBody>
+                    <a:bodyPr/>
+                    <a:lstStyle/>
+                    <a:p>
+                      <a:pPr indent="0" lvl="0" marL="0" rtl="0" algn="l">
+                        <a:spcBef>
+                          <a:spcPts val="0"/>
+                        </a:spcBef>
+                        <a:spcAft>
+                          <a:spcPts val="0"/>
+                        </a:spcAft>
+                        <a:buNone/>
+                      </a:pPr>
+                      <a:r>
+                        <a:rPr lang="en-US" sz="900">
+                          <a:latin typeface="Times New Roman"/>
+                          <a:ea typeface="Times New Roman"/>
+                          <a:cs typeface="Times New Roman"/>
+                          <a:sym typeface="Times New Roman"/>
+                        </a:rPr>
+                        <a:t>0.26</a:t>
+                      </a:r>
+                    </a:p>
+                  </a:txBody>
+                  <a:tcPr marT="45720" marB="45720" marR="45720" marL="45720">
+                    <a:lnL cap="flat" cmpd="sng" w="19050">
+                      <a:solidFill>
+                        <a:srgbClr val="262626"/>
+                      </a:solidFill>
+                      <a:prstDash val="solid"/>
+                      <a:round/>
+                      <a:headEnd len="sm" w="sm" type="none"/>
+                      <a:tailEnd len="sm" w="sm" type="none"/>
+                    </a:lnL>
+                    <a:lnR cap="flat" cmpd="sng" w="19050">
+                      <a:solidFill>
+                        <a:srgbClr val="262626"/>
+                      </a:solidFill>
+                      <a:prstDash val="solid"/>
+                      <a:round/>
+                      <a:headEnd len="sm" w="sm" type="none"/>
+                      <a:tailEnd len="sm" w="sm" type="none"/>
+                    </a:lnR>
+                    <a:lnT cap="flat" cmpd="sng" w="19050">
+                      <a:solidFill>
+                        <a:srgbClr val="262626"/>
+                      </a:solidFill>
+                      <a:prstDash val="solid"/>
+                      <a:round/>
+                      <a:headEnd len="sm" w="sm" type="none"/>
+                      <a:tailEnd len="sm" w="sm" type="none"/>
+                    </a:lnT>
+                    <a:lnB cap="flat" cmpd="sng" w="19050">
+                      <a:solidFill>
+                        <a:srgbClr val="262626"/>
+                      </a:solidFill>
+                      <a:prstDash val="solid"/>
+                      <a:round/>
+                      <a:headEnd len="sm" w="sm" type="none"/>
+                      <a:tailEnd len="sm" w="sm" type="none"/>
+                    </a:lnB>
+                  </a:tcPr>
+                </a:tc>
+                <a:tc>
+                  <a:txBody>
+                    <a:bodyPr/>
+                    <a:lstStyle/>
+                    <a:p>
+                      <a:pPr indent="0" lvl="0" marL="0" rtl="0" algn="l">
+                        <a:spcBef>
+                          <a:spcPts val="0"/>
+                        </a:spcBef>
+                        <a:spcAft>
+                          <a:spcPts val="0"/>
+                        </a:spcAft>
+                        <a:buNone/>
+                      </a:pPr>
+                      <a:r>
+                        <a:rPr lang="en-US" sz="900">
+                          <a:latin typeface="Times New Roman"/>
+                          <a:ea typeface="Times New Roman"/>
+                          <a:cs typeface="Times New Roman"/>
+                          <a:sym typeface="Times New Roman"/>
+                        </a:rPr>
+                        <a:t>0.8306</a:t>
                       </a:r>
                     </a:p>
                   </a:txBody>
@@ -19971,13 +20127,13 @@
                         <a:buNone/>
                       </a:pPr>
                       <a:r>
-                        <a:rPr b="1" lang="en-US" sz="900">
+                        <a:rPr lang="en-US" sz="900">
                           <a:latin typeface="Times New Roman"/>
                           <a:ea typeface="Times New Roman"/>
                           <a:cs typeface="Times New Roman"/>
                           <a:sym typeface="Times New Roman"/>
                         </a:rPr>
-                        <a:t>Short-text setting (deployed)</a:t>
+                        <a:t>t_low ≈ 0.30</a:t>
                       </a:r>
                     </a:p>
                   </a:txBody>
@@ -20035,13 +20191,13 @@
                         <a:buNone/>
                       </a:pPr>
                       <a:r>
-                        <a:rPr b="1" lang="en-US" sz="900">
+                        <a:rPr lang="en-US" sz="900">
                           <a:latin typeface="Times New Roman"/>
                           <a:ea typeface="Times New Roman"/>
                           <a:cs typeface="Times New Roman"/>
                           <a:sym typeface="Times New Roman"/>
                         </a:rPr>
-                        <a:t>0.40</a:t>
+                        <a:t>0.26 + 0.04</a:t>
                       </a:r>
                     </a:p>
                   </a:txBody>
@@ -20099,463 +20255,13 @@
                         <a:buNone/>
                       </a:pPr>
                       <a:r>
-                        <a:rPr b="1" lang="en-US" sz="900">
-                          <a:latin typeface="Times New Roman"/>
-                          <a:ea typeface="Times New Roman"/>
-                          <a:cs typeface="Times New Roman"/>
-                          <a:sym typeface="Times New Roman"/>
-                        </a:rPr>
-                        <a:t>same</a:t>
-                      </a:r>
-                    </a:p>
-                  </a:txBody>
-                  <a:tcPr marT="45720" marB="45720" marR="45720" marL="45720">
-                    <a:lnL cap="flat" cmpd="sng" w="19050">
-                      <a:solidFill>
-                        <a:srgbClr val="262626"/>
-                      </a:solidFill>
-                      <a:prstDash val="solid"/>
-                      <a:round/>
-                      <a:headEnd len="sm" w="sm" type="none"/>
-                      <a:tailEnd len="sm" w="sm" type="none"/>
-                    </a:lnL>
-                    <a:lnR cap="flat" cmpd="sng" w="19050">
-                      <a:solidFill>
-                        <a:srgbClr val="262626"/>
-                      </a:solidFill>
-                      <a:prstDash val="solid"/>
-                      <a:round/>
-                      <a:headEnd len="sm" w="sm" type="none"/>
-                      <a:tailEnd len="sm" w="sm" type="none"/>
-                    </a:lnR>
-                    <a:lnT cap="flat" cmpd="sng" w="19050">
-                      <a:solidFill>
-                        <a:srgbClr val="262626"/>
-                      </a:solidFill>
-                      <a:prstDash val="solid"/>
-                      <a:round/>
-                      <a:headEnd len="sm" w="sm" type="none"/>
-                      <a:tailEnd len="sm" w="sm" type="none"/>
-                    </a:lnT>
-                    <a:lnB cap="flat" cmpd="sng" w="19050">
-                      <a:solidFill>
-                        <a:srgbClr val="262626"/>
-                      </a:solidFill>
-                      <a:prstDash val="solid"/>
-                      <a:round/>
-                      <a:headEnd len="sm" w="sm" type="none"/>
-                      <a:tailEnd len="sm" w="sm" type="none"/>
-                    </a:lnB>
-                  </a:tcPr>
-                </a:tc>
-                <a:tc>
-                  <a:txBody>
-                    <a:bodyPr/>
-                    <a:lstStyle/>
-                    <a:p>
-                      <a:pPr indent="0" lvl="0" marL="0" rtl="0" algn="l">
-                        <a:spcBef>
-                          <a:spcPts val="0"/>
-                        </a:spcBef>
-                        <a:spcAft>
-                          <a:spcPts val="0"/>
-                        </a:spcAft>
-                        <a:buNone/>
-                      </a:pPr>
-                      <a:r>
-                        <a:rPr b="1" lang="en-US" sz="900">
-                          <a:latin typeface="Times New Roman"/>
-                          <a:ea typeface="Times New Roman"/>
-                          <a:cs typeface="Times New Roman"/>
-                          <a:sym typeface="Times New Roman"/>
-                        </a:rPr>
-                        <a:t>0.883</a:t>
-                      </a:r>
-                    </a:p>
-                  </a:txBody>
-                  <a:tcPr marT="45720" marB="45720" marR="45720" marL="45720">
-                    <a:lnL cap="flat" cmpd="sng" w="19050">
-                      <a:solidFill>
-                        <a:srgbClr val="262626"/>
-                      </a:solidFill>
-                      <a:prstDash val="solid"/>
-                      <a:round/>
-                      <a:headEnd len="sm" w="sm" type="none"/>
-                      <a:tailEnd len="sm" w="sm" type="none"/>
-                    </a:lnL>
-                    <a:lnR cap="flat" cmpd="sng" w="19050">
-                      <a:solidFill>
-                        <a:srgbClr val="262626"/>
-                      </a:solidFill>
-                      <a:prstDash val="solid"/>
-                      <a:round/>
-                      <a:headEnd len="sm" w="sm" type="none"/>
-                      <a:tailEnd len="sm" w="sm" type="none"/>
-                    </a:lnR>
-                    <a:lnT cap="flat" cmpd="sng" w="19050">
-                      <a:solidFill>
-                        <a:srgbClr val="262626"/>
-                      </a:solidFill>
-                      <a:prstDash val="solid"/>
-                      <a:round/>
-                      <a:headEnd len="sm" w="sm" type="none"/>
-                      <a:tailEnd len="sm" w="sm" type="none"/>
-                    </a:lnT>
-                    <a:lnB cap="flat" cmpd="sng" w="19050">
-                      <a:solidFill>
-                        <a:srgbClr val="262626"/>
-                      </a:solidFill>
-                      <a:prstDash val="solid"/>
-                      <a:round/>
-                      <a:headEnd len="sm" w="sm" type="none"/>
-                      <a:tailEnd len="sm" w="sm" type="none"/>
-                    </a:lnB>
-                  </a:tcPr>
-                </a:tc>
-                <a:tc>
-                  <a:txBody>
-                    <a:bodyPr/>
-                    <a:lstStyle/>
-                    <a:p>
-                      <a:pPr indent="0" lvl="0" marL="0" rtl="0" algn="l">
-                        <a:spcBef>
-                          <a:spcPts val="0"/>
-                        </a:spcBef>
-                        <a:spcAft>
-                          <a:spcPts val="0"/>
-                        </a:spcAft>
-                        <a:buNone/>
-                      </a:pPr>
-                      <a:r>
-                        <a:rPr b="1" lang="en-US" sz="900">
-                          <a:latin typeface="Times New Roman"/>
-                          <a:ea typeface="Times New Roman"/>
-                          <a:cs typeface="Times New Roman"/>
-                          <a:sym typeface="Times New Roman"/>
-                        </a:rPr>
-                        <a:t>0.284</a:t>
-                      </a:r>
-                    </a:p>
-                  </a:txBody>
-                  <a:tcPr marT="45720" marB="45720" marR="45720" marL="45720">
-                    <a:lnL cap="flat" cmpd="sng" w="19050">
-                      <a:solidFill>
-                        <a:srgbClr val="262626"/>
-                      </a:solidFill>
-                      <a:prstDash val="solid"/>
-                      <a:round/>
-                      <a:headEnd len="sm" w="sm" type="none"/>
-                      <a:tailEnd len="sm" w="sm" type="none"/>
-                    </a:lnL>
-                    <a:lnR cap="flat" cmpd="sng" w="19050">
-                      <a:solidFill>
-                        <a:srgbClr val="262626"/>
-                      </a:solidFill>
-                      <a:prstDash val="solid"/>
-                      <a:round/>
-                      <a:headEnd len="sm" w="sm" type="none"/>
-                      <a:tailEnd len="sm" w="sm" type="none"/>
-                    </a:lnR>
-                    <a:lnT cap="flat" cmpd="sng" w="19050">
-                      <a:solidFill>
-                        <a:srgbClr val="262626"/>
-                      </a:solidFill>
-                      <a:prstDash val="solid"/>
-                      <a:round/>
-                      <a:headEnd len="sm" w="sm" type="none"/>
-                      <a:tailEnd len="sm" w="sm" type="none"/>
-                    </a:lnT>
-                    <a:lnB cap="flat" cmpd="sng" w="19050">
-                      <a:solidFill>
-                        <a:srgbClr val="262626"/>
-                      </a:solidFill>
-                      <a:prstDash val="solid"/>
-                      <a:round/>
-                      <a:headEnd len="sm" w="sm" type="none"/>
-                      <a:tailEnd len="sm" w="sm" type="none"/>
-                    </a:lnB>
-                  </a:tcPr>
-                </a:tc>
-                <a:tc>
-                  <a:txBody>
-                    <a:bodyPr/>
-                    <a:lstStyle/>
-                    <a:p>
-                      <a:pPr indent="0" lvl="0" marL="0" rtl="0" algn="l">
-                        <a:spcBef>
-                          <a:spcPts val="0"/>
-                        </a:spcBef>
-                        <a:spcAft>
-                          <a:spcPts val="0"/>
-                        </a:spcAft>
-                        <a:buNone/>
-                      </a:pPr>
-                      <a:r>
-                        <a:rPr b="1" lang="en-US" sz="900">
-                          <a:latin typeface="Times New Roman"/>
-                          <a:ea typeface="Times New Roman"/>
-                          <a:cs typeface="Times New Roman"/>
-                          <a:sym typeface="Times New Roman"/>
-                        </a:rPr>
-                        <a:t>0.430</a:t>
-                      </a:r>
-                    </a:p>
-                  </a:txBody>
-                  <a:tcPr marT="45720" marB="45720" marR="45720" marL="45720">
-                    <a:lnL cap="flat" cmpd="sng" w="19050">
-                      <a:solidFill>
-                        <a:srgbClr val="262626"/>
-                      </a:solidFill>
-                      <a:prstDash val="solid"/>
-                      <a:round/>
-                      <a:headEnd len="sm" w="sm" type="none"/>
-                      <a:tailEnd len="sm" w="sm" type="none"/>
-                    </a:lnL>
-                    <a:lnR cap="flat" cmpd="sng" w="19050">
-                      <a:solidFill>
-                        <a:srgbClr val="262626"/>
-                      </a:solidFill>
-                      <a:prstDash val="solid"/>
-                      <a:round/>
-                      <a:headEnd len="sm" w="sm" type="none"/>
-                      <a:tailEnd len="sm" w="sm" type="none"/>
-                    </a:lnR>
-                    <a:lnT cap="flat" cmpd="sng" w="19050">
-                      <a:solidFill>
-                        <a:srgbClr val="262626"/>
-                      </a:solidFill>
-                      <a:prstDash val="solid"/>
-                      <a:round/>
-                      <a:headEnd len="sm" w="sm" type="none"/>
-                      <a:tailEnd len="sm" w="sm" type="none"/>
-                    </a:lnT>
-                    <a:lnB cap="flat" cmpd="sng" w="19050">
-                      <a:solidFill>
-                        <a:srgbClr val="262626"/>
-                      </a:solidFill>
-                      <a:prstDash val="solid"/>
-                      <a:round/>
-                      <a:headEnd len="sm" w="sm" type="none"/>
-                      <a:tailEnd len="sm" w="sm" type="none"/>
-                    </a:lnB>
-                  </a:tcPr>
-                </a:tc>
-                <a:tc>
-                  <a:txBody>
-                    <a:bodyPr/>
-                    <a:lstStyle/>
-                    <a:p>
-                      <a:pPr indent="0" lvl="0" marL="0" rtl="0" algn="l">
-                        <a:spcBef>
-                          <a:spcPts val="0"/>
-                        </a:spcBef>
-                        <a:spcAft>
-                          <a:spcPts val="0"/>
-                        </a:spcAft>
-                        <a:buNone/>
-                      </a:pPr>
-                      <a:r>
-                        <a:rPr b="1" lang="en-US" sz="900">
-                          <a:latin typeface="Times New Roman"/>
-                          <a:ea typeface="Times New Roman"/>
-                          <a:cs typeface="Times New Roman"/>
-                          <a:sym typeface="Times New Roman"/>
-                        </a:rPr>
-                        <a:t>66%</a:t>
-                      </a:r>
-                    </a:p>
-                  </a:txBody>
-                  <a:tcPr marT="45720" marB="45720" marR="45720" marL="45720">
-                    <a:lnL cap="flat" cmpd="sng" w="19050">
-                      <a:solidFill>
-                        <a:srgbClr val="262626"/>
-                      </a:solidFill>
-                      <a:prstDash val="solid"/>
-                      <a:round/>
-                      <a:headEnd len="sm" w="sm" type="none"/>
-                      <a:tailEnd len="sm" w="sm" type="none"/>
-                    </a:lnL>
-                    <a:lnR cap="flat" cmpd="sng" w="19050">
-                      <a:solidFill>
-                        <a:srgbClr val="262626"/>
-                      </a:solidFill>
-                      <a:prstDash val="solid"/>
-                      <a:round/>
-                      <a:headEnd len="sm" w="sm" type="none"/>
-                      <a:tailEnd len="sm" w="sm" type="none"/>
-                    </a:lnR>
-                    <a:lnT cap="flat" cmpd="sng" w="19050">
-                      <a:solidFill>
-                        <a:srgbClr val="262626"/>
-                      </a:solidFill>
-                      <a:prstDash val="solid"/>
-                      <a:round/>
-                      <a:headEnd len="sm" w="sm" type="none"/>
-                      <a:tailEnd len="sm" w="sm" type="none"/>
-                    </a:lnT>
-                    <a:lnB cap="flat" cmpd="sng" w="19050">
-                      <a:solidFill>
-                        <a:srgbClr val="262626"/>
-                      </a:solidFill>
-                      <a:prstDash val="solid"/>
-                      <a:round/>
-                      <a:headEnd len="sm" w="sm" type="none"/>
-                      <a:tailEnd len="sm" w="sm" type="none"/>
-                    </a:lnB>
-                  </a:tcPr>
-                </a:tc>
-              </a:tr>
-              <a:tr h="360000">
-                <a:tc>
-                  <a:txBody>
-                    <a:bodyPr/>
-                    <a:lstStyle/>
-                    <a:p>
-                      <a:pPr indent="0" lvl="0" marL="0" rtl="0" algn="l">
-                        <a:spcBef>
-                          <a:spcPts val="0"/>
-                        </a:spcBef>
-                        <a:spcAft>
-                          <a:spcPts val="0"/>
-                        </a:spcAft>
-                        <a:buNone/>
-                      </a:pPr>
-                      <a:r>
                         <a:rPr lang="en-US" sz="900">
                           <a:latin typeface="Times New Roman"/>
                           <a:ea typeface="Times New Roman"/>
                           <a:cs typeface="Times New Roman"/>
                           <a:sym typeface="Times New Roman"/>
                         </a:rPr>
-                        <a:t>t_low raised by 0.04</a:t>
-                      </a:r>
-                    </a:p>
-                  </a:txBody>
-                  <a:tcPr marT="45720" marB="45720" marR="45720" marL="45720">
-                    <a:lnL cap="flat" cmpd="sng" w="19050">
-                      <a:solidFill>
-                        <a:srgbClr val="262626"/>
-                      </a:solidFill>
-                      <a:prstDash val="solid"/>
-                      <a:round/>
-                      <a:headEnd len="sm" w="sm" type="none"/>
-                      <a:tailEnd len="sm" w="sm" type="none"/>
-                    </a:lnL>
-                    <a:lnR cap="flat" cmpd="sng" w="19050">
-                      <a:solidFill>
-                        <a:srgbClr val="262626"/>
-                      </a:solidFill>
-                      <a:prstDash val="solid"/>
-                      <a:round/>
-                      <a:headEnd len="sm" w="sm" type="none"/>
-                      <a:tailEnd len="sm" w="sm" type="none"/>
-                    </a:lnR>
-                    <a:lnT cap="flat" cmpd="sng" w="19050">
-                      <a:solidFill>
-                        <a:srgbClr val="262626"/>
-                      </a:solidFill>
-                      <a:prstDash val="solid"/>
-                      <a:round/>
-                      <a:headEnd len="sm" w="sm" type="none"/>
-                      <a:tailEnd len="sm" w="sm" type="none"/>
-                    </a:lnT>
-                    <a:lnB cap="flat" cmpd="sng" w="19050">
-                      <a:solidFill>
-                        <a:srgbClr val="262626"/>
-                      </a:solidFill>
-                      <a:prstDash val="solid"/>
-                      <a:round/>
-                      <a:headEnd len="sm" w="sm" type="none"/>
-                      <a:tailEnd len="sm" w="sm" type="none"/>
-                    </a:lnB>
-                  </a:tcPr>
-                </a:tc>
-                <a:tc>
-                  <a:txBody>
-                    <a:bodyPr/>
-                    <a:lstStyle/>
-                    <a:p>
-                      <a:pPr indent="0" lvl="0" marL="0" rtl="0" algn="l">
-                        <a:spcBef>
-                          <a:spcPts val="0"/>
-                        </a:spcBef>
-                        <a:spcAft>
-                          <a:spcPts val="0"/>
-                        </a:spcAft>
-                        <a:buNone/>
-                      </a:pPr>
-                      <a:r>
-                        <a:rPr lang="en-US" sz="900">
-                          <a:latin typeface="Times New Roman"/>
-                          <a:ea typeface="Times New Roman"/>
-                          <a:cs typeface="Times New Roman"/>
-                          <a:sym typeface="Times New Roman"/>
-                        </a:rPr>
-                        <a:t>+ 0.04</a:t>
-                      </a:r>
-                    </a:p>
-                  </a:txBody>
-                  <a:tcPr marT="45720" marB="45720" marR="45720" marL="45720">
-                    <a:lnL cap="flat" cmpd="sng" w="19050">
-                      <a:solidFill>
-                        <a:srgbClr val="262626"/>
-                      </a:solidFill>
-                      <a:prstDash val="solid"/>
-                      <a:round/>
-                      <a:headEnd len="sm" w="sm" type="none"/>
-                      <a:tailEnd len="sm" w="sm" type="none"/>
-                    </a:lnL>
-                    <a:lnR cap="flat" cmpd="sng" w="19050">
-                      <a:solidFill>
-                        <a:srgbClr val="262626"/>
-                      </a:solidFill>
-                      <a:prstDash val="solid"/>
-                      <a:round/>
-                      <a:headEnd len="sm" w="sm" type="none"/>
-                      <a:tailEnd len="sm" w="sm" type="none"/>
-                    </a:lnR>
-                    <a:lnT cap="flat" cmpd="sng" w="19050">
-                      <a:solidFill>
-                        <a:srgbClr val="262626"/>
-                      </a:solidFill>
-                      <a:prstDash val="solid"/>
-                      <a:round/>
-                      <a:headEnd len="sm" w="sm" type="none"/>
-                      <a:tailEnd len="sm" w="sm" type="none"/>
-                    </a:lnT>
-                    <a:lnB cap="flat" cmpd="sng" w="19050">
-                      <a:solidFill>
-                        <a:srgbClr val="262626"/>
-                      </a:solidFill>
-                      <a:prstDash val="solid"/>
-                      <a:round/>
-                      <a:headEnd len="sm" w="sm" type="none"/>
-                      <a:tailEnd len="sm" w="sm" type="none"/>
-                    </a:lnB>
-                  </a:tcPr>
-                </a:tc>
-                <a:tc>
-                  <a:txBody>
-                    <a:bodyPr/>
-                    <a:lstStyle/>
-                    <a:p>
-                      <a:pPr indent="0" lvl="0" marL="0" rtl="0" algn="l">
-                        <a:spcBef>
-                          <a:spcPts val="0"/>
-                        </a:spcBef>
-                        <a:spcAft>
-                          <a:spcPts val="0"/>
-                        </a:spcAft>
-                        <a:buNone/>
-                      </a:pPr>
-                      <a:r>
-                        <a:rPr lang="en-US" sz="900">
-                          <a:latin typeface="Times New Roman"/>
-                          <a:ea typeface="Times New Roman"/>
-                          <a:cs typeface="Times New Roman"/>
-                          <a:sym typeface="Times New Roman"/>
-                        </a:rPr>
-                        <a:t>same</a:t>
+                        <a:t>0.8306</a:t>
                       </a:r>
                     </a:p>
                   </a:txBody>
@@ -20877,7 +20583,7 @@
                           <a:cs typeface="Times New Roman"/>
                           <a:sym typeface="Times New Roman"/>
                         </a:rPr>
-                        <a:t>t_low raised by 0.14</a:t>
+                        <a:t>t_low ≈ 0.35</a:t>
                       </a:r>
                     </a:p>
                   </a:txBody>
@@ -20941,7 +20647,7 @@
                           <a:cs typeface="Times New Roman"/>
                           <a:sym typeface="Times New Roman"/>
                         </a:rPr>
-                        <a:t>+ 0.14</a:t>
+                        <a:t>0.26 + 0.09</a:t>
                       </a:r>
                     </a:p>
                   </a:txBody>
@@ -21005,7 +20711,7 @@
                           <a:cs typeface="Times New Roman"/>
                           <a:sym typeface="Times New Roman"/>
                         </a:rPr>
-                        <a:t>same</a:t>
+                        <a:t>0.8306</a:t>
                       </a:r>
                     </a:p>
                   </a:txBody>
@@ -21069,7 +20775,7 @@
                           <a:cs typeface="Times New Roman"/>
                           <a:sym typeface="Times New Roman"/>
                         </a:rPr>
-                        <a:t>0.906</a:t>
+                        <a:t>0.867</a:t>
                       </a:r>
                     </a:p>
                   </a:txBody>
@@ -21133,7 +20839,7 @@
                           <a:cs typeface="Times New Roman"/>
                           <a:sym typeface="Times New Roman"/>
                         </a:rPr>
-                        <a:t>0.260</a:t>
+                        <a:t>0.264</a:t>
                       </a:r>
                     </a:p>
                   </a:txBody>
@@ -21261,7 +20967,7 @@
                           <a:cs typeface="Times New Roman"/>
                           <a:sym typeface="Times New Roman"/>
                         </a:rPr>
-                        <a:t>61%</a:t>
+                        <a:t>71%</a:t>
                       </a:r>
                     </a:p>
                   </a:txBody>
@@ -21391,7 +21097,7 @@
                           <a:cs typeface="Times New Roman"/>
                           <a:sym typeface="Times New Roman"/>
                         </a:rPr>
-                        <a:t>same</a:t>
+                        <a:t>0.26</a:t>
                       </a:r>
                     </a:p>
                   </a:txBody>
@@ -21455,7 +21161,7 @@
                           <a:cs typeface="Times New Roman"/>
                           <a:sym typeface="Times New Roman"/>
                         </a:rPr>
-                        <a:t>− 0.08</a:t>
+                        <a:t>≈ 0.75</a:t>
                       </a:r>
                     </a:p>
                   </a:txBody>
@@ -22659,153 +22365,6 @@
           </a:graphicData>
         </a:graphic>
       </p:graphicFrame>
-      <p:graphicFrame>
-        <p:nvGraphicFramePr>
-          <p:cNvPr id="73" name="Google Shape;73;p11"/>
-          <p:cNvGraphicFramePr/>
-          <p:nvPr/>
-        </p:nvGraphicFramePr>
-        <p:xfrm>
-          <a:off x="152400" y="152400"/>
-          <a:ext cx="3000000" cy="3000000"/>
-        </p:xfrm>
-        <a:graphic>
-          <a:graphicData uri="http://schemas.openxmlformats.org/drawingml/2006/table">
-            <a:tbl>
-              <a:tblPr>
-                <a:noFill/>
-                <a:tableStyleId>{AE357F98-E37F-4722-A336-238EF99134D1}</a:tableStyleId>
-              </a:tblPr>
-              <a:tblGrid>
-                <a:gridCol w="19050"/>
-              </a:tblGrid>
-              <a:tr h="19050">
-                <a:tc>
-                  <a:txBody>
-                    <a:bodyPr/>
-                    <a:lstStyle/>
-                    <a:p>
-                      <a:pPr indent="0" lvl="0" marL="0" rtl="0" algn="l">
-                        <a:spcBef>
-                          <a:spcPts val="0"/>
-                        </a:spcBef>
-                        <a:spcAft>
-                          <a:spcPts val="0"/>
-                        </a:spcAft>
-                        <a:buNone/>
-                      </a:pPr>
-                      <a:r>
-                        <a:t/>
-                      </a:r>
-                      <a:endParaRPr/>
-                    </a:p>
-                  </a:txBody>
-                  <a:tcPr marT="91425" marB="91425" marR="91425" marL="91425"/>
-                </a:tc>
-              </a:tr>
-            </a:tbl>
-          </a:graphicData>
-        </a:graphic>
-      </p:graphicFrame>
-      <p:graphicFrame>
-        <p:nvGraphicFramePr>
-          <p:cNvPr id="74" name="Google Shape;74;p11"/>
-          <p:cNvGraphicFramePr/>
-          <p:nvPr/>
-        </p:nvGraphicFramePr>
-        <p:xfrm>
-          <a:off x="304800" y="304800"/>
-          <a:ext cx="3000000" cy="3000000"/>
-        </p:xfrm>
-        <a:graphic>
-          <a:graphicData uri="http://schemas.openxmlformats.org/drawingml/2006/table">
-            <a:tbl>
-              <a:tblPr>
-                <a:noFill/>
-                <a:tableStyleId>{AE357F98-E37F-4722-A336-238EF99134D1}</a:tableStyleId>
-              </a:tblPr>
-              <a:tblGrid>
-                <a:gridCol w="1209675"/>
-              </a:tblGrid>
-              <a:tr h="190500">
-                <a:tc>
-                  <a:txBody>
-                    <a:bodyPr/>
-                    <a:lstStyle/>
-                    <a:p>
-                      <a:pPr indent="0" lvl="0" marL="0" rtl="0" algn="l">
-                        <a:lnSpc>
-                          <a:spcPct val="115000"/>
-                        </a:lnSpc>
-                        <a:spcBef>
-                          <a:spcPts val="0"/>
-                        </a:spcBef>
-                        <a:spcAft>
-                          <a:spcPts val="0"/>
-                        </a:spcAft>
-                        <a:buNone/>
-                      </a:pPr>
-                      <a:r>
-                        <a:t/>
-                      </a:r>
-                      <a:endParaRPr b="1" sz="1100"/>
-                    </a:p>
-                  </a:txBody>
-                  <a:tcPr marT="91425" marB="91425" marR="91425" marL="91425"/>
-                </a:tc>
-              </a:tr>
-            </a:tbl>
-          </a:graphicData>
-        </a:graphic>
-      </p:graphicFrame>
-      <p:graphicFrame>
-        <p:nvGraphicFramePr>
-          <p:cNvPr id="75" name="Google Shape;75;p11"/>
-          <p:cNvGraphicFramePr/>
-          <p:nvPr/>
-        </p:nvGraphicFramePr>
-        <p:xfrm>
-          <a:off x="304800" y="304800"/>
-          <a:ext cx="3000000" cy="3000000"/>
-        </p:xfrm>
-        <a:graphic>
-          <a:graphicData uri="http://schemas.openxmlformats.org/drawingml/2006/table">
-            <a:tbl>
-              <a:tblPr>
-                <a:noFill/>
-                <a:tableStyleId>{AE357F98-E37F-4722-A336-238EF99134D1}</a:tableStyleId>
-              </a:tblPr>
-              <a:tblGrid>
-                <a:gridCol w="19050"/>
-              </a:tblGrid>
-              <a:tr h="19050">
-                <a:tc>
-                  <a:txBody>
-                    <a:bodyPr/>
-                    <a:lstStyle/>
-                    <a:p>
-                      <a:pPr indent="0" lvl="0" marL="0" rtl="0" algn="l">
-                        <a:spcBef>
-                          <a:spcPts val="0"/>
-                        </a:spcBef>
-                        <a:spcAft>
-                          <a:spcPts val="0"/>
-                        </a:spcAft>
-                        <a:buNone/>
-                      </a:pPr>
-                      <a:r>
-                        <a:t/>
-                      </a:r>
-                      <a:endParaRPr/>
-                    </a:p>
-                  </a:txBody>
-                  <a:tcPr marT="91425" marB="91425" marR="91425" marL="91425"/>
-                </a:tc>
-              </a:tr>
-            </a:tbl>
-          </a:graphicData>
-        </a:graphic>
-      </p:graphicFrame>
       <p:sp>
         <p:nvSpPr>
           <p:cNvPr id="960" name="Results text 960"/>
@@ -22814,7 +22373,7 @@
         </p:nvSpPr>
         <p:spPr>
           <a:xfrm>
-            <a:off x="497000" y="4360000"/>
+            <a:off x="497000" y="4440000"/>
             <a:ext cx="8100000" cy="420000"/>
           </a:xfrm>
           <a:prstGeom prst="rect">
@@ -22850,7 +22409,7 @@
                 <a:cs typeface="Times New Roman"/>
                 <a:sym typeface="Times New Roman"/>
               </a:rPr>
-              <a:t xml:space="preserve">Play Store held-out halves pooled, live judge calls. t_low = 0.40 was confirmed on unseen short reviews under a rule written before the run and is used for app reviews and chat; it changed little on long bug reports, so tickets and bug reports keep 0.26. t_high 0.8306 transfers unchanged everywhere.</a:t>
+              <a:t xml:space="preserve">Play Store held-out halves pooled, live judge calls. t_high = 0.8306 (lowest similarity at which tuning pairs are ≥ 97% true duplicates) is used for every channel; t_low is 0.40 for app reviews and chat and 0.26 for tickets and bug reports, where raising it changed little. Before re-joining (see results).</a:t>
             </a:r>
           </a:p>
         </p:txBody>
@@ -23217,7 +22776,7 @@
           <p:nvPr/>
         </p:nvGraphicFramePr>
         <p:xfrm>
-          <a:off x="497000" y="1500000"/>
+          <a:off x="497000" y="1580000"/>
           <a:ext cx="8150000" cy="2920000"/>
         </p:xfrm>
         <a:graphic>
@@ -23621,7 +23180,7 @@
                   </a:tcPr>
                 </a:tc>
               </a:tr>
-              <a:tr h="330000">
+              <a:tr h="295000">
                 <a:tc>
                   <a:txBody>
                     <a:bodyPr/>
@@ -24007,7 +23566,7 @@
                   </a:tcPr>
                 </a:tc>
               </a:tr>
-              <a:tr h="330000">
+              <a:tr h="295000">
                 <a:tc>
                   <a:txBody>
                     <a:bodyPr/>
@@ -24393,7 +23952,7 @@
                   </a:tcPr>
                 </a:tc>
               </a:tr>
-              <a:tr h="330000">
+              <a:tr h="295000">
                 <a:tc>
                   <a:txBody>
                     <a:bodyPr/>
@@ -24779,7 +24338,7 @@
                   </a:tcPr>
                 </a:tc>
               </a:tr>
-              <a:tr h="330000">
+              <a:tr h="295000">
                 <a:tc>
                   <a:txBody>
                     <a:bodyPr/>
@@ -25165,7 +24724,7 @@
                   </a:tcPr>
                 </a:tc>
               </a:tr>
-              <a:tr h="330000">
+              <a:tr h="295000">
                 <a:tc>
                   <a:txBody>
                     <a:bodyPr/>
@@ -25551,7 +25110,7 @@
                   </a:tcPr>
                 </a:tc>
               </a:tr>
-              <a:tr h="330000">
+              <a:tr h="295000">
                 <a:tc>
                   <a:txBody>
                     <a:bodyPr/>
@@ -25937,7 +25496,7 @@
                   </a:tcPr>
                 </a:tc>
               </a:tr>
-              <a:tr h="330000">
+              <a:tr h="295000">
                 <a:tc>
                   <a:txBody>
                     <a:bodyPr/>
@@ -26323,7 +25882,7 @@
                   </a:tcPr>
                 </a:tc>
               </a:tr>
-              <a:tr h="330000">
+              <a:tr h="295000">
                 <a:tc>
                   <a:txBody>
                     <a:bodyPr/>
@@ -26713,153 +26272,6 @@
           </a:graphicData>
         </a:graphic>
       </p:graphicFrame>
-      <p:graphicFrame>
-        <p:nvGraphicFramePr>
-          <p:cNvPr id="73" name="Google Shape;73;p11"/>
-          <p:cNvGraphicFramePr/>
-          <p:nvPr/>
-        </p:nvGraphicFramePr>
-        <p:xfrm>
-          <a:off x="152400" y="152400"/>
-          <a:ext cx="3000000" cy="3000000"/>
-        </p:xfrm>
-        <a:graphic>
-          <a:graphicData uri="http://schemas.openxmlformats.org/drawingml/2006/table">
-            <a:tbl>
-              <a:tblPr>
-                <a:noFill/>
-                <a:tableStyleId>{AE357F98-E37F-4722-A336-238EF99134D1}</a:tableStyleId>
-              </a:tblPr>
-              <a:tblGrid>
-                <a:gridCol w="19050"/>
-              </a:tblGrid>
-              <a:tr h="19050">
-                <a:tc>
-                  <a:txBody>
-                    <a:bodyPr/>
-                    <a:lstStyle/>
-                    <a:p>
-                      <a:pPr indent="0" lvl="0" marL="0" rtl="0" algn="l">
-                        <a:spcBef>
-                          <a:spcPts val="0"/>
-                        </a:spcBef>
-                        <a:spcAft>
-                          <a:spcPts val="0"/>
-                        </a:spcAft>
-                        <a:buNone/>
-                      </a:pPr>
-                      <a:r>
-                        <a:t/>
-                      </a:r>
-                      <a:endParaRPr/>
-                    </a:p>
-                  </a:txBody>
-                  <a:tcPr marT="91425" marB="91425" marR="91425" marL="91425"/>
-                </a:tc>
-              </a:tr>
-            </a:tbl>
-          </a:graphicData>
-        </a:graphic>
-      </p:graphicFrame>
-      <p:graphicFrame>
-        <p:nvGraphicFramePr>
-          <p:cNvPr id="74" name="Google Shape;74;p11"/>
-          <p:cNvGraphicFramePr/>
-          <p:nvPr/>
-        </p:nvGraphicFramePr>
-        <p:xfrm>
-          <a:off x="304800" y="304800"/>
-          <a:ext cx="3000000" cy="3000000"/>
-        </p:xfrm>
-        <a:graphic>
-          <a:graphicData uri="http://schemas.openxmlformats.org/drawingml/2006/table">
-            <a:tbl>
-              <a:tblPr>
-                <a:noFill/>
-                <a:tableStyleId>{AE357F98-E37F-4722-A336-238EF99134D1}</a:tableStyleId>
-              </a:tblPr>
-              <a:tblGrid>
-                <a:gridCol w="1209675"/>
-              </a:tblGrid>
-              <a:tr h="190500">
-                <a:tc>
-                  <a:txBody>
-                    <a:bodyPr/>
-                    <a:lstStyle/>
-                    <a:p>
-                      <a:pPr indent="0" lvl="0" marL="0" rtl="0" algn="l">
-                        <a:lnSpc>
-                          <a:spcPct val="115000"/>
-                        </a:lnSpc>
-                        <a:spcBef>
-                          <a:spcPts val="0"/>
-                        </a:spcBef>
-                        <a:spcAft>
-                          <a:spcPts val="0"/>
-                        </a:spcAft>
-                        <a:buNone/>
-                      </a:pPr>
-                      <a:r>
-                        <a:t/>
-                      </a:r>
-                      <a:endParaRPr b="1" sz="1100"/>
-                    </a:p>
-                  </a:txBody>
-                  <a:tcPr marT="91425" marB="91425" marR="91425" marL="91425"/>
-                </a:tc>
-              </a:tr>
-            </a:tbl>
-          </a:graphicData>
-        </a:graphic>
-      </p:graphicFrame>
-      <p:graphicFrame>
-        <p:nvGraphicFramePr>
-          <p:cNvPr id="75" name="Google Shape;75;p11"/>
-          <p:cNvGraphicFramePr/>
-          <p:nvPr/>
-        </p:nvGraphicFramePr>
-        <p:xfrm>
-          <a:off x="304800" y="304800"/>
-          <a:ext cx="3000000" cy="3000000"/>
-        </p:xfrm>
-        <a:graphic>
-          <a:graphicData uri="http://schemas.openxmlformats.org/drawingml/2006/table">
-            <a:tbl>
-              <a:tblPr>
-                <a:noFill/>
-                <a:tableStyleId>{AE357F98-E37F-4722-A336-238EF99134D1}</a:tableStyleId>
-              </a:tblPr>
-              <a:tblGrid>
-                <a:gridCol w="19050"/>
-              </a:tblGrid>
-              <a:tr h="19050">
-                <a:tc>
-                  <a:txBody>
-                    <a:bodyPr/>
-                    <a:lstStyle/>
-                    <a:p>
-                      <a:pPr indent="0" lvl="0" marL="0" rtl="0" algn="l">
-                        <a:spcBef>
-                          <a:spcPts val="0"/>
-                        </a:spcBef>
-                        <a:spcAft>
-                          <a:spcPts val="0"/>
-                        </a:spcAft>
-                        <a:buNone/>
-                      </a:pPr>
-                      <a:r>
-                        <a:t/>
-                      </a:r>
-                      <a:endParaRPr/>
-                    </a:p>
-                  </a:txBody>
-                  <a:tcPr marT="91425" marB="91425" marR="91425" marL="91425"/>
-                </a:tc>
-              </a:tr>
-            </a:tbl>
-          </a:graphicData>
-        </a:graphic>
-      </p:graphicFrame>
       <p:sp>
         <p:nvSpPr>
           <p:cNvPr id="960" name="Results text 960"/>
@@ -26868,7 +26280,7 @@
         </p:nvSpPr>
         <p:spPr>
           <a:xfrm>
-            <a:off x="497000" y="4480000"/>
+            <a:off x="497000" y="4280000"/>
             <a:ext cx="8150000" cy="300000"/>
           </a:xfrm>
           <a:prstGeom prst="rect">
@@ -27271,7 +26683,7 @@
           <p:nvPr/>
         </p:nvGraphicFramePr>
         <p:xfrm>
-          <a:off x="497000" y="1500000"/>
+          <a:off x="497000" y="1580000"/>
           <a:ext cx="8150000" cy="2980000"/>
         </p:xfrm>
         <a:graphic>
@@ -29540,153 +28952,6 @@
                       <a:tailEnd len="sm" w="sm" type="none"/>
                     </a:lnB>
                   </a:tcPr>
-                </a:tc>
-              </a:tr>
-            </a:tbl>
-          </a:graphicData>
-        </a:graphic>
-      </p:graphicFrame>
-      <p:graphicFrame>
-        <p:nvGraphicFramePr>
-          <p:cNvPr id="73" name="Google Shape;73;p11"/>
-          <p:cNvGraphicFramePr/>
-          <p:nvPr/>
-        </p:nvGraphicFramePr>
-        <p:xfrm>
-          <a:off x="152400" y="152400"/>
-          <a:ext cx="3000000" cy="3000000"/>
-        </p:xfrm>
-        <a:graphic>
-          <a:graphicData uri="http://schemas.openxmlformats.org/drawingml/2006/table">
-            <a:tbl>
-              <a:tblPr>
-                <a:noFill/>
-                <a:tableStyleId>{AE357F98-E37F-4722-A336-238EF99134D1}</a:tableStyleId>
-              </a:tblPr>
-              <a:tblGrid>
-                <a:gridCol w="19050"/>
-              </a:tblGrid>
-              <a:tr h="19050">
-                <a:tc>
-                  <a:txBody>
-                    <a:bodyPr/>
-                    <a:lstStyle/>
-                    <a:p>
-                      <a:pPr indent="0" lvl="0" marL="0" rtl="0" algn="l">
-                        <a:spcBef>
-                          <a:spcPts val="0"/>
-                        </a:spcBef>
-                        <a:spcAft>
-                          <a:spcPts val="0"/>
-                        </a:spcAft>
-                        <a:buNone/>
-                      </a:pPr>
-                      <a:r>
-                        <a:t/>
-                      </a:r>
-                      <a:endParaRPr/>
-                    </a:p>
-                  </a:txBody>
-                  <a:tcPr marT="91425" marB="91425" marR="91425" marL="91425"/>
-                </a:tc>
-              </a:tr>
-            </a:tbl>
-          </a:graphicData>
-        </a:graphic>
-      </p:graphicFrame>
-      <p:graphicFrame>
-        <p:nvGraphicFramePr>
-          <p:cNvPr id="74" name="Google Shape;74;p11"/>
-          <p:cNvGraphicFramePr/>
-          <p:nvPr/>
-        </p:nvGraphicFramePr>
-        <p:xfrm>
-          <a:off x="304800" y="304800"/>
-          <a:ext cx="3000000" cy="3000000"/>
-        </p:xfrm>
-        <a:graphic>
-          <a:graphicData uri="http://schemas.openxmlformats.org/drawingml/2006/table">
-            <a:tbl>
-              <a:tblPr>
-                <a:noFill/>
-                <a:tableStyleId>{AE357F98-E37F-4722-A336-238EF99134D1}</a:tableStyleId>
-              </a:tblPr>
-              <a:tblGrid>
-                <a:gridCol w="1209675"/>
-              </a:tblGrid>
-              <a:tr h="190500">
-                <a:tc>
-                  <a:txBody>
-                    <a:bodyPr/>
-                    <a:lstStyle/>
-                    <a:p>
-                      <a:pPr indent="0" lvl="0" marL="0" rtl="0" algn="l">
-                        <a:lnSpc>
-                          <a:spcPct val="115000"/>
-                        </a:lnSpc>
-                        <a:spcBef>
-                          <a:spcPts val="0"/>
-                        </a:spcBef>
-                        <a:spcAft>
-                          <a:spcPts val="0"/>
-                        </a:spcAft>
-                        <a:buNone/>
-                      </a:pPr>
-                      <a:r>
-                        <a:t/>
-                      </a:r>
-                      <a:endParaRPr b="1" sz="1100"/>
-                    </a:p>
-                  </a:txBody>
-                  <a:tcPr marT="91425" marB="91425" marR="91425" marL="91425"/>
-                </a:tc>
-              </a:tr>
-            </a:tbl>
-          </a:graphicData>
-        </a:graphic>
-      </p:graphicFrame>
-      <p:graphicFrame>
-        <p:nvGraphicFramePr>
-          <p:cNvPr id="75" name="Google Shape;75;p11"/>
-          <p:cNvGraphicFramePr/>
-          <p:nvPr/>
-        </p:nvGraphicFramePr>
-        <p:xfrm>
-          <a:off x="304800" y="304800"/>
-          <a:ext cx="3000000" cy="3000000"/>
-        </p:xfrm>
-        <a:graphic>
-          <a:graphicData uri="http://schemas.openxmlformats.org/drawingml/2006/table">
-            <a:tbl>
-              <a:tblPr>
-                <a:noFill/>
-                <a:tableStyleId>{AE357F98-E37F-4722-A336-238EF99134D1}</a:tableStyleId>
-              </a:tblPr>
-              <a:tblGrid>
-                <a:gridCol w="19050"/>
-              </a:tblGrid>
-              <a:tr h="19050">
-                <a:tc>
-                  <a:txBody>
-                    <a:bodyPr/>
-                    <a:lstStyle/>
-                    <a:p>
-                      <a:pPr indent="0" lvl="0" marL="0" rtl="0" algn="l">
-                        <a:spcBef>
-                          <a:spcPts val="0"/>
-                        </a:spcBef>
-                        <a:spcAft>
-                          <a:spcPts val="0"/>
-                        </a:spcAft>
-                        <a:buNone/>
-                      </a:pPr>
-                      <a:r>
-                        <a:t/>
-                      </a:r>
-                      <a:endParaRPr/>
-                    </a:p>
-                  </a:txBody>
-                  <a:tcPr marT="91425" marB="91425" marR="91425" marL="91425"/>
                 </a:tc>
               </a:tr>
             </a:tbl>
@@ -30680,17 +29945,8 @@
                 <a:cs typeface="Times New Roman"/>
                 <a:sym typeface="Times New Roman"/>
               </a:rPr>
-              <a:t>Vision Helpdesk handles a large volume of customer complaints generated from support tickets, emails, and feedback systems. These complaints are unstructured textual data, making manual analysis time-consuming and inefficient.</a:t>
+              <a:t xml:space="preserve">Help-desk software companies such as Vision Helpdesk receive complaints from app reviews, support tickets, chat and web forms. The same problem is reported many times in different words, so agents triage it again and again, and no one sees how many customers a single problem affects.</a:t>
             </a:r>
-            <a:endParaRPr sz="1700">
-              <a:solidFill>
-                <a:schemeClr val="dk1"/>
-              </a:solidFill>
-              <a:latin typeface="Times New Roman"/>
-              <a:ea typeface="Times New Roman"/>
-              <a:cs typeface="Times New Roman"/>
-              <a:sym typeface="Times New Roman"/>
-            </a:endParaRPr>
           </a:p>
           <a:p>
             <a:pPr indent="0" lvl="0" marL="0" rtl="0" algn="just">
@@ -30720,17 +29976,8 @@
                 <a:cs typeface="Times New Roman"/>
                 <a:sym typeface="Times New Roman"/>
               </a:rPr>
-              <a:t>Existing systems mainly rely on keyword-based filtering or manual categorization, which fail to capture hidden patterns, sentiment intensity, and sudden spikes in complaints. As a result, when complaint volume increases rapidly, it becomes difficult to identify the root cause in time, leading to delayed responses and reduced customer satisfaction.</a:t>
+              <a:t xml:space="preserve">Existing tools group complaints by theme (“login”) rather than by problem (“the OTP never arrives”): keyword rules and topic models mix different problems, and a single similarity threshold either merges unrelated complaints or misses paraphrases. Feedback tools flag spikes with z-scores on whole categories, which miss a new problem growing from a low base.</a:t>
             </a:r>
-            <a:endParaRPr sz="1700">
-              <a:solidFill>
-                <a:schemeClr val="dk1"/>
-              </a:solidFill>
-              <a:latin typeface="Times New Roman"/>
-              <a:ea typeface="Times New Roman"/>
-              <a:cs typeface="Times New Roman"/>
-              <a:sym typeface="Times New Roman"/>
-            </a:endParaRPr>
           </a:p>
           <a:p>
             <a:pPr indent="0" lvl="0" marL="0" rtl="0" algn="just">
@@ -30760,17 +30007,8 @@
                 <a:cs typeface="Times New Roman"/>
                 <a:sym typeface="Times New Roman"/>
               </a:rPr>
-              <a:t>Therefore, there is a need to develop an intelligent system for Vision Helpdesk that can automatically detect complaint spikes, group similar issues, analyze sentiment, and generate root-cause diagnostics to improve response efficiency and service quality.</a:t>
+              <a:t xml:space="preserve">There is a need for a system that groups raw complaints into problem-level cases as they arrive with high precision, tracks each case’s volume to raise incidents early, adds sentiment, topic and root cause, and routes each incident to the responsible department after a person approves it.</a:t>
             </a:r>
-            <a:endParaRPr sz="1700">
-              <a:solidFill>
-                <a:schemeClr val="dk1"/>
-              </a:solidFill>
-              <a:latin typeface="Times New Roman"/>
-              <a:ea typeface="Times New Roman"/>
-              <a:cs typeface="Times New Roman"/>
-              <a:sym typeface="Times New Roman"/>
-            </a:endParaRPr>
           </a:p>
           <a:p>
             <a:pPr indent="0" lvl="0" marL="0" rtl="0" algn="just">
@@ -32513,7 +31751,7 @@
                           <a:cs typeface="Times New Roman"/>
                           <a:sym typeface="Times New Roman"/>
                         </a:rPr>
-                        <a:t>Two calibrated cuts: 0.26 and 0.8306</a:t>
+                        <a:t>Two calibrated cuts: t_low 0.26 / 0.40 and t_high 0.8306</a:t>
                       </a:r>
                     </a:p>
                   </a:txBody>
@@ -32877,153 +32115,6 @@
                       <a:tailEnd len="sm" w="sm" type="none"/>
                     </a:lnB>
                   </a:tcPr>
-                </a:tc>
-              </a:tr>
-            </a:tbl>
-          </a:graphicData>
-        </a:graphic>
-      </p:graphicFrame>
-      <p:graphicFrame>
-        <p:nvGraphicFramePr>
-          <p:cNvPr id="73" name="Google Shape;73;p11"/>
-          <p:cNvGraphicFramePr/>
-          <p:nvPr/>
-        </p:nvGraphicFramePr>
-        <p:xfrm>
-          <a:off x="152400" y="152400"/>
-          <a:ext cx="3000000" cy="3000000"/>
-        </p:xfrm>
-        <a:graphic>
-          <a:graphicData uri="http://schemas.openxmlformats.org/drawingml/2006/table">
-            <a:tbl>
-              <a:tblPr>
-                <a:noFill/>
-                <a:tableStyleId>{AE357F98-E37F-4722-A336-238EF99134D1}</a:tableStyleId>
-              </a:tblPr>
-              <a:tblGrid>
-                <a:gridCol w="19050"/>
-              </a:tblGrid>
-              <a:tr h="19050">
-                <a:tc>
-                  <a:txBody>
-                    <a:bodyPr/>
-                    <a:lstStyle/>
-                    <a:p>
-                      <a:pPr indent="0" lvl="0" marL="0" rtl="0" algn="l">
-                        <a:spcBef>
-                          <a:spcPts val="0"/>
-                        </a:spcBef>
-                        <a:spcAft>
-                          <a:spcPts val="0"/>
-                        </a:spcAft>
-                        <a:buNone/>
-                      </a:pPr>
-                      <a:r>
-                        <a:t/>
-                      </a:r>
-                      <a:endParaRPr/>
-                    </a:p>
-                  </a:txBody>
-                  <a:tcPr marT="91425" marB="91425" marR="91425" marL="91425"/>
-                </a:tc>
-              </a:tr>
-            </a:tbl>
-          </a:graphicData>
-        </a:graphic>
-      </p:graphicFrame>
-      <p:graphicFrame>
-        <p:nvGraphicFramePr>
-          <p:cNvPr id="74" name="Google Shape;74;p11"/>
-          <p:cNvGraphicFramePr/>
-          <p:nvPr/>
-        </p:nvGraphicFramePr>
-        <p:xfrm>
-          <a:off x="304800" y="304800"/>
-          <a:ext cx="3000000" cy="3000000"/>
-        </p:xfrm>
-        <a:graphic>
-          <a:graphicData uri="http://schemas.openxmlformats.org/drawingml/2006/table">
-            <a:tbl>
-              <a:tblPr>
-                <a:noFill/>
-                <a:tableStyleId>{AE357F98-E37F-4722-A336-238EF99134D1}</a:tableStyleId>
-              </a:tblPr>
-              <a:tblGrid>
-                <a:gridCol w="1209675"/>
-              </a:tblGrid>
-              <a:tr h="190500">
-                <a:tc>
-                  <a:txBody>
-                    <a:bodyPr/>
-                    <a:lstStyle/>
-                    <a:p>
-                      <a:pPr indent="0" lvl="0" marL="0" rtl="0" algn="l">
-                        <a:lnSpc>
-                          <a:spcPct val="115000"/>
-                        </a:lnSpc>
-                        <a:spcBef>
-                          <a:spcPts val="0"/>
-                        </a:spcBef>
-                        <a:spcAft>
-                          <a:spcPts val="0"/>
-                        </a:spcAft>
-                        <a:buNone/>
-                      </a:pPr>
-                      <a:r>
-                        <a:t/>
-                      </a:r>
-                      <a:endParaRPr b="1" sz="1100"/>
-                    </a:p>
-                  </a:txBody>
-                  <a:tcPr marT="91425" marB="91425" marR="91425" marL="91425"/>
-                </a:tc>
-              </a:tr>
-            </a:tbl>
-          </a:graphicData>
-        </a:graphic>
-      </p:graphicFrame>
-      <p:graphicFrame>
-        <p:nvGraphicFramePr>
-          <p:cNvPr id="75" name="Google Shape;75;p11"/>
-          <p:cNvGraphicFramePr/>
-          <p:nvPr/>
-        </p:nvGraphicFramePr>
-        <p:xfrm>
-          <a:off x="304800" y="304800"/>
-          <a:ext cx="3000000" cy="3000000"/>
-        </p:xfrm>
-        <a:graphic>
-          <a:graphicData uri="http://schemas.openxmlformats.org/drawingml/2006/table">
-            <a:tbl>
-              <a:tblPr>
-                <a:noFill/>
-                <a:tableStyleId>{AE357F98-E37F-4722-A336-238EF99134D1}</a:tableStyleId>
-              </a:tblPr>
-              <a:tblGrid>
-                <a:gridCol w="19050"/>
-              </a:tblGrid>
-              <a:tr h="19050">
-                <a:tc>
-                  <a:txBody>
-                    <a:bodyPr/>
-                    <a:lstStyle/>
-                    <a:p>
-                      <a:pPr indent="0" lvl="0" marL="0" rtl="0" algn="l">
-                        <a:spcBef>
-                          <a:spcPts val="0"/>
-                        </a:spcBef>
-                        <a:spcAft>
-                          <a:spcPts val="0"/>
-                        </a:spcAft>
-                        <a:buNone/>
-                      </a:pPr>
-                      <a:r>
-                        <a:t/>
-                      </a:r>
-                      <a:endParaRPr/>
-                    </a:p>
-                  </a:txBody>
-                  <a:tcPr marT="91425" marB="91425" marR="91425" marL="91425"/>
                 </a:tc>
               </a:tr>
             </a:tbl>
@@ -34409,7 +33500,7 @@
                 <a:cs typeface="Times New Roman"/>
                 <a:sym typeface="Times New Roman"/>
               </a:rPr>
-              <a:t xml:space="preserve"> similarity ≥ 0.8306 joins automatically, &lt; 0.26 opens a new case; our 0.71 falls in between, so the LLM judge decides.</a:t>
+              <a:t xml:space="preserve"> similarity ≥ 0.8306 joins automatically; below t_low (0.40 for app reviews and chat, 0.26 for tickets) opens a new case; our 0.71 falls in between, so the LLM judge decides.</a:t>
             </a:r>
           </a:p>
           <a:p>
@@ -35513,7 +34604,7 @@
                 <a:cs typeface="Times New Roman"/>
                 <a:sym typeface="Times New Roman"/>
               </a:rPr>
-              <a:t xml:space="preserve">Precision 0.80</a:t>
+              <a:t xml:space="preserve">Precision 0.83</a:t>
             </a:r>
             <a:r>
               <a:rPr lang="en-US" sz="1200">
@@ -35525,7 +34616,7 @@
                 <a:cs typeface="Times New Roman"/>
                 <a:sym typeface="Times New Roman"/>
               </a:rPr>
-              <a:t xml:space="preserve"> on human-labelled Play Store reviews.</a:t>
+              <a:t xml:space="preserve"> on human-labelled Play Store reviews (0.80 before the short-text setting).</a:t>
             </a:r>
           </a:p>
           <a:p>
@@ -35553,7 +34644,7 @@
                 <a:cs typeface="Times New Roman"/>
                 <a:sym typeface="Times New Roman"/>
               </a:rPr>
-              <a:t xml:space="preserve">F1 0.46</a:t>
+              <a:t xml:space="preserve">F1 0.49</a:t>
             </a:r>
             <a:r>
               <a:rPr lang="en-US" sz="1200">
@@ -35633,7 +34724,7 @@
                 <a:cs typeface="Times New Roman"/>
                 <a:sym typeface="Times New Roman"/>
               </a:rPr>
-              <a:t xml:space="preserve">At equal precision (0.80):</a:t>
+              <a:t xml:space="preserve">At precision 0.80 or more:</a:t>
             </a:r>
             <a:r>
               <a:rPr lang="en-US" sz="1200">
@@ -35645,7 +34736,7 @@
                 <a:cs typeface="Times New Roman"/>
                 <a:sym typeface="Times New Roman"/>
               </a:rPr>
-              <a:t xml:space="preserve"> 33% of duplicates found vs about 1% for BM25, MinHash and SimHash.</a:t>
+              <a:t xml:space="preserve"> 35% of duplicates found vs about 1% for BM25, MinHash and SimHash.</a:t>
             </a:r>
           </a:p>
         </p:txBody>

</xml_diff>

<commit_message>
Deck: more platform examples, numeric band in flowchart, contents row 6, conclusion wording
Co-Authored-By: Claude Opus 5.5 <noreply@anthropic.com>
</commit_message>
<xml_diff>
--- a/reports/ppt/InsightDesk_final.pptx
+++ b/reports/ppt/InsightDesk_final.pptx
@@ -9881,7 +9881,7 @@
                 <a:cs typeface="Times New Roman"/>
                 <a:sym typeface="Times New Roman"/>
               </a:rPr>
-              <a:t xml:space="preserve">InsightDesk turns raw customer complaints into problem cases as they arrive. Similarity retrieval narrows each complaint to a few candidate cases, calibrated thresholds settle the clear ones, and an LLM judge decides the rest; a re-joining pass merges split cases. On real reviews it reaches precision 0.83, recall 0.35 and F1 0.49, the highest of every method tested; a higher lower threshold for short-text channels improved precision and recall together while cutting LLM calls by about a quarter, and the same upper threshold transfers unchanged to bug reports (F1 0.78). A Poisson CUSUM and a vague-complaint alarm detect incidents that the usual z-score misses, and every escalation is approved by a person before an email reaches the department.</a:t>
+              <a:t xml:space="preserve">InsightDesk turns raw customer complaints into problem cases as they arrive. Similarity retrieval narrows each complaint to a few candidate cases, calibrated thresholds settle the clear ones, and an LLM judge decides the rest; a re-joining pass merges split cases. On real reviews it reaches precision 0.83 and recall 0.35, an F1 of 0.49 that is the highest of every method tested; a higher lower threshold for short-text channels improved precision and recall together while cutting LLM calls by about a quarter, and the same upper threshold transfers unchanged to bug reports (F1 0.78). A Poisson CUSUM and a vague-complaint alarm detect incidents that the usual z-score misses, and every escalation is approved by a person before an email reaches the department.</a:t>
             </a:r>
           </a:p>
         </p:txBody>
@@ -17396,7 +17396,7 @@
                     <a:bodyPr/>
                     <a:lstStyle/>
                     <a:p>
-                      <a:pPr indent="0" lvl="0" marL="0" marR="0" rtl="0" algn="l">
+                      <a:pPr indent="0" lvl="0" marL="0" marR="0" rtl="0" algn="ctr">
                         <a:lnSpc>
                           <a:spcPct val="115000"/>
                         </a:lnSpc>
@@ -17414,22 +17414,13 @@
                         <a:buNone/>
                       </a:pPr>
                       <a:r>
-                        <a:rPr lang="en-US" sz="1200" u="none" cap="none" strike="noStrike">
+                        <a:rPr lang="en-US" sz="1200">
                           <a:latin typeface="Times New Roman"/>
                           <a:ea typeface="Times New Roman"/>
                           <a:cs typeface="Times New Roman"/>
                           <a:sym typeface="Times New Roman"/>
                         </a:rPr>
                         <a:t>6.</a:t>
-                      </a:r>
-                      <a:r>
-                        <a:rPr lang="en-US" sz="1200">
-                          <a:latin typeface="Times New Roman"/>
-                          <a:ea typeface="Times New Roman"/>
-                          <a:cs typeface="Times New Roman"/>
-                          <a:sym typeface="Times New Roman"/>
-                        </a:rPr>
-                        <a:t/>
                       </a:r>
                       <a:r>
                         <a:rPr lang="en-US" sz="1200" u="none" cap="none" strike="noStrike">
@@ -29945,7 +29936,7 @@
                 <a:cs typeface="Times New Roman"/>
                 <a:sym typeface="Times New Roman"/>
               </a:rPr>
-              <a:t xml:space="preserve">Help-desk software companies such as Vision Helpdesk receive complaints from app reviews, support tickets, chat and web forms. The same problem is reported many times in different words, so agents triage it again and again, and no one sees how many customers a single problem affects.</a:t>
+              <a:t xml:space="preserve">Help-desk and customer-support platforms such as Vision Helpdesk, Zendesk, Freshdesk, Intercom and ServiceNow, and the companies that use them, receive complaints from app reviews, support tickets, chat and web forms. The same problem is reported many times in different words, so agents triage it again and again, and no one sees how many customers a single problem affects.</a:t>
             </a:r>
           </a:p>
           <a:p>

</xml_diff>

<commit_message>
Deck: system architecture slide after the flowchart
</commit_message>
<xml_diff>
--- a/reports/ppt/InsightDesk_final.pptx
+++ b/reports/ppt/InsightDesk_final.pptx
@@ -16,6 +16,7 @@
     <p:sldId id="272" r:id="rId23"/>
     <p:sldId id="260" r:id="rId11"/>
     <p:sldId id="261" r:id="rId12"/>
+    <p:sldId id="280" r:id="rId31"/>
     <p:sldId id="262" r:id="rId13"/>
     <p:sldId id="263" r:id="rId14"/>
     <p:sldId id="275" r:id="rId26"/>
@@ -17286,7 +17287,7 @@
                           <a:cs typeface="Times New Roman"/>
                           <a:sym typeface="Times New Roman"/>
                         </a:rPr>
-                        <a:t>Flow Diagram</a:t>
+                        <a:t>Flow Diagram &amp; Architecture</a:t>
                       </a:r>
                       <a:endParaRPr sz="1200" u="none" cap="none" strike="noStrike">
                         <a:latin typeface="Times New Roman"/>
@@ -29569,6 +29570,660 @@
                 <a:sym typeface="Times New Roman"/>
               </a:rPr>
               <a:t xml:space="preserve"> re-clustered automatically every 6 hours when cases grow by 20% or outliers exceed 15%.</a:t>
+            </a:r>
+          </a:p>
+        </p:txBody>
+      </p:sp>
+    </p:spTree>
+  </p:cSld>
+  <p:clrMapOvr>
+    <a:masterClrMapping/>
+  </p:clrMapOvr>
+</p:sld>
+</file>
+
+<file path=ppt/slides/slide25.xml><?xml version="1.0" encoding="utf-8"?>
+<p:sld xmlns:a="http://schemas.openxmlformats.org/drawingml/2006/main" xmlns:r="http://schemas.openxmlformats.org/officeDocument/2006/relationships" xmlns:mc="http://schemas.openxmlformats.org/markup-compatibility/2006" xmlns:mv="urn:schemas-microsoft-com:mac:vml" xmlns:p="http://schemas.openxmlformats.org/presentationml/2006/main" xmlns:c="http://schemas.openxmlformats.org/drawingml/2006/chart" xmlns:dgm="http://schemas.openxmlformats.org/drawingml/2006/diagram" xmlns:o="urn:schemas-microsoft-com:office:office" xmlns:v="urn:schemas-microsoft-com:vml" xmlns:pvml="urn:schemas-microsoft-com:office:powerpoint" xmlns:com="http://schemas.openxmlformats.org/drawingml/2006/compatibility" xmlns:p14="http://schemas.microsoft.com/office/powerpoint/2010/main" xmlns:p15="http://schemas.microsoft.com/office/powerpoint/2012/main" xmlns:ahyp="http://schemas.microsoft.com/office/drawing/2018/hyperlinkcolor">
+  <p:cSld>
+    <p:spTree>
+      <p:nvGrpSpPr>
+        <p:cNvPr id="87" name="Shape 87"/>
+        <p:cNvGrpSpPr/>
+        <p:nvPr/>
+      </p:nvGrpSpPr>
+      <p:grpSpPr>
+        <a:xfrm>
+          <a:off x="0" y="0"/>
+          <a:ext cx="0" cy="0"/>
+          <a:chOff x="0" y="0"/>
+          <a:chExt cx="0" cy="0"/>
+        </a:xfrm>
+      </p:grpSpPr>
+      <p:sp>
+        <p:nvSpPr>
+          <p:cNvPr id="88" name="Google Shape;88;p13"/>
+          <p:cNvSpPr txBox="1"/>
+          <p:nvPr/>
+        </p:nvSpPr>
+        <p:spPr>
+          <a:xfrm>
+            <a:off x="257175" y="4836100"/>
+            <a:ext cx="1343100" cy="276900"/>
+          </a:xfrm>
+          <a:prstGeom prst="rect">
+            <a:avLst/>
+          </a:prstGeom>
+          <a:noFill/>
+          <a:ln>
+            <a:noFill/>
+          </a:ln>
+        </p:spPr>
+        <p:txBody>
+          <a:bodyPr anchorCtr="0" anchor="t" bIns="45700" lIns="91425" spcFirstLastPara="1" rIns="91425" wrap="square" tIns="45700">
+            <a:spAutoFit/>
+          </a:bodyPr>
+          <a:lstStyle/>
+          <a:p>
+            <a:pPr indent="0" lvl="0" marL="0" marR="0" rtl="0" algn="l">
+              <a:lnSpc>
+                <a:spcPct val="100000"/>
+              </a:lnSpc>
+              <a:spcBef>
+                <a:spcPts val="0"/>
+              </a:spcBef>
+              <a:spcAft>
+                <a:spcPts val="0"/>
+              </a:spcAft>
+              <a:buClr>
+                <a:srgbClr val="000000"/>
+              </a:buClr>
+              <a:buSzPts val="1200"/>
+              <a:buFont typeface="Arial"/>
+              <a:buNone/>
+            </a:pPr>
+            <a:r>
+              <a:rPr b="0" i="0" lang="en-US" sz="1200" u="none" cap="none" strike="noStrike">
+                <a:solidFill>
+                  <a:schemeClr val="lt1"/>
+                </a:solidFill>
+                <a:latin typeface="Times New Roman"/>
+                <a:ea typeface="Times New Roman"/>
+                <a:cs typeface="Times New Roman"/>
+                <a:sym typeface="Times New Roman"/>
+              </a:rPr>
+              <a:t>26/6/2023</a:t>
+            </a:r>
+            <a:endParaRPr b="0" i="0" sz="1200" u="none" cap="none" strike="noStrike">
+              <a:solidFill>
+                <a:schemeClr val="lt1"/>
+              </a:solidFill>
+              <a:latin typeface="Times New Roman"/>
+              <a:ea typeface="Times New Roman"/>
+              <a:cs typeface="Times New Roman"/>
+              <a:sym typeface="Times New Roman"/>
+            </a:endParaRPr>
+          </a:p>
+        </p:txBody>
+      </p:sp>
+      <p:sp>
+        <p:nvSpPr>
+          <p:cNvPr id="89" name="Google Shape;89;p13"/>
+          <p:cNvSpPr/>
+          <p:nvPr/>
+        </p:nvSpPr>
+        <p:spPr>
+          <a:xfrm>
+            <a:off x="6309074" y="4882011"/>
+            <a:ext cx="2118600" cy="108900"/>
+          </a:xfrm>
+          <a:prstGeom prst="rect">
+            <a:avLst/>
+          </a:prstGeom>
+          <a:solidFill>
+            <a:srgbClr val="C00000"/>
+          </a:solidFill>
+          <a:ln>
+            <a:noFill/>
+          </a:ln>
+        </p:spPr>
+        <p:txBody>
+          <a:bodyPr anchorCtr="0" anchor="ctr" bIns="45700" lIns="91425" spcFirstLastPara="1" rIns="91425" wrap="square" tIns="45700">
+            <a:noAutofit/>
+          </a:bodyPr>
+          <a:lstStyle/>
+          <a:p>
+            <a:pPr indent="0" lvl="0" marL="0" marR="0" rtl="0" algn="ctr">
+              <a:lnSpc>
+                <a:spcPct val="100000"/>
+              </a:lnSpc>
+              <a:spcBef>
+                <a:spcPts val="0"/>
+              </a:spcBef>
+              <a:spcAft>
+                <a:spcPts val="0"/>
+              </a:spcAft>
+              <a:buClr>
+                <a:srgbClr val="000000"/>
+              </a:buClr>
+              <a:buSzPts val="2493"/>
+              <a:buFont typeface="Arial"/>
+              <a:buNone/>
+            </a:pPr>
+            <a:r>
+              <a:t/>
+            </a:r>
+            <a:endParaRPr b="0" i="0" sz="2495" u="none" cap="none" strike="noStrike">
+              <a:solidFill>
+                <a:schemeClr val="lt1"/>
+              </a:solidFill>
+              <a:latin typeface="Arial"/>
+              <a:ea typeface="Arial"/>
+              <a:cs typeface="Arial"/>
+              <a:sym typeface="Arial"/>
+            </a:endParaRPr>
+          </a:p>
+        </p:txBody>
+      </p:sp>
+      <p:pic>
+        <p:nvPicPr>
+          <p:cNvPr id="90" name="Google Shape;90;p13"/>
+          <p:cNvPicPr preferRelativeResize="0"/>
+          <p:nvPr/>
+        </p:nvPicPr>
+        <p:blipFill rotWithShape="1">
+          <a:blip r:embed="rId3">
+            <a:alphaModFix/>
+          </a:blip>
+          <a:srcRect b="0" l="0" r="0" t="0"/>
+          <a:stretch/>
+        </p:blipFill>
+        <p:spPr>
+          <a:xfrm>
+            <a:off x="0" y="0"/>
+            <a:ext cx="9143999" cy="1332186"/>
+          </a:xfrm>
+          <a:prstGeom prst="rect">
+            <a:avLst/>
+          </a:prstGeom>
+          <a:noFill/>
+          <a:ln>
+            <a:noFill/>
+          </a:ln>
+        </p:spPr>
+      </p:pic>
+      <p:sp>
+        <p:nvSpPr>
+          <p:cNvPr id="91" name="Google Shape;91;p13"/>
+          <p:cNvSpPr/>
+          <p:nvPr/>
+        </p:nvSpPr>
+        <p:spPr>
+          <a:xfrm>
+            <a:off x="2105025" y="4836100"/>
+            <a:ext cx="6807300" cy="322800"/>
+          </a:xfrm>
+          <a:prstGeom prst="rect">
+            <a:avLst/>
+          </a:prstGeom>
+          <a:solidFill>
+            <a:srgbClr val="C00000"/>
+          </a:solidFill>
+          <a:ln>
+            <a:noFill/>
+          </a:ln>
+        </p:spPr>
+        <p:txBody>
+          <a:bodyPr anchorCtr="0" anchor="ctr" bIns="45700" lIns="91425" spcFirstLastPara="1" rIns="91425" wrap="square" tIns="45700">
+            <a:noAutofit/>
+          </a:bodyPr>
+          <a:lstStyle/>
+          <a:p>
+            <a:pPr indent="0" lvl="0" marL="0" marR="0" rtl="0" algn="ctr">
+              <a:lnSpc>
+                <a:spcPct val="100000"/>
+              </a:lnSpc>
+              <a:spcBef>
+                <a:spcPts val="0"/>
+              </a:spcBef>
+              <a:spcAft>
+                <a:spcPts val="0"/>
+              </a:spcAft>
+              <a:buClr>
+                <a:srgbClr val="000000"/>
+              </a:buClr>
+              <a:buSzPts val="2493"/>
+              <a:buFont typeface="Arial"/>
+              <a:buNone/>
+            </a:pPr>
+            <a:r>
+              <a:t/>
+            </a:r>
+            <a:endParaRPr b="0" i="0" sz="2495" u="none" cap="none" strike="noStrike">
+              <a:solidFill>
+                <a:schemeClr val="lt1"/>
+              </a:solidFill>
+              <a:latin typeface="Arial"/>
+              <a:ea typeface="Arial"/>
+              <a:cs typeface="Arial"/>
+              <a:sym typeface="Arial"/>
+            </a:endParaRPr>
+          </a:p>
+        </p:txBody>
+      </p:sp>
+      <p:sp>
+        <p:nvSpPr>
+          <p:cNvPr id="92" name="Google Shape;92;p13"/>
+          <p:cNvSpPr/>
+          <p:nvPr/>
+        </p:nvSpPr>
+        <p:spPr>
+          <a:xfrm>
+            <a:off x="8909371" y="1288085"/>
+            <a:ext cx="230400" cy="3941400"/>
+          </a:xfrm>
+          <a:prstGeom prst="rect">
+            <a:avLst/>
+          </a:prstGeom>
+          <a:solidFill>
+            <a:srgbClr val="C00000"/>
+          </a:solidFill>
+          <a:ln>
+            <a:noFill/>
+          </a:ln>
+        </p:spPr>
+        <p:txBody>
+          <a:bodyPr anchorCtr="0" anchor="ctr" bIns="45700" lIns="91425" spcFirstLastPara="1" rIns="91425" wrap="square" tIns="45700">
+            <a:noAutofit/>
+          </a:bodyPr>
+          <a:lstStyle/>
+          <a:p>
+            <a:pPr indent="0" lvl="0" marL="0" marR="0" rtl="0" algn="ctr">
+              <a:lnSpc>
+                <a:spcPct val="100000"/>
+              </a:lnSpc>
+              <a:spcBef>
+                <a:spcPts val="0"/>
+              </a:spcBef>
+              <a:spcAft>
+                <a:spcPts val="0"/>
+              </a:spcAft>
+              <a:buClr>
+                <a:srgbClr val="000000"/>
+              </a:buClr>
+              <a:buSzPts val="2493"/>
+              <a:buFont typeface="Arial"/>
+              <a:buNone/>
+            </a:pPr>
+            <a:r>
+              <a:t/>
+            </a:r>
+            <a:endParaRPr b="0" i="0" sz="2495" u="none" cap="none" strike="noStrike">
+              <a:solidFill>
+                <a:schemeClr val="lt1"/>
+              </a:solidFill>
+              <a:latin typeface="Arial"/>
+              <a:ea typeface="Arial"/>
+              <a:cs typeface="Arial"/>
+              <a:sym typeface="Arial"/>
+            </a:endParaRPr>
+          </a:p>
+        </p:txBody>
+      </p:sp>
+      <p:sp>
+        <p:nvSpPr>
+          <p:cNvPr id="93" name="Google Shape;93;p13"/>
+          <p:cNvSpPr/>
+          <p:nvPr/>
+        </p:nvSpPr>
+        <p:spPr>
+          <a:xfrm>
+            <a:off x="1728300" y="1219200"/>
+            <a:ext cx="5687400" cy="322800"/>
+          </a:xfrm>
+          <a:prstGeom prst="rect">
+            <a:avLst/>
+          </a:prstGeom>
+          <a:noFill/>
+          <a:ln>
+            <a:noFill/>
+          </a:ln>
+        </p:spPr>
+        <p:txBody>
+          <a:bodyPr anchorCtr="0" anchor="t" bIns="45700" lIns="91425" spcFirstLastPara="1" rIns="91425" wrap="square" tIns="45700">
+            <a:noAutofit/>
+          </a:bodyPr>
+          <a:lstStyle/>
+          <a:p>
+            <a:pPr indent="0" lvl="0" marL="0" marR="0" rtl="0" algn="ctr">
+              <a:lnSpc>
+                <a:spcPct val="100000"/>
+              </a:lnSpc>
+              <a:spcBef>
+                <a:spcPts val="0"/>
+              </a:spcBef>
+              <a:spcAft>
+                <a:spcPts val="0"/>
+              </a:spcAft>
+              <a:buClr>
+                <a:srgbClr val="000000"/>
+              </a:buClr>
+              <a:buSzPts val="1600"/>
+              <a:buFont typeface="Arial"/>
+              <a:buNone/>
+            </a:pPr>
+            <a:r>
+              <a:rPr b="1" i="0" lang="en-US" sz="1600" u="none" cap="none" strike="noStrike">
+                <a:solidFill>
+                  <a:srgbClr val="000000"/>
+                </a:solidFill>
+                <a:latin typeface="Times New Roman"/>
+                <a:ea typeface="Times New Roman"/>
+                <a:cs typeface="Times New Roman"/>
+                <a:sym typeface="Times New Roman"/>
+              </a:rPr>
+              <a:t>SYSTEM ARCHITECTURE</a:t>
+            </a:r>
+            <a:endParaRPr b="1" i="0" sz="1600" u="none" cap="none" strike="noStrike">
+              <a:solidFill>
+                <a:srgbClr val="000000"/>
+              </a:solidFill>
+              <a:latin typeface="Times New Roman"/>
+              <a:ea typeface="Times New Roman"/>
+              <a:cs typeface="Times New Roman"/>
+              <a:sym typeface="Times New Roman"/>
+            </a:endParaRPr>
+          </a:p>
+        </p:txBody>
+      </p:sp>
+      <p:pic>
+        <p:nvPicPr>
+          <p:cNvPr id="94" name="Google Shape;94;p13" title="InsightDesk_flowchart.png"/>
+          <p:cNvPicPr preferRelativeResize="0"/>
+          <p:nvPr/>
+        </p:nvPicPr>
+        <p:blipFill rotWithShape="1">
+          <a:blip r:embed="rId4">
+            <a:alphaModFix/>
+          </a:blip>
+          <a:srcRect b="9198" l="0" r="0" t="0"/>
+          <a:stretch/>
+        </p:blipFill>
+        <p:spPr>
+          <a:xfrm>
+            <a:off x="420000" y="1520000"/>
+            <a:ext cx="2950000" cy="3083891"/>
+          </a:xfrm>
+          <a:prstGeom prst="rect">
+            <a:avLst/>
+          </a:prstGeom>
+          <a:noFill/>
+          <a:ln>
+            <a:noFill/>
+          </a:ln>
+        </p:spPr>
+      </p:pic>
+      <p:sp>
+        <p:nvSpPr>
+          <p:cNvPr id="990" name="Results text 990"/>
+          <p:cNvSpPr txBox="1"/>
+          <p:nvPr/>
+        </p:nvSpPr>
+        <p:spPr>
+          <a:xfrm>
+            <a:off x="3800000" y="1450000"/>
+            <a:ext cx="4950000" cy="3300000"/>
+          </a:xfrm>
+          <a:prstGeom prst="rect">
+            <a:avLst/>
+          </a:prstGeom>
+          <a:noFill/>
+          <a:ln>
+            <a:noFill/>
+          </a:ln>
+        </p:spPr>
+        <p:txBody>
+          <a:bodyPr anchorCtr="0" anchor="t" bIns="45720" lIns="45720" spcFirstLastPara="1" rIns="45720" wrap="square" tIns="45720">
+            <a:noAutofit/>
+          </a:bodyPr>
+          <a:lstStyle/>
+          <a:p>
+            <a:pPr indent="-285750" lvl="0" marL="342900" rtl="0" algn="l">
+              <a:spcBef>
+                <a:spcPts val="0"/>
+              </a:spcBef>
+              <a:spcAft>
+                <a:spcPts val="300"/>
+              </a:spcAft>
+              <a:buClr>
+                <a:schemeClr val="dk1"/>
+              </a:buClr>
+              <a:buSzPts val="1150"/>
+              <a:buFont typeface="Times New Roman"/>
+              <a:buChar char="●"/>
+            </a:pPr>
+            <a:r>
+              <a:rPr b="1" lang="en-US" sz="1150">
+                <a:solidFill>
+                  <a:schemeClr val="dk1"/>
+                </a:solidFill>
+                <a:latin typeface="Times New Roman"/>
+                <a:ea typeface="Times New Roman"/>
+                <a:cs typeface="Times New Roman"/>
+                <a:sym typeface="Times New Roman"/>
+              </a:rPr>
+              <a:t xml:space="preserve">Two stores:</a:t>
+            </a:r>
+            <a:r>
+              <a:rPr lang="en-US" sz="1150">
+                <a:solidFill>
+                  <a:schemeClr val="dk1"/>
+                </a:solidFill>
+                <a:latin typeface="Times New Roman"/>
+                <a:ea typeface="Times New Roman"/>
+                <a:cs typeface="Times New Roman"/>
+                <a:sym typeface="Times New Roman"/>
+              </a:rPr>
+              <a:t xml:space="preserve"> Supabase (PostgreSQL) holds complaints, cases, 6-hour windows, the vague pool and root causes; Pinecone holds up to 5 exemplar vectors per case.</a:t>
+            </a:r>
+          </a:p>
+          <a:p>
+            <a:pPr indent="-285750" lvl="0" marL="342900" rtl="0" algn="l">
+              <a:spcBef>
+                <a:spcPts val="0"/>
+              </a:spcBef>
+              <a:spcAft>
+                <a:spcPts val="300"/>
+              </a:spcAft>
+              <a:buClr>
+                <a:schemeClr val="dk1"/>
+              </a:buClr>
+              <a:buSzPts val="1150"/>
+              <a:buFont typeface="Times New Roman"/>
+              <a:buChar char="●"/>
+            </a:pPr>
+            <a:r>
+              <a:rPr b="1" lang="en-US" sz="1150">
+                <a:solidFill>
+                  <a:schemeClr val="dk1"/>
+                </a:solidFill>
+                <a:latin typeface="Times New Roman"/>
+                <a:ea typeface="Times New Roman"/>
+                <a:cs typeface="Times New Roman"/>
+                <a:sym typeface="Times New Roman"/>
+              </a:rPr>
+              <a:t xml:space="preserve">Phases 1–4, on arrival:</a:t>
+            </a:r>
+            <a:r>
+              <a:rPr lang="en-US" sz="1150">
+                <a:solidFill>
+                  <a:schemeClr val="dk1"/>
+                </a:solidFill>
+                <a:latin typeface="Times New Roman"/>
+                <a:ea typeface="Times New Roman"/>
+                <a:cs typeface="Times New Roman"/>
+                <a:sym typeface="Times New Roman"/>
+              </a:rPr>
+              <a:t xml:space="preserve"> cleaning, MiniLM retrieval of the top-5 cases, the calibrated band (t_high 0.8306; t_low 0.40 short / 0.26 long), and the LLM judge for uncertain matches.</a:t>
+            </a:r>
+          </a:p>
+          <a:p>
+            <a:pPr indent="-285750" lvl="0" marL="342900" rtl="0" algn="l">
+              <a:spcBef>
+                <a:spcPts val="0"/>
+              </a:spcBef>
+              <a:spcAft>
+                <a:spcPts val="300"/>
+              </a:spcAft>
+              <a:buClr>
+                <a:schemeClr val="dk1"/>
+              </a:buClr>
+              <a:buSzPts val="1150"/>
+              <a:buFont typeface="Times New Roman"/>
+              <a:buChar char="●"/>
+            </a:pPr>
+            <a:r>
+              <a:rPr b="1" lang="en-US" sz="1150">
+                <a:solidFill>
+                  <a:schemeClr val="dk1"/>
+                </a:solidFill>
+                <a:latin typeface="Times New Roman"/>
+                <a:ea typeface="Times New Roman"/>
+                <a:cs typeface="Times New Roman"/>
+                <a:sym typeface="Times New Roman"/>
+              </a:rPr>
+              <a:t xml:space="preserve">Phases 5–6, every 6 h:</a:t>
+            </a:r>
+            <a:r>
+              <a:rPr lang="en-US" sz="1150">
+                <a:solidFill>
+                  <a:schemeClr val="dk1"/>
+                </a:solidFill>
+                <a:latin typeface="Times New Roman"/>
+                <a:ea typeface="Times New Roman"/>
+                <a:cs typeface="Times New Roman"/>
+                <a:sym typeface="Times New Roman"/>
+              </a:rPr>
+              <a:t xml:space="preserve"> LLM re-joining merges split cases and moves their vectors; RoBERTa sentiment and BERTopic topics map each case to a department.</a:t>
+            </a:r>
+          </a:p>
+          <a:p>
+            <a:pPr indent="-285750" lvl="0" marL="342900" rtl="0" algn="l">
+              <a:spcBef>
+                <a:spcPts val="0"/>
+              </a:spcBef>
+              <a:spcAft>
+                <a:spcPts val="300"/>
+              </a:spcAft>
+              <a:buClr>
+                <a:schemeClr val="dk1"/>
+              </a:buClr>
+              <a:buSzPts val="1150"/>
+              <a:buFont typeface="Times New Roman"/>
+              <a:buChar char="●"/>
+            </a:pPr>
+            <a:r>
+              <a:rPr b="1" lang="en-US" sz="1150">
+                <a:solidFill>
+                  <a:schemeClr val="dk1"/>
+                </a:solidFill>
+                <a:latin typeface="Times New Roman"/>
+                <a:ea typeface="Times New Roman"/>
+                <a:cs typeface="Times New Roman"/>
+                <a:sym typeface="Times New Roman"/>
+              </a:rPr>
+              <a:t xml:space="preserve">Phases 7–8, signals:</a:t>
+            </a:r>
+            <a:r>
+              <a:rPr lang="en-US" sz="1150">
+                <a:solidFill>
+                  <a:schemeClr val="dk1"/>
+                </a:solidFill>
+                <a:latin typeface="Times New Roman"/>
+                <a:ea typeface="Times New Roman"/>
+                <a:cs typeface="Times New Roman"/>
+                <a:sym typeface="Times New Roman"/>
+              </a:rPr>
+              <a:t xml:space="preserve"> Poisson CUSUM per case and alert group; a separate alarm for vague complaints per product.</a:t>
+            </a:r>
+          </a:p>
+          <a:p>
+            <a:pPr indent="-285750" lvl="0" marL="342900" rtl="0" algn="l">
+              <a:spcBef>
+                <a:spcPts val="0"/>
+              </a:spcBef>
+              <a:spcAft>
+                <a:spcPts val="300"/>
+              </a:spcAft>
+              <a:buClr>
+                <a:schemeClr val="dk1"/>
+              </a:buClr>
+              <a:buSzPts val="1150"/>
+              <a:buFont typeface="Times New Roman"/>
+              <a:buChar char="●"/>
+            </a:pPr>
+            <a:r>
+              <a:rPr b="1" lang="en-US" sz="1150">
+                <a:solidFill>
+                  <a:schemeClr val="dk1"/>
+                </a:solidFill>
+                <a:latin typeface="Times New Roman"/>
+                <a:ea typeface="Times New Roman"/>
+                <a:cs typeface="Times New Roman"/>
+                <a:sym typeface="Times New Roman"/>
+              </a:rPr>
+              <a:t xml:space="preserve">Phase 9, action:</a:t>
+            </a:r>
+            <a:r>
+              <a:rPr lang="en-US" sz="1150">
+                <a:solidFill>
+                  <a:schemeClr val="dk1"/>
+                </a:solidFill>
+                <a:latin typeface="Times New Roman"/>
+                <a:ea typeface="Times New Roman"/>
+                <a:cs typeface="Times New Roman"/>
+                <a:sym typeface="Times New Roman"/>
+              </a:rPr>
+              <a:t xml:space="preserve"> an eligible case gets an LLM root cause (JSON); email goes out only after human approval.</a:t>
+            </a:r>
+          </a:p>
+          <a:p>
+            <a:pPr indent="-285750" lvl="0" marL="342900" rtl="0" algn="l">
+              <a:spcBef>
+                <a:spcPts val="0"/>
+              </a:spcBef>
+              <a:spcAft>
+                <a:spcPts val="300"/>
+              </a:spcAft>
+              <a:buClr>
+                <a:schemeClr val="dk1"/>
+              </a:buClr>
+              <a:buSzPts val="1150"/>
+              <a:buFont typeface="Times New Roman"/>
+              <a:buChar char="●"/>
+            </a:pPr>
+            <a:r>
+              <a:rPr b="1" lang="en-US" sz="1150">
+                <a:solidFill>
+                  <a:schemeClr val="dk1"/>
+                </a:solidFill>
+                <a:latin typeface="Times New Roman"/>
+                <a:ea typeface="Times New Roman"/>
+                <a:cs typeface="Times New Roman"/>
+                <a:sym typeface="Times New Roman"/>
+              </a:rPr>
+              <a:t xml:space="preserve">Feedback loop:</a:t>
+            </a:r>
+            <a:r>
+              <a:rPr lang="en-US" sz="1150">
+                <a:solidFill>
+                  <a:schemeClr val="dk1"/>
+                </a:solidFill>
+                <a:latin typeface="Times New Roman"/>
+                <a:ea typeface="Times New Roman"/>
+                <a:cs typeface="Times New Roman"/>
+                <a:sym typeface="Times New Roman"/>
+              </a:rPr>
+              <a:t xml:space="preserve"> re-joining updates the exemplars that retrieval reads for every new complaint.</a:t>
             </a:r>
           </a:p>
         </p:txBody>

</xml_diff>

<commit_message>
Paper: published-style title, 12 pt, short tables with parameters, 2020-2026 references, coloured flowchart; deck: landscape architecture slide
Co-Authored-By: Claude Opus 5.5 <noreply@anthropic.com>
</commit_message>
<xml_diff>
--- a/reports/ppt/InsightDesk_final.pptx
+++ b/reports/ppt/InsightDesk_final.pptx
@@ -29734,7 +29734,7 @@
           <a:blip r:embed="rId3">
             <a:alphaModFix/>
           </a:blip>
-          <a:srcRect b="0" l="0" r="0" t="0"/>
+          <a:srcRect/>
           <a:stretch/>
         </p:blipFill>
         <p:spPr>
@@ -29945,13 +29945,13 @@
           <a:blip r:embed="rId4">
             <a:alphaModFix/>
           </a:blip>
-          <a:srcRect b="9198" l="0" r="0" t="0"/>
+          <a:srcRect/>
           <a:stretch/>
         </p:blipFill>
         <p:spPr>
           <a:xfrm>
-            <a:off x="420000" y="1520000"/>
-            <a:ext cx="2950000" cy="3083891"/>
+            <a:off x="870000" y="1450000"/>
+            <a:ext cx="7400000" cy="3259523"/>
           </a:xfrm>
           <a:prstGeom prst="rect">
             <a:avLst/>
@@ -29962,272 +29962,6 @@
           </a:ln>
         </p:spPr>
       </p:pic>
-      <p:sp>
-        <p:nvSpPr>
-          <p:cNvPr id="990" name="Results text 990"/>
-          <p:cNvSpPr txBox="1"/>
-          <p:nvPr/>
-        </p:nvSpPr>
-        <p:spPr>
-          <a:xfrm>
-            <a:off x="3800000" y="1450000"/>
-            <a:ext cx="4950000" cy="3300000"/>
-          </a:xfrm>
-          <a:prstGeom prst="rect">
-            <a:avLst/>
-          </a:prstGeom>
-          <a:noFill/>
-          <a:ln>
-            <a:noFill/>
-          </a:ln>
-        </p:spPr>
-        <p:txBody>
-          <a:bodyPr anchorCtr="0" anchor="t" bIns="45720" lIns="45720" spcFirstLastPara="1" rIns="45720" wrap="square" tIns="45720">
-            <a:noAutofit/>
-          </a:bodyPr>
-          <a:lstStyle/>
-          <a:p>
-            <a:pPr indent="-285750" lvl="0" marL="342900" rtl="0" algn="l">
-              <a:spcBef>
-                <a:spcPts val="0"/>
-              </a:spcBef>
-              <a:spcAft>
-                <a:spcPts val="300"/>
-              </a:spcAft>
-              <a:buClr>
-                <a:schemeClr val="dk1"/>
-              </a:buClr>
-              <a:buSzPts val="1150"/>
-              <a:buFont typeface="Times New Roman"/>
-              <a:buChar char="●"/>
-            </a:pPr>
-            <a:r>
-              <a:rPr b="1" lang="en-US" sz="1150">
-                <a:solidFill>
-                  <a:schemeClr val="dk1"/>
-                </a:solidFill>
-                <a:latin typeface="Times New Roman"/>
-                <a:ea typeface="Times New Roman"/>
-                <a:cs typeface="Times New Roman"/>
-                <a:sym typeface="Times New Roman"/>
-              </a:rPr>
-              <a:t xml:space="preserve">Two stores:</a:t>
-            </a:r>
-            <a:r>
-              <a:rPr lang="en-US" sz="1150">
-                <a:solidFill>
-                  <a:schemeClr val="dk1"/>
-                </a:solidFill>
-                <a:latin typeface="Times New Roman"/>
-                <a:ea typeface="Times New Roman"/>
-                <a:cs typeface="Times New Roman"/>
-                <a:sym typeface="Times New Roman"/>
-              </a:rPr>
-              <a:t xml:space="preserve"> Supabase (PostgreSQL) holds complaints, cases, 6-hour windows, the vague pool and root causes; Pinecone holds up to 5 exemplar vectors per case.</a:t>
-            </a:r>
-          </a:p>
-          <a:p>
-            <a:pPr indent="-285750" lvl="0" marL="342900" rtl="0" algn="l">
-              <a:spcBef>
-                <a:spcPts val="0"/>
-              </a:spcBef>
-              <a:spcAft>
-                <a:spcPts val="300"/>
-              </a:spcAft>
-              <a:buClr>
-                <a:schemeClr val="dk1"/>
-              </a:buClr>
-              <a:buSzPts val="1150"/>
-              <a:buFont typeface="Times New Roman"/>
-              <a:buChar char="●"/>
-            </a:pPr>
-            <a:r>
-              <a:rPr b="1" lang="en-US" sz="1150">
-                <a:solidFill>
-                  <a:schemeClr val="dk1"/>
-                </a:solidFill>
-                <a:latin typeface="Times New Roman"/>
-                <a:ea typeface="Times New Roman"/>
-                <a:cs typeface="Times New Roman"/>
-                <a:sym typeface="Times New Roman"/>
-              </a:rPr>
-              <a:t xml:space="preserve">Phases 1–4, on arrival:</a:t>
-            </a:r>
-            <a:r>
-              <a:rPr lang="en-US" sz="1150">
-                <a:solidFill>
-                  <a:schemeClr val="dk1"/>
-                </a:solidFill>
-                <a:latin typeface="Times New Roman"/>
-                <a:ea typeface="Times New Roman"/>
-                <a:cs typeface="Times New Roman"/>
-                <a:sym typeface="Times New Roman"/>
-              </a:rPr>
-              <a:t xml:space="preserve"> cleaning, MiniLM retrieval of the top-5 cases, the calibrated band (t_high 0.8306; t_low 0.40 short / 0.26 long), and the LLM judge for uncertain matches.</a:t>
-            </a:r>
-          </a:p>
-          <a:p>
-            <a:pPr indent="-285750" lvl="0" marL="342900" rtl="0" algn="l">
-              <a:spcBef>
-                <a:spcPts val="0"/>
-              </a:spcBef>
-              <a:spcAft>
-                <a:spcPts val="300"/>
-              </a:spcAft>
-              <a:buClr>
-                <a:schemeClr val="dk1"/>
-              </a:buClr>
-              <a:buSzPts val="1150"/>
-              <a:buFont typeface="Times New Roman"/>
-              <a:buChar char="●"/>
-            </a:pPr>
-            <a:r>
-              <a:rPr b="1" lang="en-US" sz="1150">
-                <a:solidFill>
-                  <a:schemeClr val="dk1"/>
-                </a:solidFill>
-                <a:latin typeface="Times New Roman"/>
-                <a:ea typeface="Times New Roman"/>
-                <a:cs typeface="Times New Roman"/>
-                <a:sym typeface="Times New Roman"/>
-              </a:rPr>
-              <a:t xml:space="preserve">Phases 5–6, every 6 h:</a:t>
-            </a:r>
-            <a:r>
-              <a:rPr lang="en-US" sz="1150">
-                <a:solidFill>
-                  <a:schemeClr val="dk1"/>
-                </a:solidFill>
-                <a:latin typeface="Times New Roman"/>
-                <a:ea typeface="Times New Roman"/>
-                <a:cs typeface="Times New Roman"/>
-                <a:sym typeface="Times New Roman"/>
-              </a:rPr>
-              <a:t xml:space="preserve"> LLM re-joining merges split cases and moves their vectors; RoBERTa sentiment and BERTopic topics map each case to a department.</a:t>
-            </a:r>
-          </a:p>
-          <a:p>
-            <a:pPr indent="-285750" lvl="0" marL="342900" rtl="0" algn="l">
-              <a:spcBef>
-                <a:spcPts val="0"/>
-              </a:spcBef>
-              <a:spcAft>
-                <a:spcPts val="300"/>
-              </a:spcAft>
-              <a:buClr>
-                <a:schemeClr val="dk1"/>
-              </a:buClr>
-              <a:buSzPts val="1150"/>
-              <a:buFont typeface="Times New Roman"/>
-              <a:buChar char="●"/>
-            </a:pPr>
-            <a:r>
-              <a:rPr b="1" lang="en-US" sz="1150">
-                <a:solidFill>
-                  <a:schemeClr val="dk1"/>
-                </a:solidFill>
-                <a:latin typeface="Times New Roman"/>
-                <a:ea typeface="Times New Roman"/>
-                <a:cs typeface="Times New Roman"/>
-                <a:sym typeface="Times New Roman"/>
-              </a:rPr>
-              <a:t xml:space="preserve">Phases 7–8, signals:</a:t>
-            </a:r>
-            <a:r>
-              <a:rPr lang="en-US" sz="1150">
-                <a:solidFill>
-                  <a:schemeClr val="dk1"/>
-                </a:solidFill>
-                <a:latin typeface="Times New Roman"/>
-                <a:ea typeface="Times New Roman"/>
-                <a:cs typeface="Times New Roman"/>
-                <a:sym typeface="Times New Roman"/>
-              </a:rPr>
-              <a:t xml:space="preserve"> Poisson CUSUM per case and alert group; a separate alarm for vague complaints per product.</a:t>
-            </a:r>
-          </a:p>
-          <a:p>
-            <a:pPr indent="-285750" lvl="0" marL="342900" rtl="0" algn="l">
-              <a:spcBef>
-                <a:spcPts val="0"/>
-              </a:spcBef>
-              <a:spcAft>
-                <a:spcPts val="300"/>
-              </a:spcAft>
-              <a:buClr>
-                <a:schemeClr val="dk1"/>
-              </a:buClr>
-              <a:buSzPts val="1150"/>
-              <a:buFont typeface="Times New Roman"/>
-              <a:buChar char="●"/>
-            </a:pPr>
-            <a:r>
-              <a:rPr b="1" lang="en-US" sz="1150">
-                <a:solidFill>
-                  <a:schemeClr val="dk1"/>
-                </a:solidFill>
-                <a:latin typeface="Times New Roman"/>
-                <a:ea typeface="Times New Roman"/>
-                <a:cs typeface="Times New Roman"/>
-                <a:sym typeface="Times New Roman"/>
-              </a:rPr>
-              <a:t xml:space="preserve">Phase 9, action:</a:t>
-            </a:r>
-            <a:r>
-              <a:rPr lang="en-US" sz="1150">
-                <a:solidFill>
-                  <a:schemeClr val="dk1"/>
-                </a:solidFill>
-                <a:latin typeface="Times New Roman"/>
-                <a:ea typeface="Times New Roman"/>
-                <a:cs typeface="Times New Roman"/>
-                <a:sym typeface="Times New Roman"/>
-              </a:rPr>
-              <a:t xml:space="preserve"> an eligible case gets an LLM root cause (JSON); email goes out only after human approval.</a:t>
-            </a:r>
-          </a:p>
-          <a:p>
-            <a:pPr indent="-285750" lvl="0" marL="342900" rtl="0" algn="l">
-              <a:spcBef>
-                <a:spcPts val="0"/>
-              </a:spcBef>
-              <a:spcAft>
-                <a:spcPts val="300"/>
-              </a:spcAft>
-              <a:buClr>
-                <a:schemeClr val="dk1"/>
-              </a:buClr>
-              <a:buSzPts val="1150"/>
-              <a:buFont typeface="Times New Roman"/>
-              <a:buChar char="●"/>
-            </a:pPr>
-            <a:r>
-              <a:rPr b="1" lang="en-US" sz="1150">
-                <a:solidFill>
-                  <a:schemeClr val="dk1"/>
-                </a:solidFill>
-                <a:latin typeface="Times New Roman"/>
-                <a:ea typeface="Times New Roman"/>
-                <a:cs typeface="Times New Roman"/>
-                <a:sym typeface="Times New Roman"/>
-              </a:rPr>
-              <a:t xml:space="preserve">Feedback loop:</a:t>
-            </a:r>
-            <a:r>
-              <a:rPr lang="en-US" sz="1150">
-                <a:solidFill>
-                  <a:schemeClr val="dk1"/>
-                </a:solidFill>
-                <a:latin typeface="Times New Roman"/>
-                <a:ea typeface="Times New Roman"/>
-                <a:cs typeface="Times New Roman"/>
-                <a:sym typeface="Times New Roman"/>
-              </a:rPr>
-              <a:t xml:space="preserve"> re-joining updates the exemplars that retrieval reads for every new complaint.</a:t>
-            </a:r>
-          </a:p>
-        </p:txBody>
-      </p:sp>
     </p:spTree>
   </p:cSld>
   <p:clrMapOvr>

</xml_diff>

<commit_message>
Paper: captions below figures (Fig. N:), full-width readable diagrams and charts; deck: detailed landscape architecture
Co-Authored-By: Claude Opus 5.5 <noreply@anthropic.com>
</commit_message>
<xml_diff>
--- a/reports/ppt/InsightDesk_final.pptx
+++ b/reports/ppt/InsightDesk_final.pptx
@@ -29950,8 +29950,8 @@
         </p:blipFill>
         <p:spPr>
           <a:xfrm>
-            <a:off x="870000" y="1450000"/>
-            <a:ext cx="7400000" cy="3259523"/>
+            <a:off x="720000" y="1520000"/>
+            <a:ext cx="7700000" cy="3128125"/>
           </a:xfrm>
           <a:prstGeom prst="rect">
             <a:avLst/>

</xml_diff>

<commit_message>
Deck: slide 9 as a methodology diagram (rules, typed data flows, state updates)
</commit_message>
<xml_diff>
--- a/reports/ppt/InsightDesk_final.pptx
+++ b/reports/ppt/InsightDesk_final.pptx
@@ -29921,7 +29921,7 @@
                 <a:cs typeface="Times New Roman"/>
                 <a:sym typeface="Times New Roman"/>
               </a:rPr>
-              <a:t>SYSTEM ARCHITECTURE</a:t>
+              <a:t>SYSTEM ARCHITECTURE &amp; METHODOLOGY</a:t>
             </a:r>
             <a:endParaRPr b="1" i="0" sz="1600" u="none" cap="none" strike="noStrike">
               <a:solidFill>
@@ -29950,8 +29950,8 @@
         </p:blipFill>
         <p:spPr>
           <a:xfrm>
-            <a:off x="720000" y="1520000"/>
-            <a:ext cx="7700000" cy="3128125"/>
+            <a:off x="1620000" y="1600000"/>
+            <a:ext cx="5900000" cy="3187053"/>
           </a:xfrm>
           <a:prstGeom prst="rect">
             <a:avLst/>

</xml_diff>

<commit_message>
Deck: colour-coded methodology diagram (stages, outcomes, legend)
</commit_message>
<xml_diff>
--- a/reports/ppt/InsightDesk_final.pptx
+++ b/reports/ppt/InsightDesk_final.pptx
@@ -29950,8 +29950,8 @@
         </p:blipFill>
         <p:spPr>
           <a:xfrm>
-            <a:off x="1620000" y="1600000"/>
-            <a:ext cx="5900000" cy="3187053"/>
+            <a:off x="1800000" y="1580000"/>
+            <a:ext cx="5550000" cy="3245758"/>
           </a:xfrm>
           <a:prstGeom prst="rect">
             <a:avLst/>

</xml_diff>